<commit_message>
Add ChatGPT browser handoff and visible bilingual conversion choices
</commit_message>
<xml_diff>
--- a/app/assets/templates/practice-classroom.pptx
+++ b/app/assets/templates/practice-classroom.pptx
@@ -2,26 +2,26 @@
 <file path=ppt/presentation.xml><?xml version="1.0" encoding="utf-8"?>
 <p:presentation xmlns:p="http://schemas.openxmlformats.org/presentationml/2006/main">
   <p:sldMasterIdLst>
-    <p:sldMasterId xmlns:r="http://schemas.openxmlformats.org/officeDocument/2006/relationships" id="2147483648" r:id="R448d19e1f4bd4103"/>
+    <p:sldMasterId xmlns:r="http://schemas.openxmlformats.org/officeDocument/2006/relationships" id="2147483648" r:id="Re20d4314dae44572"/>
   </p:sldMasterIdLst>
   <p:notesMasterIdLst>
-    <p:notesMasterId xmlns:r="http://schemas.openxmlformats.org/officeDocument/2006/relationships" r:id="Rd0508be3f3c44cd2"/>
+    <p:notesMasterId xmlns:r="http://schemas.openxmlformats.org/officeDocument/2006/relationships" r:id="R876eea16834443fd"/>
   </p:notesMasterIdLst>
   <p:sldIdLst>
-    <p:sldId xmlns:r="http://schemas.openxmlformats.org/officeDocument/2006/relationships" id="256" r:id="R7233843bd2324c52"/>
-    <p:sldId xmlns:r="http://schemas.openxmlformats.org/officeDocument/2006/relationships" id="257" r:id="R32e1a2a1a24446d8"/>
-    <p:sldId xmlns:r="http://schemas.openxmlformats.org/officeDocument/2006/relationships" id="258" r:id="Rb367bc54ab974ad6"/>
-    <p:sldId xmlns:r="http://schemas.openxmlformats.org/officeDocument/2006/relationships" id="259" r:id="Rd2fffb1c3d494a45"/>
-    <p:sldId xmlns:r="http://schemas.openxmlformats.org/officeDocument/2006/relationships" id="260" r:id="R63904bd48fd64efc"/>
-    <p:sldId xmlns:r="http://schemas.openxmlformats.org/officeDocument/2006/relationships" id="261" r:id="R5fee9eacb55247ca"/>
-    <p:sldId xmlns:r="http://schemas.openxmlformats.org/officeDocument/2006/relationships" id="262" r:id="Rc5df6db486244728"/>
-    <p:sldId xmlns:r="http://schemas.openxmlformats.org/officeDocument/2006/relationships" id="263" r:id="R0c08e7b38b4642e6"/>
-    <p:sldId xmlns:r="http://schemas.openxmlformats.org/officeDocument/2006/relationships" id="264" r:id="Rb8e86d28b1644607"/>
-    <p:sldId xmlns:r="http://schemas.openxmlformats.org/officeDocument/2006/relationships" id="265" r:id="R8683bcf5b8df4188"/>
-    <p:sldId xmlns:r="http://schemas.openxmlformats.org/officeDocument/2006/relationships" id="266" r:id="R972e447fa8eb48e9"/>
-    <p:sldId xmlns:r="http://schemas.openxmlformats.org/officeDocument/2006/relationships" id="267" r:id="R8400fef1c607496d"/>
-    <p:sldId xmlns:r="http://schemas.openxmlformats.org/officeDocument/2006/relationships" id="268" r:id="Rafc8979d7ce44792"/>
-    <p:sldId xmlns:r="http://schemas.openxmlformats.org/officeDocument/2006/relationships" id="269" r:id="R33bf70bd6d1b479e"/>
+    <p:sldId xmlns:r="http://schemas.openxmlformats.org/officeDocument/2006/relationships" id="256" r:id="R1ee69256707a4f8c"/>
+    <p:sldId xmlns:r="http://schemas.openxmlformats.org/officeDocument/2006/relationships" id="257" r:id="Ref25cf6476e34a25"/>
+    <p:sldId xmlns:r="http://schemas.openxmlformats.org/officeDocument/2006/relationships" id="258" r:id="Ra0b326fb02854c64"/>
+    <p:sldId xmlns:r="http://schemas.openxmlformats.org/officeDocument/2006/relationships" id="259" r:id="Rd58b110a84984e6b"/>
+    <p:sldId xmlns:r="http://schemas.openxmlformats.org/officeDocument/2006/relationships" id="260" r:id="R914a5e5efd764e3c"/>
+    <p:sldId xmlns:r="http://schemas.openxmlformats.org/officeDocument/2006/relationships" id="261" r:id="R5d8ea0f886f14372"/>
+    <p:sldId xmlns:r="http://schemas.openxmlformats.org/officeDocument/2006/relationships" id="262" r:id="R8cefb68527734282"/>
+    <p:sldId xmlns:r="http://schemas.openxmlformats.org/officeDocument/2006/relationships" id="263" r:id="Reb14df39e266436d"/>
+    <p:sldId xmlns:r="http://schemas.openxmlformats.org/officeDocument/2006/relationships" id="264" r:id="R6beae975c46e4aae"/>
+    <p:sldId xmlns:r="http://schemas.openxmlformats.org/officeDocument/2006/relationships" id="265" r:id="R3a274413bf3a4e24"/>
+    <p:sldId xmlns:r="http://schemas.openxmlformats.org/officeDocument/2006/relationships" id="266" r:id="Rb56f05a3f3b84b65"/>
+    <p:sldId xmlns:r="http://schemas.openxmlformats.org/officeDocument/2006/relationships" id="267" r:id="R2a7187db93c24921"/>
+    <p:sldId xmlns:r="http://schemas.openxmlformats.org/officeDocument/2006/relationships" id="268" r:id="R113de74eef5b4a36"/>
+    <p:sldId xmlns:r="http://schemas.openxmlformats.org/officeDocument/2006/relationships" id="269" r:id="R8d91e14483ac4e87"/>
   </p:sldIdLst>
   <p:sldSz cx="12192000" cy="6858000"/>
   <p:notesSz cx="6858000" cy="9144000"/>
@@ -455,7 +455,7 @@
           <a:lstStyle xmlns:a="http://schemas.openxmlformats.org/drawingml/2006/main"/>
           <a:p xmlns:a="http://schemas.openxmlformats.org/drawingml/2006/main">
             <a:r>
-              <a:t>Mẫu practice: title. Thay các phần trong ngoặc bằng nội dung đã kiểm tra. Đây là mẫu cấu trúc, không phải bài học đã duyệt.</a:t>
+              <a:t>Mẫu practice: title. Ví dụ minh họa thiết kế từ app/assets/templates/demo_lessons.json. Khi tạo bài, thay bằng nội dung và hình của tài liệu giáo viên; không sao chép kiến thức của bài minh họa sang môn khác.</a:t>
             </a:r>
           </a:p>
         </p:txBody>
@@ -525,7 +525,7 @@
           <a:lstStyle xmlns:a="http://schemas.openxmlformats.org/drawingml/2006/main"/>
           <a:p xmlns:a="http://schemas.openxmlformats.org/drawingml/2006/main">
             <a:r>
-              <a:t>Mẫu practice: example. Thay các phần trong ngoặc bằng nội dung đã kiểm tra. Đây là mẫu cấu trúc, không phải bài học đã duyệt.</a:t>
+              <a:t>Mẫu practice: example. Ví dụ minh họa thiết kế từ app/assets/templates/demo_lessons.json. Khi tạo bài, thay bằng nội dung và hình của tài liệu giáo viên; không sao chép kiến thức của bài minh họa sang môn khác.</a:t>
             </a:r>
           </a:p>
         </p:txBody>
@@ -595,7 +595,7 @@
           <a:lstStyle xmlns:a="http://schemas.openxmlformats.org/drawingml/2006/main"/>
           <a:p xmlns:a="http://schemas.openxmlformats.org/drawingml/2006/main">
             <a:r>
-              <a:t>Mẫu practice: practice. Thay các phần trong ngoặc bằng nội dung đã kiểm tra. Đây là mẫu cấu trúc, không phải bài học đã duyệt.</a:t>
+              <a:t>Mẫu practice: practice. Ví dụ minh họa thiết kế từ app/assets/templates/demo_lessons.json. Khi tạo bài, thay bằng nội dung và hình của tài liệu giáo viên; không sao chép kiến thức của bài minh họa sang môn khác.</a:t>
             </a:r>
           </a:p>
         </p:txBody>
@@ -665,7 +665,7 @@
           <a:lstStyle xmlns:a="http://schemas.openxmlformats.org/drawingml/2006/main"/>
           <a:p xmlns:a="http://schemas.openxmlformats.org/drawingml/2006/main">
             <a:r>
-              <a:t>Mẫu practice: question. Thay các phần trong ngoặc bằng nội dung đã kiểm tra. Đây là mẫu cấu trúc, không phải bài học đã duyệt.</a:t>
+              <a:t>Mẫu practice: question. Ví dụ minh họa thiết kế từ app/assets/templates/demo_lessons.json. Khi tạo bài, thay bằng nội dung và hình của tài liệu giáo viên; không sao chép kiến thức của bài minh họa sang môn khác.</a:t>
             </a:r>
           </a:p>
         </p:txBody>
@@ -735,7 +735,7 @@
           <a:lstStyle xmlns:a="http://schemas.openxmlformats.org/drawingml/2006/main"/>
           <a:p xmlns:a="http://schemas.openxmlformats.org/drawingml/2006/main">
             <a:r>
-              <a:t>Mẫu practice: check. Thay các phần trong ngoặc bằng nội dung đã kiểm tra. Đây là mẫu cấu trúc, không phải bài học đã duyệt.</a:t>
+              <a:t>Mẫu practice: check. Ví dụ minh họa thiết kế từ app/assets/templates/demo_lessons.json. Khi tạo bài, thay bằng nội dung và hình của tài liệu giáo viên; không sao chép kiến thức của bài minh họa sang môn khác.</a:t>
             </a:r>
           </a:p>
         </p:txBody>
@@ -805,7 +805,7 @@
           <a:lstStyle xmlns:a="http://schemas.openxmlformats.org/drawingml/2006/main"/>
           <a:p xmlns:a="http://schemas.openxmlformats.org/drawingml/2006/main">
             <a:r>
-              <a:t>Mẫu practice: summary. Thay các phần trong ngoặc bằng nội dung đã kiểm tra. Đây là mẫu cấu trúc, không phải bài học đã duyệt.</a:t>
+              <a:t>Mẫu practice: summary. Ví dụ minh họa thiết kế từ app/assets/templates/demo_lessons.json. Khi tạo bài, thay bằng nội dung và hình của tài liệu giáo viên; không sao chép kiến thức của bài minh họa sang môn khác.</a:t>
             </a:r>
           </a:p>
         </p:txBody>
@@ -875,7 +875,7 @@
           <a:lstStyle xmlns:a="http://schemas.openxmlformats.org/drawingml/2006/main"/>
           <a:p xmlns:a="http://schemas.openxmlformats.org/drawingml/2006/main">
             <a:r>
-              <a:t>Mẫu practice: goal. Thay các phần trong ngoặc bằng nội dung đã kiểm tra. Đây là mẫu cấu trúc, không phải bài học đã duyệt.</a:t>
+              <a:t>Mẫu practice: goal. Ví dụ minh họa thiết kế từ app/assets/templates/demo_lessons.json. Khi tạo bài, thay bằng nội dung và hình của tài liệu giáo viên; không sao chép kiến thức của bài minh họa sang môn khác.</a:t>
             </a:r>
           </a:p>
         </p:txBody>
@@ -945,7 +945,7 @@
           <a:lstStyle xmlns:a="http://schemas.openxmlformats.org/drawingml/2006/main"/>
           <a:p xmlns:a="http://schemas.openxmlformats.org/drawingml/2006/main">
             <a:r>
-              <a:t>Mẫu practice: warmup. Thay các phần trong ngoặc bằng nội dung đã kiểm tra. Đây là mẫu cấu trúc, không phải bài học đã duyệt.</a:t>
+              <a:t>Mẫu practice: warmup. Ví dụ minh họa thiết kế từ app/assets/templates/demo_lessons.json. Khi tạo bài, thay bằng nội dung và hình của tài liệu giáo viên; không sao chép kiến thức của bài minh họa sang môn khác.</a:t>
             </a:r>
           </a:p>
         </p:txBody>
@@ -1015,7 +1015,7 @@
           <a:lstStyle xmlns:a="http://schemas.openxmlformats.org/drawingml/2006/main"/>
           <a:p xmlns:a="http://schemas.openxmlformats.org/drawingml/2006/main">
             <a:r>
-              <a:t>Mẫu practice: vocabulary. Thay các phần trong ngoặc bằng nội dung đã kiểm tra. Đây là mẫu cấu trúc, không phải bài học đã duyệt.</a:t>
+              <a:t>Mẫu practice: vocabulary. Ví dụ minh họa thiết kế từ app/assets/templates/demo_lessons.json. Khi tạo bài, thay bằng nội dung và hình của tài liệu giáo viên; không sao chép kiến thức của bài minh họa sang môn khác.</a:t>
             </a:r>
           </a:p>
         </p:txBody>
@@ -1085,7 +1085,7 @@
           <a:lstStyle xmlns:a="http://schemas.openxmlformats.org/drawingml/2006/main"/>
           <a:p xmlns:a="http://schemas.openxmlformats.org/drawingml/2006/main">
             <a:r>
-              <a:t>Mẫu practice: concept. Thay các phần trong ngoặc bằng nội dung đã kiểm tra. Đây là mẫu cấu trúc, không phải bài học đã duyệt.</a:t>
+              <a:t>Mẫu practice: concept. Ví dụ minh họa thiết kế từ app/assets/templates/demo_lessons.json. Khi tạo bài, thay bằng nội dung và hình của tài liệu giáo viên; không sao chép kiến thức của bài minh họa sang môn khác.</a:t>
             </a:r>
           </a:p>
         </p:txBody>
@@ -1155,7 +1155,7 @@
           <a:lstStyle xmlns:a="http://schemas.openxmlformats.org/drawingml/2006/main"/>
           <a:p xmlns:a="http://schemas.openxmlformats.org/drawingml/2006/main">
             <a:r>
-              <a:t>Mẫu practice: explanation. Thay các phần trong ngoặc bằng nội dung đã kiểm tra. Đây là mẫu cấu trúc, không phải bài học đã duyệt.</a:t>
+              <a:t>Mẫu practice: explanation. Ví dụ minh họa thiết kế từ app/assets/templates/demo_lessons.json. Khi tạo bài, thay bằng nội dung và hình của tài liệu giáo viên; không sao chép kiến thức của bài minh họa sang môn khác.</a:t>
             </a:r>
           </a:p>
         </p:txBody>
@@ -1225,7 +1225,7 @@
           <a:lstStyle xmlns:a="http://schemas.openxmlformats.org/drawingml/2006/main"/>
           <a:p xmlns:a="http://schemas.openxmlformats.org/drawingml/2006/main">
             <a:r>
-              <a:t>Mẫu practice: visual. Thay các phần trong ngoặc bằng nội dung đã kiểm tra. Đây là mẫu cấu trúc, không phải bài học đã duyệt.</a:t>
+              <a:t>Mẫu practice: visual. Ví dụ minh họa thiết kế từ app/assets/templates/demo_lessons.json. Khi tạo bài, thay bằng nội dung và hình của tài liệu giáo viên; không sao chép kiến thức của bài minh họa sang môn khác.</a:t>
             </a:r>
           </a:p>
         </p:txBody>
@@ -1295,7 +1295,7 @@
           <a:lstStyle xmlns:a="http://schemas.openxmlformats.org/drawingml/2006/main"/>
           <a:p xmlns:a="http://schemas.openxmlformats.org/drawingml/2006/main">
             <a:r>
-              <a:t>Mẫu practice: compare. Thay các phần trong ngoặc bằng nội dung đã kiểm tra. Đây là mẫu cấu trúc, không phải bài học đã duyệt.</a:t>
+              <a:t>Mẫu practice: compare. Ví dụ minh họa thiết kế từ app/assets/templates/demo_lessons.json. Khi tạo bài, thay bằng nội dung và hình của tài liệu giáo viên; không sao chép kiến thức của bài minh họa sang môn khác.</a:t>
             </a:r>
           </a:p>
         </p:txBody>
@@ -1365,7 +1365,7 @@
           <a:lstStyle xmlns:a="http://schemas.openxmlformats.org/drawingml/2006/main"/>
           <a:p xmlns:a="http://schemas.openxmlformats.org/drawingml/2006/main">
             <a:r>
-              <a:t>Mẫu practice: formula. Thay các phần trong ngoặc bằng nội dung đã kiểm tra. Đây là mẫu cấu trúc, không phải bài học đã duyệt.</a:t>
+              <a:t>Mẫu practice: formula. Ví dụ minh họa thiết kế từ app/assets/templates/demo_lessons.json. Khi tạo bài, thay bằng nội dung và hình của tài liệu giáo viên; không sao chép kiến thức của bài minh họa sang môn khác.</a:t>
             </a:r>
           </a:p>
         </p:txBody>
@@ -1433,7 +1433,7 @@
   </p:cSld>
   <p:clrMap bg1="lt1" tx1="dk1" bg2="lt2" tx2="dk2" accent1="accent1" accent2="accent2" accent3="accent3" accent4="accent4" accent5="accent5" accent6="accent6" hlink="hlink" folHlink="folHlink"/>
   <p:sldLayoutIdLst>
-    <p:sldLayoutId xmlns:r="http://schemas.openxmlformats.org/officeDocument/2006/relationships" id="2147483649" r:id="Rb6c91b0cb79d4f86"/>
+    <p:sldLayoutId xmlns:r="http://schemas.openxmlformats.org/officeDocument/2006/relationships" id="2147483649" r:id="R82a01d56e6ad4c25"/>
   </p:sldLayoutIdLst>
   <p:txStyles>
     <p:titleStyle>
@@ -1981,10 +1981,10 @@
       </p:grpSpPr>
       <p:sp>
         <p:nvSpPr>
-          <p:cNvPr id="7" name="title-0">
-            <a:extLst xmlns:a="http://schemas.openxmlformats.org/drawingml/2006/main">
-              <a:ext uri="{FF2B5EF4-FFF2-40B4-BE49-F238E27FC236}">
-                <a16:creationId xmlns:a16="http://schemas.microsoft.com/office/drawing/2014/main" id="{D8B9A107-13D7-4A04-B575-91A1B1D501CE}"/>
+          <p:cNvPr id="8" name="title-0">
+            <a:extLst xmlns:a="http://schemas.openxmlformats.org/drawingml/2006/main">
+              <a:ext uri="{FF2B5EF4-FFF2-40B4-BE49-F238E27FC236}">
+                <a16:creationId xmlns:a16="http://schemas.microsoft.com/office/drawing/2014/main" id="{C7047810-CC56-44E4-A1CD-0704BD35996D}"/>
               </a:ext>
             </a:extLst>
           </p:cNvPr>
@@ -2031,7 +2031,7 @@
                 <a:ea typeface="Arial"/>
                 <a:cs typeface="Arial"/>
               </a:rPr>
-              <a:t>BiliClass   /   Môn học của thầy cô   /   10–12</a:t>
+              <a:t>BiliClass   /   Toán · ví dụ minh họa   /   11</a:t>
             </a:r>
           </a:p>
         </p:txBody>
@@ -2041,7 +2041,7 @@
           <p:cNvPr id="2" name="title-1">
             <a:extLst xmlns:a="http://schemas.openxmlformats.org/drawingml/2006/main">
               <a:ext uri="{FF2B5EF4-FFF2-40B4-BE49-F238E27FC236}">
-                <a16:creationId xmlns:a16="http://schemas.microsoft.com/office/drawing/2014/main" id="{AB919BE2-5D5C-4ADF-8221-EF946E24BF7F}"/>
+                <a16:creationId xmlns:a16="http://schemas.microsoft.com/office/drawing/2014/main" id="{E3462FF7-D186-40B1-B6C5-1AA77DB9F055}"/>
               </a:ext>
             </a:extLst>
           </p:cNvPr>
@@ -2088,7 +2088,7 @@
                 <a:ea typeface="Arial"/>
                 <a:cs typeface="Arial"/>
               </a:rPr>
-              <a:t>Mẫu bài giảng song ngữ</a:t>
+              <a:t>Cấp số cộng</a:t>
             </a:r>
           </a:p>
         </p:txBody>
@@ -2098,7 +2098,7 @@
           <p:cNvPr id="3" name="title-2">
             <a:extLst xmlns:a="http://schemas.openxmlformats.org/drawingml/2006/main">
               <a:ext uri="{FF2B5EF4-FFF2-40B4-BE49-F238E27FC236}">
-                <a16:creationId xmlns:a16="http://schemas.microsoft.com/office/drawing/2014/main" id="{E8FB1CF8-886B-4F0A-98B5-A9B383D114D3}"/>
+                <a16:creationId xmlns:a16="http://schemas.microsoft.com/office/drawing/2014/main" id="{B1C748EF-A631-421A-B1F6-4A1CA9D98CA1}"/>
               </a:ext>
             </a:extLst>
           </p:cNvPr>
@@ -2155,7 +2155,7 @@
           <p:cNvPr id="4" name="title-3">
             <a:extLst xmlns:a="http://schemas.openxmlformats.org/drawingml/2006/main">
               <a:ext uri="{FF2B5EF4-FFF2-40B4-BE49-F238E27FC236}">
-                <a16:creationId xmlns:a16="http://schemas.microsoft.com/office/drawing/2014/main" id="{5321B3BF-AFC7-46C3-AD33-8A03CA890C2B}"/>
+                <a16:creationId xmlns:a16="http://schemas.microsoft.com/office/drawing/2014/main" id="{65B4FA2B-51A4-4654-A248-5765EC8DC689}"/>
               </a:ext>
             </a:extLst>
           </p:cNvPr>
@@ -2202,7 +2202,7 @@
                 <a:ea typeface="Arial"/>
                 <a:cs typeface="Arial"/>
               </a:rPr>
-              <a:t>Mẫu cấu trúc · Thay bằng nội dung bài học</a:t>
+              <a:t>Ví dụ để xem thiết kế · Bài của thầy cô dùng nội dung và hình từ nguồn</a:t>
             </a:r>
           </a:p>
         </p:txBody>
@@ -2212,7 +2212,7 @@
           <p:cNvPr id="5" name="title-4">
             <a:extLst xmlns:a="http://schemas.openxmlformats.org/drawingml/2006/main">
               <a:ext uri="{FF2B5EF4-FFF2-40B4-BE49-F238E27FC236}">
-                <a16:creationId xmlns:a16="http://schemas.microsoft.com/office/drawing/2014/main" id="{7F81F3E8-6EE8-4E88-B633-080DEAD00022}"/>
+                <a16:creationId xmlns:a16="http://schemas.microsoft.com/office/drawing/2014/main" id="{19EC5D05-DC30-406B-B498-D04120B6ECA2}"/>
               </a:ext>
             </a:extLst>
           </p:cNvPr>
@@ -2224,24 +2224,24 @@
         <p:spPr>
           <a:xfrm xmlns:a="http://schemas.openxmlformats.org/drawingml/2006/main">
             <a:off x="914400" y="2171700"/>
-            <a:ext cx="10363200" cy="1752600"/>
-          </a:xfrm>
-          <a:prstGeom xmlns:a="http://schemas.openxmlformats.org/drawingml/2006/main" prst="rect">
-            <a:avLst/>
-          </a:prstGeom>
-          <a:noFill xmlns:a="http://schemas.openxmlformats.org/drawingml/2006/main"/>
-          <a:ln xmlns:a="http://schemas.openxmlformats.org/drawingml/2006/main" w="0">
-            <a:noFill/>
-          </a:ln>
-        </p:spPr>
-        <p:txBody>
-          <a:bodyPr xmlns:a="http://schemas.openxmlformats.org/drawingml/2006/main">
-            <a:noAutofit/>
-          </a:bodyPr>
-          <a:lstStyle xmlns:a="http://schemas.openxmlformats.org/drawingml/2006/main"/>
-          <a:p xmlns:a="http://schemas.openxmlformats.org/drawingml/2006/main">
-            <a:pPr algn="l">
-              <a:defRPr sz="3900" b="1" i="0">
+            <a:ext cx="5219700" cy="1752600"/>
+          </a:xfrm>
+          <a:prstGeom xmlns:a="http://schemas.openxmlformats.org/drawingml/2006/main" prst="rect">
+            <a:avLst/>
+          </a:prstGeom>
+          <a:noFill xmlns:a="http://schemas.openxmlformats.org/drawingml/2006/main"/>
+          <a:ln xmlns:a="http://schemas.openxmlformats.org/drawingml/2006/main" w="0">
+            <a:noFill/>
+          </a:ln>
+        </p:spPr>
+        <p:txBody>
+          <a:bodyPr xmlns:a="http://schemas.openxmlformats.org/drawingml/2006/main">
+            <a:noAutofit/>
+          </a:bodyPr>
+          <a:lstStyle xmlns:a="http://schemas.openxmlformats.org/drawingml/2006/main"/>
+          <a:p xmlns:a="http://schemas.openxmlformats.org/drawingml/2006/main">
+            <a:pPr algn="l">
+              <a:defRPr sz="2100" b="1" i="0">
                 <a:solidFill>
                   <a:srgbClr val="422D1A"/>
                 </a:solidFill>
@@ -2251,7 +2251,7 @@
               </a:defRPr>
             </a:pPr>
             <a:r>
-              <a:rPr sz="3900" b="1" i="0">
+              <a:rPr sz="2100" b="1" i="0">
                 <a:solidFill>
                   <a:srgbClr val="422D1A"/>
                 </a:solidFill>
@@ -2259,30 +2259,7 @@
                 <a:ea typeface="Arial"/>
                 <a:cs typeface="Arial"/>
               </a:rPr>
-              <a:t>[Tên bài học]</a:t>
-            </a:r>
-          </a:p>
-          <a:p xmlns:a="http://schemas.openxmlformats.org/drawingml/2006/main">
-            <a:pPr algn="l">
-              <a:defRPr sz="3900" b="1" i="0">
-                <a:solidFill>
-                  <a:srgbClr val="422D1A"/>
-                </a:solidFill>
-                <a:latin typeface="Arial"/>
-                <a:ea typeface="Arial"/>
-                <a:cs typeface="Arial"/>
-              </a:defRPr>
-            </a:pPr>
-            <a:r>
-              <a:rPr sz="3900" b="1" i="0">
-                <a:solidFill>
-                  <a:srgbClr val="422D1A"/>
-                </a:solidFill>
-                <a:latin typeface="Arial"/>
-                <a:ea typeface="Arial"/>
-                <a:cs typeface="Arial"/>
-              </a:rPr>
-              <a:t>[Chủ đề của tiết học]</a:t>
+              <a:t>Tìm quy luật của dãy số</a:t>
             </a:r>
           </a:p>
         </p:txBody>
@@ -2292,7 +2269,7 @@
           <p:cNvPr id="6" name="title-5">
             <a:extLst xmlns:a="http://schemas.openxmlformats.org/drawingml/2006/main">
               <a:ext uri="{FF2B5EF4-FFF2-40B4-BE49-F238E27FC236}">
-                <a16:creationId xmlns:a16="http://schemas.microsoft.com/office/drawing/2014/main" id="{95B76698-9208-42F9-8ED7-FBEB3DD4F6C9}"/>
+                <a16:creationId xmlns:a16="http://schemas.microsoft.com/office/drawing/2014/main" id="{D38F6E51-4F21-46C4-B812-7CD0C61ACB53}"/>
               </a:ext>
             </a:extLst>
           </p:cNvPr>
@@ -2304,24 +2281,24 @@
         <p:spPr>
           <a:xfrm xmlns:a="http://schemas.openxmlformats.org/drawingml/2006/main">
             <a:off x="914400" y="4248150"/>
-            <a:ext cx="10363200" cy="1752600"/>
-          </a:xfrm>
-          <a:prstGeom xmlns:a="http://schemas.openxmlformats.org/drawingml/2006/main" prst="rect">
-            <a:avLst/>
-          </a:prstGeom>
-          <a:noFill xmlns:a="http://schemas.openxmlformats.org/drawingml/2006/main"/>
-          <a:ln xmlns:a="http://schemas.openxmlformats.org/drawingml/2006/main" w="0">
-            <a:noFill/>
-          </a:ln>
-        </p:spPr>
-        <p:txBody>
-          <a:bodyPr xmlns:a="http://schemas.openxmlformats.org/drawingml/2006/main">
-            <a:noAutofit/>
-          </a:bodyPr>
-          <a:lstStyle xmlns:a="http://schemas.openxmlformats.org/drawingml/2006/main"/>
-          <a:p xmlns:a="http://schemas.openxmlformats.org/drawingml/2006/main">
-            <a:pPr algn="l">
-              <a:defRPr sz="3900" b="1" i="1">
+            <a:ext cx="5219700" cy="1752600"/>
+          </a:xfrm>
+          <a:prstGeom xmlns:a="http://schemas.openxmlformats.org/drawingml/2006/main" prst="rect">
+            <a:avLst/>
+          </a:prstGeom>
+          <a:noFill xmlns:a="http://schemas.openxmlformats.org/drawingml/2006/main"/>
+          <a:ln xmlns:a="http://schemas.openxmlformats.org/drawingml/2006/main" w="0">
+            <a:noFill/>
+          </a:ln>
+        </p:spPr>
+        <p:txBody>
+          <a:bodyPr xmlns:a="http://schemas.openxmlformats.org/drawingml/2006/main">
+            <a:noAutofit/>
+          </a:bodyPr>
+          <a:lstStyle xmlns:a="http://schemas.openxmlformats.org/drawingml/2006/main"/>
+          <a:p xmlns:a="http://schemas.openxmlformats.org/drawingml/2006/main">
+            <a:pPr algn="l">
+              <a:defRPr sz="2100" b="1" i="1">
                 <a:solidFill>
                   <a:srgbClr val="B85B14"/>
                 </a:solidFill>
@@ -2331,7 +2308,7 @@
               </a:defRPr>
             </a:pPr>
             <a:r>
-              <a:rPr sz="3900" b="1" i="1">
+              <a:rPr sz="2100" b="1" i="1">
                 <a:solidFill>
                   <a:srgbClr val="B85B14"/>
                 </a:solidFill>
@@ -2339,38 +2316,43 @@
                 <a:ea typeface="Arial"/>
                 <a:cs typeface="Arial"/>
               </a:rPr>
-              <a:t>[Lesson title]</a:t>
-            </a:r>
-          </a:p>
-          <a:p xmlns:a="http://schemas.openxmlformats.org/drawingml/2006/main">
-            <a:pPr algn="l">
-              <a:defRPr sz="3900" b="1" i="1">
-                <a:solidFill>
-                  <a:srgbClr val="B85B14"/>
-                </a:solidFill>
-                <a:latin typeface="Arial"/>
-                <a:ea typeface="Arial"/>
-                <a:cs typeface="Arial"/>
-              </a:defRPr>
-            </a:pPr>
-            <a:r>
-              <a:rPr sz="3900" b="1" i="1">
-                <a:solidFill>
-                  <a:srgbClr val="B85B14"/>
-                </a:solidFill>
-                <a:latin typeface="Arial"/>
-                <a:ea typeface="Arial"/>
-                <a:cs typeface="Arial"/>
-              </a:rPr>
-              <a:t>[Topic of the lesson]</a:t>
-            </a:r>
-          </a:p>
-        </p:txBody>
-      </p:sp>
+              <a:t>Find the sequence pattern</a:t>
+            </a:r>
+          </a:p>
+        </p:txBody>
+      </p:sp>
+      <p:pic>
+        <p:nvPicPr>
+          <p:cNvPr id="14" name=""/>
+          <p:cNvPicPr>
+            <a:picLocks xmlns:a="http://schemas.openxmlformats.org/drawingml/2006/main" noChangeAspect="1"/>
+          </p:cNvPicPr>
+          <p:nvPr/>
+        </p:nvPicPr>
+        <p:blipFill>
+          <a:blip xmlns:r="http://schemas.openxmlformats.org/officeDocument/2006/relationships" xmlns:a="http://schemas.openxmlformats.org/drawingml/2006/main" r:embed="R9b2486ee7ea547a3">
+            <a:extLst>
+              <a:ext uri="{96DAC541-7B7A-43D3-8B79-37D633B846F1}">
+                <asvg:svgBlip xmlns:asvg="http://schemas.microsoft.com/office/drawing/2016/SVG/main" r:embed="Rb8840b2b64b9407e"/>
+              </a:ext>
+            </a:extLst>
+          </a:blip>
+          <a:stretch xmlns:a="http://schemas.openxmlformats.org/drawingml/2006/main"/>
+        </p:blipFill>
+        <p:spPr>
+          <a:xfrm xmlns:a="http://schemas.openxmlformats.org/drawingml/2006/main">
+            <a:off x="6629400" y="2038350"/>
+            <a:ext cx="4953000" cy="3905250"/>
+          </a:xfrm>
+          <a:prstGeom xmlns:a="http://schemas.openxmlformats.org/drawingml/2006/main" prst="rect">
+            <a:avLst/>
+          </a:prstGeom>
+        </p:spPr>
+      </p:pic>
     </p:spTree>
     <p:extLst>
       <p:ext uri="{BB962C8B-B14F-4D97-AF65-F5344CB8AC3E}">
-        <p14:creationId xmlns:p14="http://schemas.microsoft.com/office/powerpoint/2010/main" val="1204073979"/>
+        <p14:creationId xmlns:p14="http://schemas.microsoft.com/office/powerpoint/2010/main" val="761577200"/>
       </p:ext>
     </p:extLst>
   </p:cSld>
@@ -2398,10 +2380,10 @@
       </p:grpSpPr>
       <p:sp>
         <p:nvSpPr>
-          <p:cNvPr id="7" name="example-0">
-            <a:extLst xmlns:a="http://schemas.openxmlformats.org/drawingml/2006/main">
-              <a:ext uri="{FF2B5EF4-FFF2-40B4-BE49-F238E27FC236}">
-                <a16:creationId xmlns:a16="http://schemas.microsoft.com/office/drawing/2014/main" id="{59918655-41EA-4185-8D43-A5B1FF62DD6B}"/>
+          <p:cNvPr id="8" name="example-0">
+            <a:extLst xmlns:a="http://schemas.openxmlformats.org/drawingml/2006/main">
+              <a:ext uri="{FF2B5EF4-FFF2-40B4-BE49-F238E27FC236}">
+                <a16:creationId xmlns:a16="http://schemas.microsoft.com/office/drawing/2014/main" id="{3F7C9CCE-6EB2-4840-9000-A194293CFAC4}"/>
               </a:ext>
             </a:extLst>
           </p:cNvPr>
@@ -2448,7 +2430,7 @@
                 <a:ea typeface="Arial"/>
                 <a:cs typeface="Arial"/>
               </a:rPr>
-              <a:t>BiliClass   /   Môn học của thầy cô   /   10–12</a:t>
+              <a:t>BiliClass   /   Toán · ví dụ minh họa   /   11</a:t>
             </a:r>
           </a:p>
         </p:txBody>
@@ -2458,7 +2440,7 @@
           <p:cNvPr id="2" name="example-1">
             <a:extLst xmlns:a="http://schemas.openxmlformats.org/drawingml/2006/main">
               <a:ext uri="{FF2B5EF4-FFF2-40B4-BE49-F238E27FC236}">
-                <a16:creationId xmlns:a16="http://schemas.microsoft.com/office/drawing/2014/main" id="{F3980B4B-580F-470E-9DB7-19365CD1B685}"/>
+                <a16:creationId xmlns:a16="http://schemas.microsoft.com/office/drawing/2014/main" id="{846CB0D7-C413-453E-A8DA-64335300819E}"/>
               </a:ext>
             </a:extLst>
           </p:cNvPr>
@@ -2505,7 +2487,7 @@
                 <a:ea typeface="Arial"/>
                 <a:cs typeface="Arial"/>
               </a:rPr>
-              <a:t>Mẫu bài giảng song ngữ</a:t>
+              <a:t>Cấp số cộng</a:t>
             </a:r>
           </a:p>
         </p:txBody>
@@ -2515,7 +2497,7 @@
           <p:cNvPr id="3" name="example-2">
             <a:extLst xmlns:a="http://schemas.openxmlformats.org/drawingml/2006/main">
               <a:ext uri="{FF2B5EF4-FFF2-40B4-BE49-F238E27FC236}">
-                <a16:creationId xmlns:a16="http://schemas.microsoft.com/office/drawing/2014/main" id="{641E94B7-C0BB-4F7D-AE83-A9ED2CD5C332}"/>
+                <a16:creationId xmlns:a16="http://schemas.microsoft.com/office/drawing/2014/main" id="{5576AF7A-5125-4007-B1C6-0E8B810F81C8}"/>
               </a:ext>
             </a:extLst>
           </p:cNvPr>
@@ -2572,7 +2554,7 @@
           <p:cNvPr id="4" name="example-3">
             <a:extLst xmlns:a="http://schemas.openxmlformats.org/drawingml/2006/main">
               <a:ext uri="{FF2B5EF4-FFF2-40B4-BE49-F238E27FC236}">
-                <a16:creationId xmlns:a16="http://schemas.microsoft.com/office/drawing/2014/main" id="{0345E91B-16E8-4732-B5CF-540F57938498}"/>
+                <a16:creationId xmlns:a16="http://schemas.microsoft.com/office/drawing/2014/main" id="{1B1D8A2F-0ABF-468A-8741-CDA6B7C37561}"/>
               </a:ext>
             </a:extLst>
           </p:cNvPr>
@@ -2619,7 +2601,7 @@
                 <a:ea typeface="Arial"/>
                 <a:cs typeface="Arial"/>
               </a:rPr>
-              <a:t>Mẫu cấu trúc · Thay bằng nội dung bài học</a:t>
+              <a:t>Ví dụ để xem thiết kế · Bài của thầy cô dùng nội dung và hình từ nguồn</a:t>
             </a:r>
           </a:p>
         </p:txBody>
@@ -2629,7 +2611,7 @@
           <p:cNvPr id="5" name="example-4">
             <a:extLst xmlns:a="http://schemas.openxmlformats.org/drawingml/2006/main">
               <a:ext uri="{FF2B5EF4-FFF2-40B4-BE49-F238E27FC236}">
-                <a16:creationId xmlns:a16="http://schemas.microsoft.com/office/drawing/2014/main" id="{C717DB41-AEF4-481C-98F5-80BA134B730A}"/>
+                <a16:creationId xmlns:a16="http://schemas.microsoft.com/office/drawing/2014/main" id="{C9AFDD44-C7E7-4599-8C14-34F59C42F6FE}"/>
               </a:ext>
             </a:extLst>
           </p:cNvPr>
@@ -2641,24 +2623,24 @@
         <p:spPr>
           <a:xfrm xmlns:a="http://schemas.openxmlformats.org/drawingml/2006/main">
             <a:off x="609600" y="2038350"/>
-            <a:ext cx="10972800" cy="1790700"/>
-          </a:xfrm>
-          <a:prstGeom xmlns:a="http://schemas.openxmlformats.org/drawingml/2006/main" prst="rect">
-            <a:avLst/>
-          </a:prstGeom>
-          <a:noFill xmlns:a="http://schemas.openxmlformats.org/drawingml/2006/main"/>
-          <a:ln xmlns:a="http://schemas.openxmlformats.org/drawingml/2006/main" w="0">
-            <a:noFill/>
-          </a:ln>
-        </p:spPr>
-        <p:txBody>
-          <a:bodyPr xmlns:a="http://schemas.openxmlformats.org/drawingml/2006/main">
-            <a:noAutofit/>
-          </a:bodyPr>
-          <a:lstStyle xmlns:a="http://schemas.openxmlformats.org/drawingml/2006/main"/>
-          <a:p xmlns:a="http://schemas.openxmlformats.org/drawingml/2006/main">
-            <a:pPr algn="l">
-              <a:defRPr sz="2400" b="0" i="0">
+            <a:ext cx="5219700" cy="1790700"/>
+          </a:xfrm>
+          <a:prstGeom xmlns:a="http://schemas.openxmlformats.org/drawingml/2006/main" prst="rect">
+            <a:avLst/>
+          </a:prstGeom>
+          <a:noFill xmlns:a="http://schemas.openxmlformats.org/drawingml/2006/main"/>
+          <a:ln xmlns:a="http://schemas.openxmlformats.org/drawingml/2006/main" w="0">
+            <a:noFill/>
+          </a:ln>
+        </p:spPr>
+        <p:txBody>
+          <a:bodyPr xmlns:a="http://schemas.openxmlformats.org/drawingml/2006/main">
+            <a:noAutofit/>
+          </a:bodyPr>
+          <a:lstStyle xmlns:a="http://schemas.openxmlformats.org/drawingml/2006/main"/>
+          <a:p xmlns:a="http://schemas.openxmlformats.org/drawingml/2006/main">
+            <a:pPr algn="l">
+              <a:defRPr sz="2100" b="0" i="0">
                 <a:solidFill>
                   <a:srgbClr val="422D1A"/>
                 </a:solidFill>
@@ -2668,7 +2650,7 @@
               </a:defRPr>
             </a:pPr>
             <a:r>
-              <a:rPr sz="2400" b="0" i="0">
+              <a:rPr sz="2100" b="0" i="0">
                 <a:solidFill>
                   <a:srgbClr val="422D1A"/>
                 </a:solidFill>
@@ -2676,12 +2658,12 @@
                 <a:ea typeface="Arial"/>
                 <a:cs typeface="Arial"/>
               </a:rPr>
-              <a:t>[Dữ kiện của ví dụ]</a:t>
-            </a:r>
-          </a:p>
-          <a:p xmlns:a="http://schemas.openxmlformats.org/drawingml/2006/main">
-            <a:pPr algn="l">
-              <a:defRPr sz="2400" b="0" i="0">
+              <a:t>u₁ = 2, d = 3</a:t>
+            </a:r>
+          </a:p>
+          <a:p xmlns:a="http://schemas.openxmlformats.org/drawingml/2006/main">
+            <a:pPr algn="l">
+              <a:defRPr sz="2100" b="0" i="0">
                 <a:solidFill>
                   <a:srgbClr val="422D1A"/>
                 </a:solidFill>
@@ -2691,7 +2673,7 @@
               </a:defRPr>
             </a:pPr>
             <a:r>
-              <a:rPr sz="2400" b="0" i="0">
+              <a:rPr sz="2100" b="0" i="0">
                 <a:solidFill>
                   <a:srgbClr val="422D1A"/>
                 </a:solidFill>
@@ -2699,30 +2681,7 @@
                 <a:ea typeface="Arial"/>
                 <a:cs typeface="Arial"/>
               </a:rPr>
-              <a:t>[Bước giải đã kiểm tra]</a:t>
-            </a:r>
-          </a:p>
-          <a:p xmlns:a="http://schemas.openxmlformats.org/drawingml/2006/main">
-            <a:pPr algn="l">
-              <a:defRPr sz="2400" b="0" i="0">
-                <a:solidFill>
-                  <a:srgbClr val="422D1A"/>
-                </a:solidFill>
-                <a:latin typeface="Arial"/>
-                <a:ea typeface="Arial"/>
-                <a:cs typeface="Arial"/>
-              </a:defRPr>
-            </a:pPr>
-            <a:r>
-              <a:rPr sz="2400" b="0" i="0">
-                <a:solidFill>
-                  <a:srgbClr val="422D1A"/>
-                </a:solidFill>
-                <a:latin typeface="Arial"/>
-                <a:ea typeface="Arial"/>
-                <a:cs typeface="Arial"/>
-              </a:rPr>
-              <a:t>[Kết quả và đơn vị]</a:t>
+              <a:t>u₄ = 2 + 3 × 3 = 11</a:t>
             </a:r>
           </a:p>
         </p:txBody>
@@ -2732,7 +2691,7 @@
           <p:cNvPr id="6" name="example-5">
             <a:extLst xmlns:a="http://schemas.openxmlformats.org/drawingml/2006/main">
               <a:ext uri="{FF2B5EF4-FFF2-40B4-BE49-F238E27FC236}">
-                <a16:creationId xmlns:a16="http://schemas.microsoft.com/office/drawing/2014/main" id="{A515EF39-3AB6-4F07-8A84-69D9AA2783F5}"/>
+                <a16:creationId xmlns:a16="http://schemas.microsoft.com/office/drawing/2014/main" id="{63394EE0-6C12-47C1-8C9A-F26F946AADC9}"/>
               </a:ext>
             </a:extLst>
           </p:cNvPr>
@@ -2744,24 +2703,24 @@
         <p:spPr>
           <a:xfrm xmlns:a="http://schemas.openxmlformats.org/drawingml/2006/main">
             <a:off x="609600" y="4152900"/>
-            <a:ext cx="10972800" cy="1790700"/>
-          </a:xfrm>
-          <a:prstGeom xmlns:a="http://schemas.openxmlformats.org/drawingml/2006/main" prst="rect">
-            <a:avLst/>
-          </a:prstGeom>
-          <a:noFill xmlns:a="http://schemas.openxmlformats.org/drawingml/2006/main"/>
-          <a:ln xmlns:a="http://schemas.openxmlformats.org/drawingml/2006/main" w="0">
-            <a:noFill/>
-          </a:ln>
-        </p:spPr>
-        <p:txBody>
-          <a:bodyPr xmlns:a="http://schemas.openxmlformats.org/drawingml/2006/main">
-            <a:noAutofit/>
-          </a:bodyPr>
-          <a:lstStyle xmlns:a="http://schemas.openxmlformats.org/drawingml/2006/main"/>
-          <a:p xmlns:a="http://schemas.openxmlformats.org/drawingml/2006/main">
-            <a:pPr algn="l">
-              <a:defRPr sz="2400" b="0" i="1">
+            <a:ext cx="5219700" cy="1790700"/>
+          </a:xfrm>
+          <a:prstGeom xmlns:a="http://schemas.openxmlformats.org/drawingml/2006/main" prst="rect">
+            <a:avLst/>
+          </a:prstGeom>
+          <a:noFill xmlns:a="http://schemas.openxmlformats.org/drawingml/2006/main"/>
+          <a:ln xmlns:a="http://schemas.openxmlformats.org/drawingml/2006/main" w="0">
+            <a:noFill/>
+          </a:ln>
+        </p:spPr>
+        <p:txBody>
+          <a:bodyPr xmlns:a="http://schemas.openxmlformats.org/drawingml/2006/main">
+            <a:noAutofit/>
+          </a:bodyPr>
+          <a:lstStyle xmlns:a="http://schemas.openxmlformats.org/drawingml/2006/main"/>
+          <a:p xmlns:a="http://schemas.openxmlformats.org/drawingml/2006/main">
+            <a:pPr algn="l">
+              <a:defRPr sz="2100" b="0" i="1">
                 <a:solidFill>
                   <a:srgbClr val="B85B14"/>
                 </a:solidFill>
@@ -2771,7 +2730,7 @@
               </a:defRPr>
             </a:pPr>
             <a:r>
-              <a:rPr sz="2400" b="0" i="1">
+              <a:rPr sz="2100" b="0" i="1">
                 <a:solidFill>
                   <a:srgbClr val="B85B14"/>
                 </a:solidFill>
@@ -2779,12 +2738,12 @@
                 <a:ea typeface="Arial"/>
                 <a:cs typeface="Arial"/>
               </a:rPr>
-              <a:t>[Example information]</a:t>
-            </a:r>
-          </a:p>
-          <a:p xmlns:a="http://schemas.openxmlformats.org/drawingml/2006/main">
-            <a:pPr algn="l">
-              <a:defRPr sz="2400" b="0" i="1">
+              <a:t>u₁ = 2, d = 3</a:t>
+            </a:r>
+          </a:p>
+          <a:p xmlns:a="http://schemas.openxmlformats.org/drawingml/2006/main">
+            <a:pPr algn="l">
+              <a:defRPr sz="2100" b="0" i="1">
                 <a:solidFill>
                   <a:srgbClr val="B85B14"/>
                 </a:solidFill>
@@ -2794,7 +2753,7 @@
               </a:defRPr>
             </a:pPr>
             <a:r>
-              <a:rPr sz="2400" b="0" i="1">
+              <a:rPr sz="2100" b="0" i="1">
                 <a:solidFill>
                   <a:srgbClr val="B85B14"/>
                 </a:solidFill>
@@ -2802,38 +2761,43 @@
                 <a:ea typeface="Arial"/>
                 <a:cs typeface="Arial"/>
               </a:rPr>
-              <a:t>[Checked solution step]</a:t>
-            </a:r>
-          </a:p>
-          <a:p xmlns:a="http://schemas.openxmlformats.org/drawingml/2006/main">
-            <a:pPr algn="l">
-              <a:defRPr sz="2400" b="0" i="1">
-                <a:solidFill>
-                  <a:srgbClr val="B85B14"/>
-                </a:solidFill>
-                <a:latin typeface="Arial"/>
-                <a:ea typeface="Arial"/>
-                <a:cs typeface="Arial"/>
-              </a:defRPr>
-            </a:pPr>
-            <a:r>
-              <a:rPr sz="2400" b="0" i="1">
-                <a:solidFill>
-                  <a:srgbClr val="B85B14"/>
-                </a:solidFill>
-                <a:latin typeface="Arial"/>
-                <a:ea typeface="Arial"/>
-                <a:cs typeface="Arial"/>
-              </a:rPr>
-              <a:t>[Result and unit]</a:t>
-            </a:r>
-          </a:p>
-        </p:txBody>
-      </p:sp>
+              <a:t>u₄ = 2 + 3 × 3 = 11</a:t>
+            </a:r>
+          </a:p>
+        </p:txBody>
+      </p:sp>
+      <p:pic>
+        <p:nvPicPr>
+          <p:cNvPr id="14" name=""/>
+          <p:cNvPicPr>
+            <a:picLocks xmlns:a="http://schemas.openxmlformats.org/drawingml/2006/main" noChangeAspect="1"/>
+          </p:cNvPicPr>
+          <p:nvPr/>
+        </p:nvPicPr>
+        <p:blipFill>
+          <a:blip xmlns:r="http://schemas.openxmlformats.org/officeDocument/2006/relationships" xmlns:a="http://schemas.openxmlformats.org/drawingml/2006/main" r:embed="Rc23ccf82e355495a">
+            <a:extLst>
+              <a:ext uri="{96DAC541-7B7A-43D3-8B79-37D633B846F1}">
+                <asvg:svgBlip xmlns:asvg="http://schemas.microsoft.com/office/drawing/2016/SVG/main" r:embed="R07b50303c0714f1a"/>
+              </a:ext>
+            </a:extLst>
+          </a:blip>
+          <a:stretch xmlns:a="http://schemas.openxmlformats.org/drawingml/2006/main"/>
+        </p:blipFill>
+        <p:spPr>
+          <a:xfrm xmlns:a="http://schemas.openxmlformats.org/drawingml/2006/main">
+            <a:off x="6629400" y="2038350"/>
+            <a:ext cx="4953000" cy="3905250"/>
+          </a:xfrm>
+          <a:prstGeom xmlns:a="http://schemas.openxmlformats.org/drawingml/2006/main" prst="rect">
+            <a:avLst/>
+          </a:prstGeom>
+        </p:spPr>
+      </p:pic>
     </p:spTree>
     <p:extLst>
       <p:ext uri="{BB962C8B-B14F-4D97-AF65-F5344CB8AC3E}">
-        <p14:creationId xmlns:p14="http://schemas.microsoft.com/office/powerpoint/2010/main" val="1829951890"/>
+        <p14:creationId xmlns:p14="http://schemas.microsoft.com/office/powerpoint/2010/main" val="350359093"/>
       </p:ext>
     </p:extLst>
   </p:cSld>
@@ -2861,10 +2825,10 @@
       </p:grpSpPr>
       <p:sp>
         <p:nvSpPr>
-          <p:cNvPr id="7" name="practice-0">
-            <a:extLst xmlns:a="http://schemas.openxmlformats.org/drawingml/2006/main">
-              <a:ext uri="{FF2B5EF4-FFF2-40B4-BE49-F238E27FC236}">
-                <a16:creationId xmlns:a16="http://schemas.microsoft.com/office/drawing/2014/main" id="{473D62B7-CBC9-4BC9-88B4-C43053AAC321}"/>
+          <p:cNvPr id="8" name="practice-0">
+            <a:extLst xmlns:a="http://schemas.openxmlformats.org/drawingml/2006/main">
+              <a:ext uri="{FF2B5EF4-FFF2-40B4-BE49-F238E27FC236}">
+                <a16:creationId xmlns:a16="http://schemas.microsoft.com/office/drawing/2014/main" id="{68019FA1-D244-4C0E-BA4F-EFD7E7D5CD55}"/>
               </a:ext>
             </a:extLst>
           </p:cNvPr>
@@ -2911,7 +2875,7 @@
                 <a:ea typeface="Arial"/>
                 <a:cs typeface="Arial"/>
               </a:rPr>
-              <a:t>BiliClass   /   Môn học của thầy cô   /   10–12</a:t>
+              <a:t>BiliClass   /   Toán · ví dụ minh họa   /   11</a:t>
             </a:r>
           </a:p>
         </p:txBody>
@@ -2921,7 +2885,7 @@
           <p:cNvPr id="2" name="practice-1">
             <a:extLst xmlns:a="http://schemas.openxmlformats.org/drawingml/2006/main">
               <a:ext uri="{FF2B5EF4-FFF2-40B4-BE49-F238E27FC236}">
-                <a16:creationId xmlns:a16="http://schemas.microsoft.com/office/drawing/2014/main" id="{DAA6F640-CDEF-45E1-A097-1FE900DAD3F5}"/>
+                <a16:creationId xmlns:a16="http://schemas.microsoft.com/office/drawing/2014/main" id="{B22D174D-9D7B-470A-B6B9-EEE89F47160F}"/>
               </a:ext>
             </a:extLst>
           </p:cNvPr>
@@ -2968,7 +2932,7 @@
                 <a:ea typeface="Arial"/>
                 <a:cs typeface="Arial"/>
               </a:rPr>
-              <a:t>Mẫu bài giảng song ngữ</a:t>
+              <a:t>Cấp số cộng</a:t>
             </a:r>
           </a:p>
         </p:txBody>
@@ -2978,7 +2942,7 @@
           <p:cNvPr id="3" name="practice-2">
             <a:extLst xmlns:a="http://schemas.openxmlformats.org/drawingml/2006/main">
               <a:ext uri="{FF2B5EF4-FFF2-40B4-BE49-F238E27FC236}">
-                <a16:creationId xmlns:a16="http://schemas.microsoft.com/office/drawing/2014/main" id="{EF9226B5-DF94-4AFC-AFDC-D103DD9D399C}"/>
+                <a16:creationId xmlns:a16="http://schemas.microsoft.com/office/drawing/2014/main" id="{8FD432FC-C2FA-4740-85E6-6CF899854D94}"/>
               </a:ext>
             </a:extLst>
           </p:cNvPr>
@@ -3035,7 +2999,7 @@
           <p:cNvPr id="4" name="practice-3">
             <a:extLst xmlns:a="http://schemas.openxmlformats.org/drawingml/2006/main">
               <a:ext uri="{FF2B5EF4-FFF2-40B4-BE49-F238E27FC236}">
-                <a16:creationId xmlns:a16="http://schemas.microsoft.com/office/drawing/2014/main" id="{4718CD2E-664A-4905-AA92-835A5A875CB4}"/>
+                <a16:creationId xmlns:a16="http://schemas.microsoft.com/office/drawing/2014/main" id="{23AAE244-8101-445C-B918-5B3FE5F8353A}"/>
               </a:ext>
             </a:extLst>
           </p:cNvPr>
@@ -3082,7 +3046,7 @@
                 <a:ea typeface="Arial"/>
                 <a:cs typeface="Arial"/>
               </a:rPr>
-              <a:t>Mẫu cấu trúc · Thay bằng nội dung bài học</a:t>
+              <a:t>Ví dụ để xem thiết kế · Bài của thầy cô dùng nội dung và hình từ nguồn</a:t>
             </a:r>
           </a:p>
         </p:txBody>
@@ -3092,7 +3056,7 @@
           <p:cNvPr id="5" name="practice-4">
             <a:extLst xmlns:a="http://schemas.openxmlformats.org/drawingml/2006/main">
               <a:ext uri="{FF2B5EF4-FFF2-40B4-BE49-F238E27FC236}">
-                <a16:creationId xmlns:a16="http://schemas.microsoft.com/office/drawing/2014/main" id="{65A231B5-74FA-4AF4-A5C6-FC4AB78C0417}"/>
+                <a16:creationId xmlns:a16="http://schemas.microsoft.com/office/drawing/2014/main" id="{51350BF7-684B-4FD8-BAB0-4BA911F1D99F}"/>
               </a:ext>
             </a:extLst>
           </p:cNvPr>
@@ -3104,24 +3068,24 @@
         <p:spPr>
           <a:xfrm xmlns:a="http://schemas.openxmlformats.org/drawingml/2006/main">
             <a:off x="609600" y="2038350"/>
-            <a:ext cx="10972800" cy="1790700"/>
-          </a:xfrm>
-          <a:prstGeom xmlns:a="http://schemas.openxmlformats.org/drawingml/2006/main" prst="rect">
-            <a:avLst/>
-          </a:prstGeom>
-          <a:noFill xmlns:a="http://schemas.openxmlformats.org/drawingml/2006/main"/>
-          <a:ln xmlns:a="http://schemas.openxmlformats.org/drawingml/2006/main" w="0">
-            <a:noFill/>
-          </a:ln>
-        </p:spPr>
-        <p:txBody>
-          <a:bodyPr xmlns:a="http://schemas.openxmlformats.org/drawingml/2006/main">
-            <a:noAutofit/>
-          </a:bodyPr>
-          <a:lstStyle xmlns:a="http://schemas.openxmlformats.org/drawingml/2006/main"/>
-          <a:p xmlns:a="http://schemas.openxmlformats.org/drawingml/2006/main">
-            <a:pPr algn="l">
-              <a:defRPr sz="2550" b="0" i="0">
+            <a:ext cx="5219700" cy="1790700"/>
+          </a:xfrm>
+          <a:prstGeom xmlns:a="http://schemas.openxmlformats.org/drawingml/2006/main" prst="rect">
+            <a:avLst/>
+          </a:prstGeom>
+          <a:noFill xmlns:a="http://schemas.openxmlformats.org/drawingml/2006/main"/>
+          <a:ln xmlns:a="http://schemas.openxmlformats.org/drawingml/2006/main" w="0">
+            <a:noFill/>
+          </a:ln>
+        </p:spPr>
+        <p:txBody>
+          <a:bodyPr xmlns:a="http://schemas.openxmlformats.org/drawingml/2006/main">
+            <a:noAutofit/>
+          </a:bodyPr>
+          <a:lstStyle xmlns:a="http://schemas.openxmlformats.org/drawingml/2006/main"/>
+          <a:p xmlns:a="http://schemas.openxmlformats.org/drawingml/2006/main">
+            <a:pPr algn="l">
+              <a:defRPr sz="2100" b="0" i="0">
                 <a:solidFill>
                   <a:srgbClr val="422D1A"/>
                 </a:solidFill>
@@ -3131,7 +3095,7 @@
               </a:defRPr>
             </a:pPr>
             <a:r>
-              <a:rPr sz="2550" b="0" i="0">
+              <a:rPr sz="2100" b="0" i="0">
                 <a:solidFill>
                   <a:srgbClr val="422D1A"/>
                 </a:solidFill>
@@ -3139,53 +3103,7 @@
                 <a:ea typeface="Arial"/>
                 <a:cs typeface="Arial"/>
               </a:rPr>
-              <a:t>[Yêu cầu của bài tập]</a:t>
-            </a:r>
-          </a:p>
-          <a:p xmlns:a="http://schemas.openxmlformats.org/drawingml/2006/main">
-            <a:pPr algn="l">
-              <a:defRPr sz="2550" b="0" i="0">
-                <a:solidFill>
-                  <a:srgbClr val="422D1A"/>
-                </a:solidFill>
-                <a:latin typeface="Arial"/>
-                <a:ea typeface="Arial"/>
-                <a:cs typeface="Arial"/>
-              </a:defRPr>
-            </a:pPr>
-            <a:r>
-              <a:rPr sz="2550" b="0" i="0">
-                <a:solidFill>
-                  <a:srgbClr val="422D1A"/>
-                </a:solidFill>
-                <a:latin typeface="Arial"/>
-                <a:ea typeface="Arial"/>
-                <a:cs typeface="Arial"/>
-              </a:rPr>
-              <a:t>[Dữ kiện được cung cấp]</a:t>
-            </a:r>
-          </a:p>
-          <a:p xmlns:a="http://schemas.openxmlformats.org/drawingml/2006/main">
-            <a:pPr algn="l">
-              <a:defRPr sz="2550" b="0" i="0">
-                <a:solidFill>
-                  <a:srgbClr val="422D1A"/>
-                </a:solidFill>
-                <a:latin typeface="Arial"/>
-                <a:ea typeface="Arial"/>
-                <a:cs typeface="Arial"/>
-              </a:defRPr>
-            </a:pPr>
-            <a:r>
-              <a:rPr sz="2550" b="0" i="0">
-                <a:solidFill>
-                  <a:srgbClr val="422D1A"/>
-                </a:solidFill>
-                <a:latin typeface="Arial"/>
-                <a:ea typeface="Arial"/>
-                <a:cs typeface="Arial"/>
-              </a:rPr>
-              <a:t>[Cách học sinh trình bày kết quả]</a:t>
+              <a:t>u₁ = 2, d = 3. Tìm u₅.</a:t>
             </a:r>
           </a:p>
         </p:txBody>
@@ -3195,7 +3113,7 @@
           <p:cNvPr id="6" name="practice-5">
             <a:extLst xmlns:a="http://schemas.openxmlformats.org/drawingml/2006/main">
               <a:ext uri="{FF2B5EF4-FFF2-40B4-BE49-F238E27FC236}">
-                <a16:creationId xmlns:a16="http://schemas.microsoft.com/office/drawing/2014/main" id="{398A8FC1-65F0-474F-83F8-8CCFC10E3314}"/>
+                <a16:creationId xmlns:a16="http://schemas.microsoft.com/office/drawing/2014/main" id="{E6030DF1-AFE9-4F8F-807F-99F400E928FC}"/>
               </a:ext>
             </a:extLst>
           </p:cNvPr>
@@ -3207,24 +3125,24 @@
         <p:spPr>
           <a:xfrm xmlns:a="http://schemas.openxmlformats.org/drawingml/2006/main">
             <a:off x="609600" y="4152900"/>
-            <a:ext cx="10972800" cy="1790700"/>
-          </a:xfrm>
-          <a:prstGeom xmlns:a="http://schemas.openxmlformats.org/drawingml/2006/main" prst="rect">
-            <a:avLst/>
-          </a:prstGeom>
-          <a:noFill xmlns:a="http://schemas.openxmlformats.org/drawingml/2006/main"/>
-          <a:ln xmlns:a="http://schemas.openxmlformats.org/drawingml/2006/main" w="0">
-            <a:noFill/>
-          </a:ln>
-        </p:spPr>
-        <p:txBody>
-          <a:bodyPr xmlns:a="http://schemas.openxmlformats.org/drawingml/2006/main">
-            <a:noAutofit/>
-          </a:bodyPr>
-          <a:lstStyle xmlns:a="http://schemas.openxmlformats.org/drawingml/2006/main"/>
-          <a:p xmlns:a="http://schemas.openxmlformats.org/drawingml/2006/main">
-            <a:pPr algn="l">
-              <a:defRPr sz="2550" b="0" i="1">
+            <a:ext cx="5219700" cy="1790700"/>
+          </a:xfrm>
+          <a:prstGeom xmlns:a="http://schemas.openxmlformats.org/drawingml/2006/main" prst="rect">
+            <a:avLst/>
+          </a:prstGeom>
+          <a:noFill xmlns:a="http://schemas.openxmlformats.org/drawingml/2006/main"/>
+          <a:ln xmlns:a="http://schemas.openxmlformats.org/drawingml/2006/main" w="0">
+            <a:noFill/>
+          </a:ln>
+        </p:spPr>
+        <p:txBody>
+          <a:bodyPr xmlns:a="http://schemas.openxmlformats.org/drawingml/2006/main">
+            <a:noAutofit/>
+          </a:bodyPr>
+          <a:lstStyle xmlns:a="http://schemas.openxmlformats.org/drawingml/2006/main"/>
+          <a:p xmlns:a="http://schemas.openxmlformats.org/drawingml/2006/main">
+            <a:pPr algn="l">
+              <a:defRPr sz="2100" b="0" i="1">
                 <a:solidFill>
                   <a:srgbClr val="B85B14"/>
                 </a:solidFill>
@@ -3234,7 +3152,7 @@
               </a:defRPr>
             </a:pPr>
             <a:r>
-              <a:rPr sz="2550" b="0" i="1">
+              <a:rPr sz="2100" b="0" i="1">
                 <a:solidFill>
                   <a:srgbClr val="B85B14"/>
                 </a:solidFill>
@@ -3242,61 +3160,43 @@
                 <a:ea typeface="Arial"/>
                 <a:cs typeface="Arial"/>
               </a:rPr>
-              <a:t>[Task instructions]</a:t>
-            </a:r>
-          </a:p>
-          <a:p xmlns:a="http://schemas.openxmlformats.org/drawingml/2006/main">
-            <a:pPr algn="l">
-              <a:defRPr sz="2550" b="0" i="1">
-                <a:solidFill>
-                  <a:srgbClr val="B85B14"/>
-                </a:solidFill>
-                <a:latin typeface="Arial"/>
-                <a:ea typeface="Arial"/>
-                <a:cs typeface="Arial"/>
-              </a:defRPr>
-            </a:pPr>
-            <a:r>
-              <a:rPr sz="2550" b="0" i="1">
-                <a:solidFill>
-                  <a:srgbClr val="B85B14"/>
-                </a:solidFill>
-                <a:latin typeface="Arial"/>
-                <a:ea typeface="Arial"/>
-                <a:cs typeface="Arial"/>
-              </a:rPr>
-              <a:t>[Given information]</a:t>
-            </a:r>
-          </a:p>
-          <a:p xmlns:a="http://schemas.openxmlformats.org/drawingml/2006/main">
-            <a:pPr algn="l">
-              <a:defRPr sz="2550" b="0" i="1">
-                <a:solidFill>
-                  <a:srgbClr val="B85B14"/>
-                </a:solidFill>
-                <a:latin typeface="Arial"/>
-                <a:ea typeface="Arial"/>
-                <a:cs typeface="Arial"/>
-              </a:defRPr>
-            </a:pPr>
-            <a:r>
-              <a:rPr sz="2550" b="0" i="1">
-                <a:solidFill>
-                  <a:srgbClr val="B85B14"/>
-                </a:solidFill>
-                <a:latin typeface="Arial"/>
-                <a:ea typeface="Arial"/>
-                <a:cs typeface="Arial"/>
-              </a:rPr>
-              <a:t>[How students present their results]</a:t>
-            </a:r>
-          </a:p>
-        </p:txBody>
-      </p:sp>
+              <a:t>u₁ = 2, d = 3. Find u₅.</a:t>
+            </a:r>
+          </a:p>
+        </p:txBody>
+      </p:sp>
+      <p:pic>
+        <p:nvPicPr>
+          <p:cNvPr id="14" name=""/>
+          <p:cNvPicPr>
+            <a:picLocks xmlns:a="http://schemas.openxmlformats.org/drawingml/2006/main" noChangeAspect="1"/>
+          </p:cNvPicPr>
+          <p:nvPr/>
+        </p:nvPicPr>
+        <p:blipFill>
+          <a:blip xmlns:r="http://schemas.openxmlformats.org/officeDocument/2006/relationships" xmlns:a="http://schemas.openxmlformats.org/drawingml/2006/main" r:embed="Rb3e86e3e5d5645c0">
+            <a:extLst>
+              <a:ext uri="{96DAC541-7B7A-43D3-8B79-37D633B846F1}">
+                <asvg:svgBlip xmlns:asvg="http://schemas.microsoft.com/office/drawing/2016/SVG/main" r:embed="Rc95a1ee8c0d34076"/>
+              </a:ext>
+            </a:extLst>
+          </a:blip>
+          <a:stretch xmlns:a="http://schemas.openxmlformats.org/drawingml/2006/main"/>
+        </p:blipFill>
+        <p:spPr>
+          <a:xfrm xmlns:a="http://schemas.openxmlformats.org/drawingml/2006/main">
+            <a:off x="6629400" y="2038350"/>
+            <a:ext cx="4953000" cy="3905250"/>
+          </a:xfrm>
+          <a:prstGeom xmlns:a="http://schemas.openxmlformats.org/drawingml/2006/main" prst="rect">
+            <a:avLst/>
+          </a:prstGeom>
+        </p:spPr>
+      </p:pic>
     </p:spTree>
     <p:extLst>
       <p:ext uri="{BB962C8B-B14F-4D97-AF65-F5344CB8AC3E}">
-        <p14:creationId xmlns:p14="http://schemas.microsoft.com/office/powerpoint/2010/main" val="65259122"/>
+        <p14:creationId xmlns:p14="http://schemas.microsoft.com/office/powerpoint/2010/main" val="2030892870"/>
       </p:ext>
     </p:extLst>
   </p:cSld>
@@ -3324,10 +3224,10 @@
       </p:grpSpPr>
       <p:sp>
         <p:nvSpPr>
-          <p:cNvPr id="7" name="question-0">
-            <a:extLst xmlns:a="http://schemas.openxmlformats.org/drawingml/2006/main">
-              <a:ext uri="{FF2B5EF4-FFF2-40B4-BE49-F238E27FC236}">
-                <a16:creationId xmlns:a16="http://schemas.microsoft.com/office/drawing/2014/main" id="{8850E951-EBA6-49FE-8763-2F7757B04F91}"/>
+          <p:cNvPr id="8" name="question-0">
+            <a:extLst xmlns:a="http://schemas.openxmlformats.org/drawingml/2006/main">
+              <a:ext uri="{FF2B5EF4-FFF2-40B4-BE49-F238E27FC236}">
+                <a16:creationId xmlns:a16="http://schemas.microsoft.com/office/drawing/2014/main" id="{CB4A8068-FDBD-4EE3-BAC3-27E90BC495E5}"/>
               </a:ext>
             </a:extLst>
           </p:cNvPr>
@@ -3374,7 +3274,7 @@
                 <a:ea typeface="Arial"/>
                 <a:cs typeface="Arial"/>
               </a:rPr>
-              <a:t>BiliClass   /   Môn học của thầy cô   /   10–12</a:t>
+              <a:t>BiliClass   /   Toán · ví dụ minh họa   /   11</a:t>
             </a:r>
           </a:p>
         </p:txBody>
@@ -3384,7 +3284,7 @@
           <p:cNvPr id="2" name="question-1">
             <a:extLst xmlns:a="http://schemas.openxmlformats.org/drawingml/2006/main">
               <a:ext uri="{FF2B5EF4-FFF2-40B4-BE49-F238E27FC236}">
-                <a16:creationId xmlns:a16="http://schemas.microsoft.com/office/drawing/2014/main" id="{B1C67FA7-12BB-4135-9F4A-AA2F1B1DD011}"/>
+                <a16:creationId xmlns:a16="http://schemas.microsoft.com/office/drawing/2014/main" id="{7969E238-1641-4BFE-B7D3-4A64BFB54D61}"/>
               </a:ext>
             </a:extLst>
           </p:cNvPr>
@@ -3431,7 +3331,7 @@
                 <a:ea typeface="Arial"/>
                 <a:cs typeface="Arial"/>
               </a:rPr>
-              <a:t>Mẫu bài giảng song ngữ</a:t>
+              <a:t>Cấp số cộng</a:t>
             </a:r>
           </a:p>
         </p:txBody>
@@ -3441,7 +3341,7 @@
           <p:cNvPr id="3" name="question-2">
             <a:extLst xmlns:a="http://schemas.openxmlformats.org/drawingml/2006/main">
               <a:ext uri="{FF2B5EF4-FFF2-40B4-BE49-F238E27FC236}">
-                <a16:creationId xmlns:a16="http://schemas.microsoft.com/office/drawing/2014/main" id="{C66FA899-C4BA-4BEE-BAE9-0C744FEDBBC4}"/>
+                <a16:creationId xmlns:a16="http://schemas.microsoft.com/office/drawing/2014/main" id="{64A4B209-03F4-4CC0-9766-46C58D1D0B57}"/>
               </a:ext>
             </a:extLst>
           </p:cNvPr>
@@ -3498,7 +3398,7 @@
           <p:cNvPr id="4" name="question-3">
             <a:extLst xmlns:a="http://schemas.openxmlformats.org/drawingml/2006/main">
               <a:ext uri="{FF2B5EF4-FFF2-40B4-BE49-F238E27FC236}">
-                <a16:creationId xmlns:a16="http://schemas.microsoft.com/office/drawing/2014/main" id="{A2AB7947-9608-4C05-9BE8-D29503298D2A}"/>
+                <a16:creationId xmlns:a16="http://schemas.microsoft.com/office/drawing/2014/main" id="{41474098-9777-42F0-8DC8-61BDAB5830D7}"/>
               </a:ext>
             </a:extLst>
           </p:cNvPr>
@@ -3545,7 +3445,7 @@
                 <a:ea typeface="Arial"/>
                 <a:cs typeface="Arial"/>
               </a:rPr>
-              <a:t>Mẫu cấu trúc · Thay bằng nội dung bài học</a:t>
+              <a:t>Ví dụ để xem thiết kế · Bài của thầy cô dùng nội dung và hình từ nguồn</a:t>
             </a:r>
           </a:p>
         </p:txBody>
@@ -3555,7 +3455,7 @@
           <p:cNvPr id="5" name="question-4">
             <a:extLst xmlns:a="http://schemas.openxmlformats.org/drawingml/2006/main">
               <a:ext uri="{FF2B5EF4-FFF2-40B4-BE49-F238E27FC236}">
-                <a16:creationId xmlns:a16="http://schemas.microsoft.com/office/drawing/2014/main" id="{6DAC64E6-9A68-45BC-B026-677BA43906E5}"/>
+                <a16:creationId xmlns:a16="http://schemas.microsoft.com/office/drawing/2014/main" id="{946486EA-900F-4EDD-B980-7E577936C5E1}"/>
               </a:ext>
             </a:extLst>
           </p:cNvPr>
@@ -3567,24 +3467,24 @@
         <p:spPr>
           <a:xfrm xmlns:a="http://schemas.openxmlformats.org/drawingml/2006/main">
             <a:off x="609600" y="2038350"/>
-            <a:ext cx="10972800" cy="1790700"/>
-          </a:xfrm>
-          <a:prstGeom xmlns:a="http://schemas.openxmlformats.org/drawingml/2006/main" prst="rect">
-            <a:avLst/>
-          </a:prstGeom>
-          <a:noFill xmlns:a="http://schemas.openxmlformats.org/drawingml/2006/main"/>
-          <a:ln xmlns:a="http://schemas.openxmlformats.org/drawingml/2006/main" w="0">
-            <a:noFill/>
-          </a:ln>
-        </p:spPr>
-        <p:txBody>
-          <a:bodyPr xmlns:a="http://schemas.openxmlformats.org/drawingml/2006/main">
-            <a:noAutofit/>
-          </a:bodyPr>
-          <a:lstStyle xmlns:a="http://schemas.openxmlformats.org/drawingml/2006/main"/>
-          <a:p xmlns:a="http://schemas.openxmlformats.org/drawingml/2006/main">
-            <a:pPr algn="l">
-              <a:defRPr sz="3150" b="1" i="0">
+            <a:ext cx="5219700" cy="1790700"/>
+          </a:xfrm>
+          <a:prstGeom xmlns:a="http://schemas.openxmlformats.org/drawingml/2006/main" prst="rect">
+            <a:avLst/>
+          </a:prstGeom>
+          <a:noFill xmlns:a="http://schemas.openxmlformats.org/drawingml/2006/main"/>
+          <a:ln xmlns:a="http://schemas.openxmlformats.org/drawingml/2006/main" w="0">
+            <a:noFill/>
+          </a:ln>
+        </p:spPr>
+        <p:txBody>
+          <a:bodyPr xmlns:a="http://schemas.openxmlformats.org/drawingml/2006/main">
+            <a:noAutofit/>
+          </a:bodyPr>
+          <a:lstStyle xmlns:a="http://schemas.openxmlformats.org/drawingml/2006/main"/>
+          <a:p xmlns:a="http://schemas.openxmlformats.org/drawingml/2006/main">
+            <a:pPr algn="l">
+              <a:defRPr sz="2100" b="1" i="0">
                 <a:solidFill>
                   <a:srgbClr val="422D1A"/>
                 </a:solidFill>
@@ -3594,7 +3494,7 @@
               </a:defRPr>
             </a:pPr>
             <a:r>
-              <a:rPr sz="3150" b="1" i="0">
+              <a:rPr sz="2100" b="1" i="0">
                 <a:solidFill>
                   <a:srgbClr val="422D1A"/>
                 </a:solidFill>
@@ -3602,30 +3502,7 @@
                 <a:ea typeface="Arial"/>
                 <a:cs typeface="Arial"/>
               </a:rPr>
-              <a:t>[Câu hỏi cho cả lớp]</a:t>
-            </a:r>
-          </a:p>
-          <a:p xmlns:a="http://schemas.openxmlformats.org/drawingml/2006/main">
-            <a:pPr algn="l">
-              <a:defRPr sz="3150" b="1" i="0">
-                <a:solidFill>
-                  <a:srgbClr val="422D1A"/>
-                </a:solidFill>
-                <a:latin typeface="Arial"/>
-                <a:ea typeface="Arial"/>
-                <a:cs typeface="Arial"/>
-              </a:defRPr>
-            </a:pPr>
-            <a:r>
-              <a:rPr sz="3150" b="1" i="0">
-                <a:solidFill>
-                  <a:srgbClr val="422D1A"/>
-                </a:solidFill>
-                <a:latin typeface="Arial"/>
-                <a:ea typeface="Arial"/>
-                <a:cs typeface="Arial"/>
-              </a:rPr>
-              <a:t>[Điều học sinh cần giải thích]</a:t>
+              <a:t>Giải thích vì sao công sai bằng 3.</a:t>
             </a:r>
           </a:p>
         </p:txBody>
@@ -3635,7 +3512,7 @@
           <p:cNvPr id="6" name="question-5">
             <a:extLst xmlns:a="http://schemas.openxmlformats.org/drawingml/2006/main">
               <a:ext uri="{FF2B5EF4-FFF2-40B4-BE49-F238E27FC236}">
-                <a16:creationId xmlns:a16="http://schemas.microsoft.com/office/drawing/2014/main" id="{81A7689D-4147-43B8-B006-121C34866D9A}"/>
+                <a16:creationId xmlns:a16="http://schemas.microsoft.com/office/drawing/2014/main" id="{B5C524EC-4828-4972-9576-FC02FFC68228}"/>
               </a:ext>
             </a:extLst>
           </p:cNvPr>
@@ -3647,24 +3524,24 @@
         <p:spPr>
           <a:xfrm xmlns:a="http://schemas.openxmlformats.org/drawingml/2006/main">
             <a:off x="609600" y="4152900"/>
-            <a:ext cx="10972800" cy="1790700"/>
-          </a:xfrm>
-          <a:prstGeom xmlns:a="http://schemas.openxmlformats.org/drawingml/2006/main" prst="rect">
-            <a:avLst/>
-          </a:prstGeom>
-          <a:noFill xmlns:a="http://schemas.openxmlformats.org/drawingml/2006/main"/>
-          <a:ln xmlns:a="http://schemas.openxmlformats.org/drawingml/2006/main" w="0">
-            <a:noFill/>
-          </a:ln>
-        </p:spPr>
-        <p:txBody>
-          <a:bodyPr xmlns:a="http://schemas.openxmlformats.org/drawingml/2006/main">
-            <a:noAutofit/>
-          </a:bodyPr>
-          <a:lstStyle xmlns:a="http://schemas.openxmlformats.org/drawingml/2006/main"/>
-          <a:p xmlns:a="http://schemas.openxmlformats.org/drawingml/2006/main">
-            <a:pPr algn="l">
-              <a:defRPr sz="3150" b="1" i="1">
+            <a:ext cx="5219700" cy="1790700"/>
+          </a:xfrm>
+          <a:prstGeom xmlns:a="http://schemas.openxmlformats.org/drawingml/2006/main" prst="rect">
+            <a:avLst/>
+          </a:prstGeom>
+          <a:noFill xmlns:a="http://schemas.openxmlformats.org/drawingml/2006/main"/>
+          <a:ln xmlns:a="http://schemas.openxmlformats.org/drawingml/2006/main" w="0">
+            <a:noFill/>
+          </a:ln>
+        </p:spPr>
+        <p:txBody>
+          <a:bodyPr xmlns:a="http://schemas.openxmlformats.org/drawingml/2006/main">
+            <a:noAutofit/>
+          </a:bodyPr>
+          <a:lstStyle xmlns:a="http://schemas.openxmlformats.org/drawingml/2006/main"/>
+          <a:p xmlns:a="http://schemas.openxmlformats.org/drawingml/2006/main">
+            <a:pPr algn="l">
+              <a:defRPr sz="2100" b="1" i="1">
                 <a:solidFill>
                   <a:srgbClr val="B85B14"/>
                 </a:solidFill>
@@ -3674,7 +3551,7 @@
               </a:defRPr>
             </a:pPr>
             <a:r>
-              <a:rPr sz="3150" b="1" i="1">
+              <a:rPr sz="2100" b="1" i="1">
                 <a:solidFill>
                   <a:srgbClr val="B85B14"/>
                 </a:solidFill>
@@ -3682,38 +3559,43 @@
                 <a:ea typeface="Arial"/>
                 <a:cs typeface="Arial"/>
               </a:rPr>
-              <a:t>[Question for the class]</a:t>
-            </a:r>
-          </a:p>
-          <a:p xmlns:a="http://schemas.openxmlformats.org/drawingml/2006/main">
-            <a:pPr algn="l">
-              <a:defRPr sz="3150" b="1" i="1">
-                <a:solidFill>
-                  <a:srgbClr val="B85B14"/>
-                </a:solidFill>
-                <a:latin typeface="Arial"/>
-                <a:ea typeface="Arial"/>
-                <a:cs typeface="Arial"/>
-              </a:defRPr>
-            </a:pPr>
-            <a:r>
-              <a:rPr sz="3150" b="1" i="1">
-                <a:solidFill>
-                  <a:srgbClr val="B85B14"/>
-                </a:solidFill>
-                <a:latin typeface="Arial"/>
-                <a:ea typeface="Arial"/>
-                <a:cs typeface="Arial"/>
-              </a:rPr>
-              <a:t>[What students should explain]</a:t>
-            </a:r>
-          </a:p>
-        </p:txBody>
-      </p:sp>
+              <a:t>Explain why the common difference is 3.</a:t>
+            </a:r>
+          </a:p>
+        </p:txBody>
+      </p:sp>
+      <p:pic>
+        <p:nvPicPr>
+          <p:cNvPr id="14" name=""/>
+          <p:cNvPicPr>
+            <a:picLocks xmlns:a="http://schemas.openxmlformats.org/drawingml/2006/main" noChangeAspect="1"/>
+          </p:cNvPicPr>
+          <p:nvPr/>
+        </p:nvPicPr>
+        <p:blipFill>
+          <a:blip xmlns:r="http://schemas.openxmlformats.org/officeDocument/2006/relationships" xmlns:a="http://schemas.openxmlformats.org/drawingml/2006/main" r:embed="R88fe688ab15941c4">
+            <a:extLst>
+              <a:ext uri="{96DAC541-7B7A-43D3-8B79-37D633B846F1}">
+                <asvg:svgBlip xmlns:asvg="http://schemas.microsoft.com/office/drawing/2016/SVG/main" r:embed="R10d0bcf633054d98"/>
+              </a:ext>
+            </a:extLst>
+          </a:blip>
+          <a:stretch xmlns:a="http://schemas.openxmlformats.org/drawingml/2006/main"/>
+        </p:blipFill>
+        <p:spPr>
+          <a:xfrm xmlns:a="http://schemas.openxmlformats.org/drawingml/2006/main">
+            <a:off x="6629400" y="2038350"/>
+            <a:ext cx="4953000" cy="3905250"/>
+          </a:xfrm>
+          <a:prstGeom xmlns:a="http://schemas.openxmlformats.org/drawingml/2006/main" prst="rect">
+            <a:avLst/>
+          </a:prstGeom>
+        </p:spPr>
+      </p:pic>
     </p:spTree>
     <p:extLst>
       <p:ext uri="{BB962C8B-B14F-4D97-AF65-F5344CB8AC3E}">
-        <p14:creationId xmlns:p14="http://schemas.microsoft.com/office/powerpoint/2010/main" val="1576947557"/>
+        <p14:creationId xmlns:p14="http://schemas.microsoft.com/office/powerpoint/2010/main" val="632685968"/>
       </p:ext>
     </p:extLst>
   </p:cSld>
@@ -3741,10 +3623,10 @@
       </p:grpSpPr>
       <p:sp>
         <p:nvSpPr>
-          <p:cNvPr id="7" name="check-0">
-            <a:extLst xmlns:a="http://schemas.openxmlformats.org/drawingml/2006/main">
-              <a:ext uri="{FF2B5EF4-FFF2-40B4-BE49-F238E27FC236}">
-                <a16:creationId xmlns:a16="http://schemas.microsoft.com/office/drawing/2014/main" id="{0788B149-2844-41FA-85CD-9F7DBFB9CE26}"/>
+          <p:cNvPr id="8" name="check-0">
+            <a:extLst xmlns:a="http://schemas.openxmlformats.org/drawingml/2006/main">
+              <a:ext uri="{FF2B5EF4-FFF2-40B4-BE49-F238E27FC236}">
+                <a16:creationId xmlns:a16="http://schemas.microsoft.com/office/drawing/2014/main" id="{8360E07F-4A5B-46AF-A0AF-EEF5029D2850}"/>
               </a:ext>
             </a:extLst>
           </p:cNvPr>
@@ -3791,7 +3673,7 @@
                 <a:ea typeface="Arial"/>
                 <a:cs typeface="Arial"/>
               </a:rPr>
-              <a:t>BiliClass   /   Môn học của thầy cô   /   10–12</a:t>
+              <a:t>BiliClass   /   Toán · ví dụ minh họa   /   11</a:t>
             </a:r>
           </a:p>
         </p:txBody>
@@ -3801,7 +3683,7 @@
           <p:cNvPr id="2" name="check-1">
             <a:extLst xmlns:a="http://schemas.openxmlformats.org/drawingml/2006/main">
               <a:ext uri="{FF2B5EF4-FFF2-40B4-BE49-F238E27FC236}">
-                <a16:creationId xmlns:a16="http://schemas.microsoft.com/office/drawing/2014/main" id="{AE301DB3-65F5-439F-984B-7ED0AB192B6E}"/>
+                <a16:creationId xmlns:a16="http://schemas.microsoft.com/office/drawing/2014/main" id="{7CF0E57F-76EA-4658-932E-F739E5951F88}"/>
               </a:ext>
             </a:extLst>
           </p:cNvPr>
@@ -3848,7 +3730,7 @@
                 <a:ea typeface="Arial"/>
                 <a:cs typeface="Arial"/>
               </a:rPr>
-              <a:t>Mẫu bài giảng song ngữ</a:t>
+              <a:t>Cấp số cộng</a:t>
             </a:r>
           </a:p>
         </p:txBody>
@@ -3858,7 +3740,7 @@
           <p:cNvPr id="3" name="check-2">
             <a:extLst xmlns:a="http://schemas.openxmlformats.org/drawingml/2006/main">
               <a:ext uri="{FF2B5EF4-FFF2-40B4-BE49-F238E27FC236}">
-                <a16:creationId xmlns:a16="http://schemas.microsoft.com/office/drawing/2014/main" id="{3887B10A-C678-4264-A758-F4FCF561ADED}"/>
+                <a16:creationId xmlns:a16="http://schemas.microsoft.com/office/drawing/2014/main" id="{0DAC3060-5A8E-4B8E-ABC8-6BD0857B4AE3}"/>
               </a:ext>
             </a:extLst>
           </p:cNvPr>
@@ -3915,7 +3797,7 @@
           <p:cNvPr id="4" name="check-3">
             <a:extLst xmlns:a="http://schemas.openxmlformats.org/drawingml/2006/main">
               <a:ext uri="{FF2B5EF4-FFF2-40B4-BE49-F238E27FC236}">
-                <a16:creationId xmlns:a16="http://schemas.microsoft.com/office/drawing/2014/main" id="{90FCB33A-D963-4ACE-ADFC-3857C6E5F200}"/>
+                <a16:creationId xmlns:a16="http://schemas.microsoft.com/office/drawing/2014/main" id="{40B20B4D-EEC9-472C-AE0E-386BB2307853}"/>
               </a:ext>
             </a:extLst>
           </p:cNvPr>
@@ -3962,7 +3844,7 @@
                 <a:ea typeface="Arial"/>
                 <a:cs typeface="Arial"/>
               </a:rPr>
-              <a:t>Mẫu cấu trúc · Thay bằng nội dung bài học</a:t>
+              <a:t>Ví dụ để xem thiết kế · Bài của thầy cô dùng nội dung và hình từ nguồn</a:t>
             </a:r>
           </a:p>
         </p:txBody>
@@ -3972,7 +3854,7 @@
           <p:cNvPr id="5" name="check-4">
             <a:extLst xmlns:a="http://schemas.openxmlformats.org/drawingml/2006/main">
               <a:ext uri="{FF2B5EF4-FFF2-40B4-BE49-F238E27FC236}">
-                <a16:creationId xmlns:a16="http://schemas.microsoft.com/office/drawing/2014/main" id="{E1D16BA5-EBA6-4C9A-B14A-74C31E5A9633}"/>
+                <a16:creationId xmlns:a16="http://schemas.microsoft.com/office/drawing/2014/main" id="{27CCF6B5-7A8F-4B67-BC20-FD457448F1AD}"/>
               </a:ext>
             </a:extLst>
           </p:cNvPr>
@@ -3984,24 +3866,24 @@
         <p:spPr>
           <a:xfrm xmlns:a="http://schemas.openxmlformats.org/drawingml/2006/main">
             <a:off x="609600" y="2038350"/>
-            <a:ext cx="10972800" cy="1790700"/>
-          </a:xfrm>
-          <a:prstGeom xmlns:a="http://schemas.openxmlformats.org/drawingml/2006/main" prst="rect">
-            <a:avLst/>
-          </a:prstGeom>
-          <a:noFill xmlns:a="http://schemas.openxmlformats.org/drawingml/2006/main"/>
-          <a:ln xmlns:a="http://schemas.openxmlformats.org/drawingml/2006/main" w="0">
-            <a:noFill/>
-          </a:ln>
-        </p:spPr>
-        <p:txBody>
-          <a:bodyPr xmlns:a="http://schemas.openxmlformats.org/drawingml/2006/main">
-            <a:noAutofit/>
-          </a:bodyPr>
-          <a:lstStyle xmlns:a="http://schemas.openxmlformats.org/drawingml/2006/main"/>
-          <a:p xmlns:a="http://schemas.openxmlformats.org/drawingml/2006/main">
-            <a:pPr algn="l">
-              <a:defRPr sz="2550" b="0" i="0">
+            <a:ext cx="5219700" cy="1790700"/>
+          </a:xfrm>
+          <a:prstGeom xmlns:a="http://schemas.openxmlformats.org/drawingml/2006/main" prst="rect">
+            <a:avLst/>
+          </a:prstGeom>
+          <a:noFill xmlns:a="http://schemas.openxmlformats.org/drawingml/2006/main"/>
+          <a:ln xmlns:a="http://schemas.openxmlformats.org/drawingml/2006/main" w="0">
+            <a:noFill/>
+          </a:ln>
+        </p:spPr>
+        <p:txBody>
+          <a:bodyPr xmlns:a="http://schemas.openxmlformats.org/drawingml/2006/main">
+            <a:noAutofit/>
+          </a:bodyPr>
+          <a:lstStyle xmlns:a="http://schemas.openxmlformats.org/drawingml/2006/main"/>
+          <a:p xmlns:a="http://schemas.openxmlformats.org/drawingml/2006/main">
+            <a:pPr algn="l">
+              <a:defRPr sz="2100" b="0" i="0">
                 <a:solidFill>
                   <a:srgbClr val="422D1A"/>
                 </a:solidFill>
@@ -4011,7 +3893,7 @@
               </a:defRPr>
             </a:pPr>
             <a:r>
-              <a:rPr sz="2550" b="0" i="0">
+              <a:rPr sz="2100" b="0" i="0">
                 <a:solidFill>
                   <a:srgbClr val="422D1A"/>
                 </a:solidFill>
@@ -4019,30 +3901,7 @@
                 <a:ea typeface="Arial"/>
                 <a:cs typeface="Arial"/>
               </a:rPr>
-              <a:t>[Câu hỏi kiểm tra]</a:t>
-            </a:r>
-          </a:p>
-          <a:p xmlns:a="http://schemas.openxmlformats.org/drawingml/2006/main">
-            <a:pPr algn="l">
-              <a:defRPr sz="2550" b="0" i="0">
-                <a:solidFill>
-                  <a:srgbClr val="422D1A"/>
-                </a:solidFill>
-                <a:latin typeface="Arial"/>
-                <a:ea typeface="Arial"/>
-                <a:cs typeface="Arial"/>
-              </a:defRPr>
-            </a:pPr>
-            <a:r>
-              <a:rPr sz="2550" b="0" i="0">
-                <a:solidFill>
-                  <a:srgbClr val="422D1A"/>
-                </a:solidFill>
-                <a:latin typeface="Arial"/>
-                <a:ea typeface="Arial"/>
-                <a:cs typeface="Arial"/>
-              </a:rPr>
-              <a:t>[Nội dung học sinh cần trả lời]</a:t>
+              <a:t>Dãy 3, 7, 11 có công sai là gì?</a:t>
             </a:r>
           </a:p>
         </p:txBody>
@@ -4052,7 +3911,7 @@
           <p:cNvPr id="6" name="check-5">
             <a:extLst xmlns:a="http://schemas.openxmlformats.org/drawingml/2006/main">
               <a:ext uri="{FF2B5EF4-FFF2-40B4-BE49-F238E27FC236}">
-                <a16:creationId xmlns:a16="http://schemas.microsoft.com/office/drawing/2014/main" id="{9DE3BA94-CE99-4D79-A753-C34FECAC6299}"/>
+                <a16:creationId xmlns:a16="http://schemas.microsoft.com/office/drawing/2014/main" id="{A5497DD4-5794-430F-B775-08E5A91CF73B}"/>
               </a:ext>
             </a:extLst>
           </p:cNvPr>
@@ -4064,24 +3923,24 @@
         <p:spPr>
           <a:xfrm xmlns:a="http://schemas.openxmlformats.org/drawingml/2006/main">
             <a:off x="609600" y="4152900"/>
-            <a:ext cx="10972800" cy="1790700"/>
-          </a:xfrm>
-          <a:prstGeom xmlns:a="http://schemas.openxmlformats.org/drawingml/2006/main" prst="rect">
-            <a:avLst/>
-          </a:prstGeom>
-          <a:noFill xmlns:a="http://schemas.openxmlformats.org/drawingml/2006/main"/>
-          <a:ln xmlns:a="http://schemas.openxmlformats.org/drawingml/2006/main" w="0">
-            <a:noFill/>
-          </a:ln>
-        </p:spPr>
-        <p:txBody>
-          <a:bodyPr xmlns:a="http://schemas.openxmlformats.org/drawingml/2006/main">
-            <a:noAutofit/>
-          </a:bodyPr>
-          <a:lstStyle xmlns:a="http://schemas.openxmlformats.org/drawingml/2006/main"/>
-          <a:p xmlns:a="http://schemas.openxmlformats.org/drawingml/2006/main">
-            <a:pPr algn="l">
-              <a:defRPr sz="2550" b="0" i="1">
+            <a:ext cx="5219700" cy="1790700"/>
+          </a:xfrm>
+          <a:prstGeom xmlns:a="http://schemas.openxmlformats.org/drawingml/2006/main" prst="rect">
+            <a:avLst/>
+          </a:prstGeom>
+          <a:noFill xmlns:a="http://schemas.openxmlformats.org/drawingml/2006/main"/>
+          <a:ln xmlns:a="http://schemas.openxmlformats.org/drawingml/2006/main" w="0">
+            <a:noFill/>
+          </a:ln>
+        </p:spPr>
+        <p:txBody>
+          <a:bodyPr xmlns:a="http://schemas.openxmlformats.org/drawingml/2006/main">
+            <a:noAutofit/>
+          </a:bodyPr>
+          <a:lstStyle xmlns:a="http://schemas.openxmlformats.org/drawingml/2006/main"/>
+          <a:p xmlns:a="http://schemas.openxmlformats.org/drawingml/2006/main">
+            <a:pPr algn="l">
+              <a:defRPr sz="2100" b="0" i="1">
                 <a:solidFill>
                   <a:srgbClr val="B85B14"/>
                 </a:solidFill>
@@ -4091,7 +3950,7 @@
               </a:defRPr>
             </a:pPr>
             <a:r>
-              <a:rPr sz="2550" b="0" i="1">
+              <a:rPr sz="2100" b="0" i="1">
                 <a:solidFill>
                   <a:srgbClr val="B85B14"/>
                 </a:solidFill>
@@ -4099,38 +3958,43 @@
                 <a:ea typeface="Arial"/>
                 <a:cs typeface="Arial"/>
               </a:rPr>
-              <a:t>[Check question]</a:t>
-            </a:r>
-          </a:p>
-          <a:p xmlns:a="http://schemas.openxmlformats.org/drawingml/2006/main">
-            <a:pPr algn="l">
-              <a:defRPr sz="2550" b="0" i="1">
-                <a:solidFill>
-                  <a:srgbClr val="B85B14"/>
-                </a:solidFill>
-                <a:latin typeface="Arial"/>
-                <a:ea typeface="Arial"/>
-                <a:cs typeface="Arial"/>
-              </a:defRPr>
-            </a:pPr>
-            <a:r>
-              <a:rPr sz="2550" b="0" i="1">
-                <a:solidFill>
-                  <a:srgbClr val="B85B14"/>
-                </a:solidFill>
-                <a:latin typeface="Arial"/>
-                <a:ea typeface="Arial"/>
-                <a:cs typeface="Arial"/>
-              </a:rPr>
-              <a:t>[What students should answer]</a:t>
-            </a:r>
-          </a:p>
-        </p:txBody>
-      </p:sp>
+              <a:t>Find d for the sequence 3, 7, 11.</a:t>
+            </a:r>
+          </a:p>
+        </p:txBody>
+      </p:sp>
+      <p:pic>
+        <p:nvPicPr>
+          <p:cNvPr id="14" name=""/>
+          <p:cNvPicPr>
+            <a:picLocks xmlns:a="http://schemas.openxmlformats.org/drawingml/2006/main" noChangeAspect="1"/>
+          </p:cNvPicPr>
+          <p:nvPr/>
+        </p:nvPicPr>
+        <p:blipFill>
+          <a:blip xmlns:r="http://schemas.openxmlformats.org/officeDocument/2006/relationships" xmlns:a="http://schemas.openxmlformats.org/drawingml/2006/main" r:embed="Rf7eafb23eb164cc0">
+            <a:extLst>
+              <a:ext uri="{96DAC541-7B7A-43D3-8B79-37D633B846F1}">
+                <asvg:svgBlip xmlns:asvg="http://schemas.microsoft.com/office/drawing/2016/SVG/main" r:embed="Re3e3352294c54f2c"/>
+              </a:ext>
+            </a:extLst>
+          </a:blip>
+          <a:stretch xmlns:a="http://schemas.openxmlformats.org/drawingml/2006/main"/>
+        </p:blipFill>
+        <p:spPr>
+          <a:xfrm xmlns:a="http://schemas.openxmlformats.org/drawingml/2006/main">
+            <a:off x="6629400" y="2038350"/>
+            <a:ext cx="4953000" cy="3905250"/>
+          </a:xfrm>
+          <a:prstGeom xmlns:a="http://schemas.openxmlformats.org/drawingml/2006/main" prst="rect">
+            <a:avLst/>
+          </a:prstGeom>
+        </p:spPr>
+      </p:pic>
     </p:spTree>
     <p:extLst>
       <p:ext uri="{BB962C8B-B14F-4D97-AF65-F5344CB8AC3E}">
-        <p14:creationId xmlns:p14="http://schemas.microsoft.com/office/powerpoint/2010/main" val="1107025983"/>
+        <p14:creationId xmlns:p14="http://schemas.microsoft.com/office/powerpoint/2010/main" val="1380380957"/>
       </p:ext>
     </p:extLst>
   </p:cSld>
@@ -4158,10 +4022,10 @@
       </p:grpSpPr>
       <p:sp>
         <p:nvSpPr>
-          <p:cNvPr id="7" name="summary-0">
-            <a:extLst xmlns:a="http://schemas.openxmlformats.org/drawingml/2006/main">
-              <a:ext uri="{FF2B5EF4-FFF2-40B4-BE49-F238E27FC236}">
-                <a16:creationId xmlns:a16="http://schemas.microsoft.com/office/drawing/2014/main" id="{037A3472-E83C-4D52-8481-ADFBD1328247}"/>
+          <p:cNvPr id="8" name="summary-0">
+            <a:extLst xmlns:a="http://schemas.openxmlformats.org/drawingml/2006/main">
+              <a:ext uri="{FF2B5EF4-FFF2-40B4-BE49-F238E27FC236}">
+                <a16:creationId xmlns:a16="http://schemas.microsoft.com/office/drawing/2014/main" id="{E9A5F8F7-D83B-4BAC-9712-73502C8FCE70}"/>
               </a:ext>
             </a:extLst>
           </p:cNvPr>
@@ -4208,7 +4072,7 @@
                 <a:ea typeface="Arial"/>
                 <a:cs typeface="Arial"/>
               </a:rPr>
-              <a:t>BiliClass   /   Môn học của thầy cô   /   10–12</a:t>
+              <a:t>BiliClass   /   Toán · ví dụ minh họa   /   11</a:t>
             </a:r>
           </a:p>
         </p:txBody>
@@ -4218,7 +4082,7 @@
           <p:cNvPr id="2" name="summary-1">
             <a:extLst xmlns:a="http://schemas.openxmlformats.org/drawingml/2006/main">
               <a:ext uri="{FF2B5EF4-FFF2-40B4-BE49-F238E27FC236}">
-                <a16:creationId xmlns:a16="http://schemas.microsoft.com/office/drawing/2014/main" id="{A1C7F45E-AEBC-40AA-B234-0D77C119E69B}"/>
+                <a16:creationId xmlns:a16="http://schemas.microsoft.com/office/drawing/2014/main" id="{01A76EAE-3C08-4485-A373-0B9D4F88EAA6}"/>
               </a:ext>
             </a:extLst>
           </p:cNvPr>
@@ -4265,7 +4129,7 @@
                 <a:ea typeface="Arial"/>
                 <a:cs typeface="Arial"/>
               </a:rPr>
-              <a:t>Mẫu bài giảng song ngữ</a:t>
+              <a:t>Cấp số cộng</a:t>
             </a:r>
           </a:p>
         </p:txBody>
@@ -4275,7 +4139,7 @@
           <p:cNvPr id="3" name="summary-2">
             <a:extLst xmlns:a="http://schemas.openxmlformats.org/drawingml/2006/main">
               <a:ext uri="{FF2B5EF4-FFF2-40B4-BE49-F238E27FC236}">
-                <a16:creationId xmlns:a16="http://schemas.microsoft.com/office/drawing/2014/main" id="{C824A822-C174-482F-AF54-64AAE13D00BC}"/>
+                <a16:creationId xmlns:a16="http://schemas.microsoft.com/office/drawing/2014/main" id="{431FB87D-3754-45FD-904B-3FEBA2395213}"/>
               </a:ext>
             </a:extLst>
           </p:cNvPr>
@@ -4332,7 +4196,7 @@
           <p:cNvPr id="4" name="summary-3">
             <a:extLst xmlns:a="http://schemas.openxmlformats.org/drawingml/2006/main">
               <a:ext uri="{FF2B5EF4-FFF2-40B4-BE49-F238E27FC236}">
-                <a16:creationId xmlns:a16="http://schemas.microsoft.com/office/drawing/2014/main" id="{1D9FD17A-07A1-4835-9B51-BA314D2CEF95}"/>
+                <a16:creationId xmlns:a16="http://schemas.microsoft.com/office/drawing/2014/main" id="{7093137E-EA0B-4855-84BE-91588E781C56}"/>
               </a:ext>
             </a:extLst>
           </p:cNvPr>
@@ -4379,7 +4243,7 @@
                 <a:ea typeface="Arial"/>
                 <a:cs typeface="Arial"/>
               </a:rPr>
-              <a:t>Mẫu cấu trúc · Thay bằng nội dung bài học</a:t>
+              <a:t>Ví dụ để xem thiết kế · Bài của thầy cô dùng nội dung và hình từ nguồn</a:t>
             </a:r>
           </a:p>
         </p:txBody>
@@ -4389,7 +4253,7 @@
           <p:cNvPr id="5" name="summary-4">
             <a:extLst xmlns:a="http://schemas.openxmlformats.org/drawingml/2006/main">
               <a:ext uri="{FF2B5EF4-FFF2-40B4-BE49-F238E27FC236}">
-                <a16:creationId xmlns:a16="http://schemas.microsoft.com/office/drawing/2014/main" id="{B82BD287-454F-410C-867A-7379567C6869}"/>
+                <a16:creationId xmlns:a16="http://schemas.microsoft.com/office/drawing/2014/main" id="{10C6695A-CCC2-4C5F-9072-1559C8F7A3AE}"/>
               </a:ext>
             </a:extLst>
           </p:cNvPr>
@@ -4401,24 +4265,24 @@
         <p:spPr>
           <a:xfrm xmlns:a="http://schemas.openxmlformats.org/drawingml/2006/main">
             <a:off x="609600" y="2038350"/>
-            <a:ext cx="10972800" cy="1790700"/>
-          </a:xfrm>
-          <a:prstGeom xmlns:a="http://schemas.openxmlformats.org/drawingml/2006/main" prst="rect">
-            <a:avLst/>
-          </a:prstGeom>
-          <a:noFill xmlns:a="http://schemas.openxmlformats.org/drawingml/2006/main"/>
-          <a:ln xmlns:a="http://schemas.openxmlformats.org/drawingml/2006/main" w="0">
-            <a:noFill/>
-          </a:ln>
-        </p:spPr>
-        <p:txBody>
-          <a:bodyPr xmlns:a="http://schemas.openxmlformats.org/drawingml/2006/main">
-            <a:noAutofit/>
-          </a:bodyPr>
-          <a:lstStyle xmlns:a="http://schemas.openxmlformats.org/drawingml/2006/main"/>
-          <a:p xmlns:a="http://schemas.openxmlformats.org/drawingml/2006/main">
-            <a:pPr algn="l">
-              <a:defRPr sz="2550" b="0" i="0">
+            <a:ext cx="5219700" cy="1790700"/>
+          </a:xfrm>
+          <a:prstGeom xmlns:a="http://schemas.openxmlformats.org/drawingml/2006/main" prst="rect">
+            <a:avLst/>
+          </a:prstGeom>
+          <a:noFill xmlns:a="http://schemas.openxmlformats.org/drawingml/2006/main"/>
+          <a:ln xmlns:a="http://schemas.openxmlformats.org/drawingml/2006/main" w="0">
+            <a:noFill/>
+          </a:ln>
+        </p:spPr>
+        <p:txBody>
+          <a:bodyPr xmlns:a="http://schemas.openxmlformats.org/drawingml/2006/main">
+            <a:noAutofit/>
+          </a:bodyPr>
+          <a:lstStyle xmlns:a="http://schemas.openxmlformats.org/drawingml/2006/main"/>
+          <a:p xmlns:a="http://schemas.openxmlformats.org/drawingml/2006/main">
+            <a:pPr algn="l">
+              <a:defRPr sz="2100" b="0" i="0">
                 <a:solidFill>
                   <a:srgbClr val="422D1A"/>
                 </a:solidFill>
@@ -4428,7 +4292,7 @@
               </a:defRPr>
             </a:pPr>
             <a:r>
-              <a:rPr sz="2550" b="0" i="0">
+              <a:rPr sz="2100" b="0" i="0">
                 <a:solidFill>
                   <a:srgbClr val="422D1A"/>
                 </a:solidFill>
@@ -4436,30 +4300,7 @@
                 <a:ea typeface="Arial"/>
                 <a:cs typeface="Arial"/>
               </a:rPr>
-              <a:t>[Ý chính cần ghi nhớ]</a:t>
-            </a:r>
-          </a:p>
-          <a:p xmlns:a="http://schemas.openxmlformats.org/drawingml/2006/main">
-            <a:pPr algn="l">
-              <a:defRPr sz="2550" b="0" i="0">
-                <a:solidFill>
-                  <a:srgbClr val="422D1A"/>
-                </a:solidFill>
-                <a:latin typeface="Arial"/>
-                <a:ea typeface="Arial"/>
-                <a:cs typeface="Arial"/>
-              </a:defRPr>
-            </a:pPr>
-            <a:r>
-              <a:rPr sz="2550" b="0" i="0">
-                <a:solidFill>
-                  <a:srgbClr val="422D1A"/>
-                </a:solidFill>
-                <a:latin typeface="Arial"/>
-                <a:ea typeface="Arial"/>
-                <a:cs typeface="Arial"/>
-              </a:rPr>
-              <a:t>[Điều học sinh cần giải thích cuối tiết]</a:t>
+              <a:t>Mỗi bước cộng cùng một số d.</a:t>
             </a:r>
           </a:p>
         </p:txBody>
@@ -4469,7 +4310,7 @@
           <p:cNvPr id="6" name="summary-5">
             <a:extLst xmlns:a="http://schemas.openxmlformats.org/drawingml/2006/main">
               <a:ext uri="{FF2B5EF4-FFF2-40B4-BE49-F238E27FC236}">
-                <a16:creationId xmlns:a16="http://schemas.microsoft.com/office/drawing/2014/main" id="{1414CFF0-8AC4-4D46-8B6C-FA3D89C98C8F}"/>
+                <a16:creationId xmlns:a16="http://schemas.microsoft.com/office/drawing/2014/main" id="{3ED28ADC-F8AD-4452-9747-F0780BDB668C}"/>
               </a:ext>
             </a:extLst>
           </p:cNvPr>
@@ -4481,24 +4322,24 @@
         <p:spPr>
           <a:xfrm xmlns:a="http://schemas.openxmlformats.org/drawingml/2006/main">
             <a:off x="609600" y="4152900"/>
-            <a:ext cx="10972800" cy="1790700"/>
-          </a:xfrm>
-          <a:prstGeom xmlns:a="http://schemas.openxmlformats.org/drawingml/2006/main" prst="rect">
-            <a:avLst/>
-          </a:prstGeom>
-          <a:noFill xmlns:a="http://schemas.openxmlformats.org/drawingml/2006/main"/>
-          <a:ln xmlns:a="http://schemas.openxmlformats.org/drawingml/2006/main" w="0">
-            <a:noFill/>
-          </a:ln>
-        </p:spPr>
-        <p:txBody>
-          <a:bodyPr xmlns:a="http://schemas.openxmlformats.org/drawingml/2006/main">
-            <a:noAutofit/>
-          </a:bodyPr>
-          <a:lstStyle xmlns:a="http://schemas.openxmlformats.org/drawingml/2006/main"/>
-          <a:p xmlns:a="http://schemas.openxmlformats.org/drawingml/2006/main">
-            <a:pPr algn="l">
-              <a:defRPr sz="2550" b="0" i="1">
+            <a:ext cx="5219700" cy="1790700"/>
+          </a:xfrm>
+          <a:prstGeom xmlns:a="http://schemas.openxmlformats.org/drawingml/2006/main" prst="rect">
+            <a:avLst/>
+          </a:prstGeom>
+          <a:noFill xmlns:a="http://schemas.openxmlformats.org/drawingml/2006/main"/>
+          <a:ln xmlns:a="http://schemas.openxmlformats.org/drawingml/2006/main" w="0">
+            <a:noFill/>
+          </a:ln>
+        </p:spPr>
+        <p:txBody>
+          <a:bodyPr xmlns:a="http://schemas.openxmlformats.org/drawingml/2006/main">
+            <a:noAutofit/>
+          </a:bodyPr>
+          <a:lstStyle xmlns:a="http://schemas.openxmlformats.org/drawingml/2006/main"/>
+          <a:p xmlns:a="http://schemas.openxmlformats.org/drawingml/2006/main">
+            <a:pPr algn="l">
+              <a:defRPr sz="2100" b="0" i="1">
                 <a:solidFill>
                   <a:srgbClr val="B85B14"/>
                 </a:solidFill>
@@ -4508,7 +4349,7 @@
               </a:defRPr>
             </a:pPr>
             <a:r>
-              <a:rPr sz="2550" b="0" i="1">
+              <a:rPr sz="2100" b="0" i="1">
                 <a:solidFill>
                   <a:srgbClr val="B85B14"/>
                 </a:solidFill>
@@ -4516,38 +4357,43 @@
                 <a:ea typeface="Arial"/>
                 <a:cs typeface="Arial"/>
               </a:rPr>
-              <a:t>[Key idea to remember]</a:t>
-            </a:r>
-          </a:p>
-          <a:p xmlns:a="http://schemas.openxmlformats.org/drawingml/2006/main">
-            <a:pPr algn="l">
-              <a:defRPr sz="2550" b="0" i="1">
-                <a:solidFill>
-                  <a:srgbClr val="B85B14"/>
-                </a:solidFill>
-                <a:latin typeface="Arial"/>
-                <a:ea typeface="Arial"/>
-                <a:cs typeface="Arial"/>
-              </a:defRPr>
-            </a:pPr>
-            <a:r>
-              <a:rPr sz="2550" b="0" i="1">
-                <a:solidFill>
-                  <a:srgbClr val="B85B14"/>
-                </a:solidFill>
-                <a:latin typeface="Arial"/>
-                <a:ea typeface="Arial"/>
-                <a:cs typeface="Arial"/>
-              </a:rPr>
-              <a:t>[What students should explain at the end]</a:t>
-            </a:r>
-          </a:p>
-        </p:txBody>
-      </p:sp>
+              <a:t>Add the same number d at each step.</a:t>
+            </a:r>
+          </a:p>
+        </p:txBody>
+      </p:sp>
+      <p:pic>
+        <p:nvPicPr>
+          <p:cNvPr id="14" name=""/>
+          <p:cNvPicPr>
+            <a:picLocks xmlns:a="http://schemas.openxmlformats.org/drawingml/2006/main" noChangeAspect="1"/>
+          </p:cNvPicPr>
+          <p:nvPr/>
+        </p:nvPicPr>
+        <p:blipFill>
+          <a:blip xmlns:r="http://schemas.openxmlformats.org/officeDocument/2006/relationships" xmlns:a="http://schemas.openxmlformats.org/drawingml/2006/main" r:embed="R20068229eca44d14">
+            <a:extLst>
+              <a:ext uri="{96DAC541-7B7A-43D3-8B79-37D633B846F1}">
+                <asvg:svgBlip xmlns:asvg="http://schemas.microsoft.com/office/drawing/2016/SVG/main" r:embed="R60140cc4a0e04b52"/>
+              </a:ext>
+            </a:extLst>
+          </a:blip>
+          <a:stretch xmlns:a="http://schemas.openxmlformats.org/drawingml/2006/main"/>
+        </p:blipFill>
+        <p:spPr>
+          <a:xfrm xmlns:a="http://schemas.openxmlformats.org/drawingml/2006/main">
+            <a:off x="6629400" y="2038350"/>
+            <a:ext cx="4953000" cy="3905250"/>
+          </a:xfrm>
+          <a:prstGeom xmlns:a="http://schemas.openxmlformats.org/drawingml/2006/main" prst="rect">
+            <a:avLst/>
+          </a:prstGeom>
+        </p:spPr>
+      </p:pic>
     </p:spTree>
     <p:extLst>
       <p:ext uri="{BB962C8B-B14F-4D97-AF65-F5344CB8AC3E}">
-        <p14:creationId xmlns:p14="http://schemas.microsoft.com/office/powerpoint/2010/main" val="857411165"/>
+        <p14:creationId xmlns:p14="http://schemas.microsoft.com/office/powerpoint/2010/main" val="735612599"/>
       </p:ext>
     </p:extLst>
   </p:cSld>
@@ -4575,10 +4421,10 @@
       </p:grpSpPr>
       <p:sp>
         <p:nvSpPr>
-          <p:cNvPr id="7" name="goal-0">
-            <a:extLst xmlns:a="http://schemas.openxmlformats.org/drawingml/2006/main">
-              <a:ext uri="{FF2B5EF4-FFF2-40B4-BE49-F238E27FC236}">
-                <a16:creationId xmlns:a16="http://schemas.microsoft.com/office/drawing/2014/main" id="{1B668CA9-F3F5-4DD3-8642-600D3116437C}"/>
+          <p:cNvPr id="8" name="goal-0">
+            <a:extLst xmlns:a="http://schemas.openxmlformats.org/drawingml/2006/main">
+              <a:ext uri="{FF2B5EF4-FFF2-40B4-BE49-F238E27FC236}">
+                <a16:creationId xmlns:a16="http://schemas.microsoft.com/office/drawing/2014/main" id="{FAFBB90B-D43F-40A1-A2DE-A41F15AF2E7D}"/>
               </a:ext>
             </a:extLst>
           </p:cNvPr>
@@ -4625,7 +4471,7 @@
                 <a:ea typeface="Arial"/>
                 <a:cs typeface="Arial"/>
               </a:rPr>
-              <a:t>BiliClass   /   Môn học của thầy cô   /   10–12</a:t>
+              <a:t>BiliClass   /   Toán · ví dụ minh họa   /   11</a:t>
             </a:r>
           </a:p>
         </p:txBody>
@@ -4635,7 +4481,7 @@
           <p:cNvPr id="2" name="goal-1">
             <a:extLst xmlns:a="http://schemas.openxmlformats.org/drawingml/2006/main">
               <a:ext uri="{FF2B5EF4-FFF2-40B4-BE49-F238E27FC236}">
-                <a16:creationId xmlns:a16="http://schemas.microsoft.com/office/drawing/2014/main" id="{A9AB0A86-629C-46CB-AC02-69C04CB46855}"/>
+                <a16:creationId xmlns:a16="http://schemas.microsoft.com/office/drawing/2014/main" id="{52BBB271-B810-4EB4-AC15-E894980A34CC}"/>
               </a:ext>
             </a:extLst>
           </p:cNvPr>
@@ -4682,7 +4528,7 @@
                 <a:ea typeface="Arial"/>
                 <a:cs typeface="Arial"/>
               </a:rPr>
-              <a:t>Mẫu bài giảng song ngữ</a:t>
+              <a:t>Cấp số cộng</a:t>
             </a:r>
           </a:p>
         </p:txBody>
@@ -4692,7 +4538,7 @@
           <p:cNvPr id="3" name="goal-2">
             <a:extLst xmlns:a="http://schemas.openxmlformats.org/drawingml/2006/main">
               <a:ext uri="{FF2B5EF4-FFF2-40B4-BE49-F238E27FC236}">
-                <a16:creationId xmlns:a16="http://schemas.microsoft.com/office/drawing/2014/main" id="{69883BFA-AB33-44A5-9927-9545937041B7}"/>
+                <a16:creationId xmlns:a16="http://schemas.microsoft.com/office/drawing/2014/main" id="{2655DF45-73C6-4215-A3A4-F3DF30EAE769}"/>
               </a:ext>
             </a:extLst>
           </p:cNvPr>
@@ -4749,7 +4595,7 @@
           <p:cNvPr id="4" name="goal-3">
             <a:extLst xmlns:a="http://schemas.openxmlformats.org/drawingml/2006/main">
               <a:ext uri="{FF2B5EF4-FFF2-40B4-BE49-F238E27FC236}">
-                <a16:creationId xmlns:a16="http://schemas.microsoft.com/office/drawing/2014/main" id="{F722E571-A3F1-42E9-833A-1E0E3BF162E8}"/>
+                <a16:creationId xmlns:a16="http://schemas.microsoft.com/office/drawing/2014/main" id="{176CC7ED-8564-4433-9C44-C927F1148C9C}"/>
               </a:ext>
             </a:extLst>
           </p:cNvPr>
@@ -4796,7 +4642,7 @@
                 <a:ea typeface="Arial"/>
                 <a:cs typeface="Arial"/>
               </a:rPr>
-              <a:t>Mẫu cấu trúc · Thay bằng nội dung bài học</a:t>
+              <a:t>Ví dụ để xem thiết kế · Bài của thầy cô dùng nội dung và hình từ nguồn</a:t>
             </a:r>
           </a:p>
         </p:txBody>
@@ -4806,7 +4652,7 @@
           <p:cNvPr id="5" name="goal-4">
             <a:extLst xmlns:a="http://schemas.openxmlformats.org/drawingml/2006/main">
               <a:ext uri="{FF2B5EF4-FFF2-40B4-BE49-F238E27FC236}">
-                <a16:creationId xmlns:a16="http://schemas.microsoft.com/office/drawing/2014/main" id="{E1A8729F-7784-40C2-A02F-4482DAC495EA}"/>
+                <a16:creationId xmlns:a16="http://schemas.microsoft.com/office/drawing/2014/main" id="{7FFDE290-A7CB-40F2-93D3-2E901B153635}"/>
               </a:ext>
             </a:extLst>
           </p:cNvPr>
@@ -4818,24 +4664,24 @@
         <p:spPr>
           <a:xfrm xmlns:a="http://schemas.openxmlformats.org/drawingml/2006/main">
             <a:off x="609600" y="2038350"/>
-            <a:ext cx="10972800" cy="1790700"/>
-          </a:xfrm>
-          <a:prstGeom xmlns:a="http://schemas.openxmlformats.org/drawingml/2006/main" prst="rect">
-            <a:avLst/>
-          </a:prstGeom>
-          <a:noFill xmlns:a="http://schemas.openxmlformats.org/drawingml/2006/main"/>
-          <a:ln xmlns:a="http://schemas.openxmlformats.org/drawingml/2006/main" w="0">
-            <a:noFill/>
-          </a:ln>
-        </p:spPr>
-        <p:txBody>
-          <a:bodyPr xmlns:a="http://schemas.openxmlformats.org/drawingml/2006/main">
-            <a:noAutofit/>
-          </a:bodyPr>
-          <a:lstStyle xmlns:a="http://schemas.openxmlformats.org/drawingml/2006/main"/>
-          <a:p xmlns:a="http://schemas.openxmlformats.org/drawingml/2006/main">
-            <a:pPr algn="l">
-              <a:defRPr sz="2550" b="0" i="0">
+            <a:ext cx="5219700" cy="1790700"/>
+          </a:xfrm>
+          <a:prstGeom xmlns:a="http://schemas.openxmlformats.org/drawingml/2006/main" prst="rect">
+            <a:avLst/>
+          </a:prstGeom>
+          <a:noFill xmlns:a="http://schemas.openxmlformats.org/drawingml/2006/main"/>
+          <a:ln xmlns:a="http://schemas.openxmlformats.org/drawingml/2006/main" w="0">
+            <a:noFill/>
+          </a:ln>
+        </p:spPr>
+        <p:txBody>
+          <a:bodyPr xmlns:a="http://schemas.openxmlformats.org/drawingml/2006/main">
+            <a:noAutofit/>
+          </a:bodyPr>
+          <a:lstStyle xmlns:a="http://schemas.openxmlformats.org/drawingml/2006/main"/>
+          <a:p xmlns:a="http://schemas.openxmlformats.org/drawingml/2006/main">
+            <a:pPr algn="l">
+              <a:defRPr sz="2100" b="0" i="0">
                 <a:solidFill>
                   <a:srgbClr val="422D1A"/>
                 </a:solidFill>
@@ -4845,7 +4691,7 @@
               </a:defRPr>
             </a:pPr>
             <a:r>
-              <a:rPr sz="2550" b="0" i="0">
+              <a:rPr sz="2100" b="0" i="0">
                 <a:solidFill>
                   <a:srgbClr val="422D1A"/>
                 </a:solidFill>
@@ -4853,30 +4699,7 @@
                 <a:ea typeface="Arial"/>
                 <a:cs typeface="Arial"/>
               </a:rPr>
-              <a:t>[Điều học sinh cần hiểu]</a:t>
-            </a:r>
-          </a:p>
-          <a:p xmlns:a="http://schemas.openxmlformats.org/drawingml/2006/main">
-            <a:pPr algn="l">
-              <a:defRPr sz="2550" b="0" i="0">
-                <a:solidFill>
-                  <a:srgbClr val="422D1A"/>
-                </a:solidFill>
-                <a:latin typeface="Arial"/>
-                <a:ea typeface="Arial"/>
-                <a:cs typeface="Arial"/>
-              </a:defRPr>
-            </a:pPr>
-            <a:r>
-              <a:rPr sz="2550" b="0" i="0">
-                <a:solidFill>
-                  <a:srgbClr val="422D1A"/>
-                </a:solidFill>
-                <a:latin typeface="Arial"/>
-                <a:ea typeface="Arial"/>
-                <a:cs typeface="Arial"/>
-              </a:rPr>
-              <a:t>[Điều học sinh cần làm được]</a:t>
+              <a:t>Xác định công sai của cấp số cộng.</a:t>
             </a:r>
           </a:p>
         </p:txBody>
@@ -4886,7 +4709,7 @@
           <p:cNvPr id="6" name="goal-5">
             <a:extLst xmlns:a="http://schemas.openxmlformats.org/drawingml/2006/main">
               <a:ext uri="{FF2B5EF4-FFF2-40B4-BE49-F238E27FC236}">
-                <a16:creationId xmlns:a16="http://schemas.microsoft.com/office/drawing/2014/main" id="{687DB8D8-DEFE-4D91-84DD-37046C2CA549}"/>
+                <a16:creationId xmlns:a16="http://schemas.microsoft.com/office/drawing/2014/main" id="{10904B56-FDA9-4F4F-9962-AC4D96F742FD}"/>
               </a:ext>
             </a:extLst>
           </p:cNvPr>
@@ -4898,24 +4721,24 @@
         <p:spPr>
           <a:xfrm xmlns:a="http://schemas.openxmlformats.org/drawingml/2006/main">
             <a:off x="609600" y="4152900"/>
-            <a:ext cx="10972800" cy="1790700"/>
-          </a:xfrm>
-          <a:prstGeom xmlns:a="http://schemas.openxmlformats.org/drawingml/2006/main" prst="rect">
-            <a:avLst/>
-          </a:prstGeom>
-          <a:noFill xmlns:a="http://schemas.openxmlformats.org/drawingml/2006/main"/>
-          <a:ln xmlns:a="http://schemas.openxmlformats.org/drawingml/2006/main" w="0">
-            <a:noFill/>
-          </a:ln>
-        </p:spPr>
-        <p:txBody>
-          <a:bodyPr xmlns:a="http://schemas.openxmlformats.org/drawingml/2006/main">
-            <a:noAutofit/>
-          </a:bodyPr>
-          <a:lstStyle xmlns:a="http://schemas.openxmlformats.org/drawingml/2006/main"/>
-          <a:p xmlns:a="http://schemas.openxmlformats.org/drawingml/2006/main">
-            <a:pPr algn="l">
-              <a:defRPr sz="2550" b="0" i="1">
+            <a:ext cx="5219700" cy="1790700"/>
+          </a:xfrm>
+          <a:prstGeom xmlns:a="http://schemas.openxmlformats.org/drawingml/2006/main" prst="rect">
+            <a:avLst/>
+          </a:prstGeom>
+          <a:noFill xmlns:a="http://schemas.openxmlformats.org/drawingml/2006/main"/>
+          <a:ln xmlns:a="http://schemas.openxmlformats.org/drawingml/2006/main" w="0">
+            <a:noFill/>
+          </a:ln>
+        </p:spPr>
+        <p:txBody>
+          <a:bodyPr xmlns:a="http://schemas.openxmlformats.org/drawingml/2006/main">
+            <a:noAutofit/>
+          </a:bodyPr>
+          <a:lstStyle xmlns:a="http://schemas.openxmlformats.org/drawingml/2006/main"/>
+          <a:p xmlns:a="http://schemas.openxmlformats.org/drawingml/2006/main">
+            <a:pPr algn="l">
+              <a:defRPr sz="2100" b="0" i="1">
                 <a:solidFill>
                   <a:srgbClr val="B85B14"/>
                 </a:solidFill>
@@ -4925,7 +4748,7 @@
               </a:defRPr>
             </a:pPr>
             <a:r>
-              <a:rPr sz="2550" b="0" i="1">
+              <a:rPr sz="2100" b="0" i="1">
                 <a:solidFill>
                   <a:srgbClr val="B85B14"/>
                 </a:solidFill>
@@ -4933,38 +4756,43 @@
                 <a:ea typeface="Arial"/>
                 <a:cs typeface="Arial"/>
               </a:rPr>
-              <a:t>[What students should understand]</a:t>
-            </a:r>
-          </a:p>
-          <a:p xmlns:a="http://schemas.openxmlformats.org/drawingml/2006/main">
-            <a:pPr algn="l">
-              <a:defRPr sz="2550" b="0" i="1">
-                <a:solidFill>
-                  <a:srgbClr val="B85B14"/>
-                </a:solidFill>
-                <a:latin typeface="Arial"/>
-                <a:ea typeface="Arial"/>
-                <a:cs typeface="Arial"/>
-              </a:defRPr>
-            </a:pPr>
-            <a:r>
-              <a:rPr sz="2550" b="0" i="1">
-                <a:solidFill>
-                  <a:srgbClr val="B85B14"/>
-                </a:solidFill>
-                <a:latin typeface="Arial"/>
-                <a:ea typeface="Arial"/>
-                <a:cs typeface="Arial"/>
-              </a:rPr>
-              <a:t>[What students should be able to do]</a:t>
-            </a:r>
-          </a:p>
-        </p:txBody>
-      </p:sp>
+              <a:t>Find the common difference.</a:t>
+            </a:r>
+          </a:p>
+        </p:txBody>
+      </p:sp>
+      <p:pic>
+        <p:nvPicPr>
+          <p:cNvPr id="14" name=""/>
+          <p:cNvPicPr>
+            <a:picLocks xmlns:a="http://schemas.openxmlformats.org/drawingml/2006/main" noChangeAspect="1"/>
+          </p:cNvPicPr>
+          <p:nvPr/>
+        </p:nvPicPr>
+        <p:blipFill>
+          <a:blip xmlns:r="http://schemas.openxmlformats.org/officeDocument/2006/relationships" xmlns:a="http://schemas.openxmlformats.org/drawingml/2006/main" r:embed="Rf27746f8b0604742">
+            <a:extLst>
+              <a:ext uri="{96DAC541-7B7A-43D3-8B79-37D633B846F1}">
+                <asvg:svgBlip xmlns:asvg="http://schemas.microsoft.com/office/drawing/2016/SVG/main" r:embed="R5a45f908da6b4cca"/>
+              </a:ext>
+            </a:extLst>
+          </a:blip>
+          <a:stretch xmlns:a="http://schemas.openxmlformats.org/drawingml/2006/main"/>
+        </p:blipFill>
+        <p:spPr>
+          <a:xfrm xmlns:a="http://schemas.openxmlformats.org/drawingml/2006/main">
+            <a:off x="6629400" y="2038350"/>
+            <a:ext cx="4953000" cy="3905250"/>
+          </a:xfrm>
+          <a:prstGeom xmlns:a="http://schemas.openxmlformats.org/drawingml/2006/main" prst="rect">
+            <a:avLst/>
+          </a:prstGeom>
+        </p:spPr>
+      </p:pic>
     </p:spTree>
     <p:extLst>
       <p:ext uri="{BB962C8B-B14F-4D97-AF65-F5344CB8AC3E}">
-        <p14:creationId xmlns:p14="http://schemas.microsoft.com/office/powerpoint/2010/main" val="2046009564"/>
+        <p14:creationId xmlns:p14="http://schemas.microsoft.com/office/powerpoint/2010/main" val="1256756105"/>
       </p:ext>
     </p:extLst>
   </p:cSld>
@@ -4992,10 +4820,10 @@
       </p:grpSpPr>
       <p:sp>
         <p:nvSpPr>
-          <p:cNvPr id="7" name="warmup-0">
-            <a:extLst xmlns:a="http://schemas.openxmlformats.org/drawingml/2006/main">
-              <a:ext uri="{FF2B5EF4-FFF2-40B4-BE49-F238E27FC236}">
-                <a16:creationId xmlns:a16="http://schemas.microsoft.com/office/drawing/2014/main" id="{E7E264A8-0856-4FB0-8F8E-DA57D96EED0B}"/>
+          <p:cNvPr id="8" name="warmup-0">
+            <a:extLst xmlns:a="http://schemas.openxmlformats.org/drawingml/2006/main">
+              <a:ext uri="{FF2B5EF4-FFF2-40B4-BE49-F238E27FC236}">
+                <a16:creationId xmlns:a16="http://schemas.microsoft.com/office/drawing/2014/main" id="{50ECA62F-F63F-4563-8D7E-719E69D405E4}"/>
               </a:ext>
             </a:extLst>
           </p:cNvPr>
@@ -5042,7 +4870,7 @@
                 <a:ea typeface="Arial"/>
                 <a:cs typeface="Arial"/>
               </a:rPr>
-              <a:t>BiliClass   /   Môn học của thầy cô   /   10–12</a:t>
+              <a:t>BiliClass   /   Toán · ví dụ minh họa   /   11</a:t>
             </a:r>
           </a:p>
         </p:txBody>
@@ -5052,7 +4880,7 @@
           <p:cNvPr id="2" name="warmup-1">
             <a:extLst xmlns:a="http://schemas.openxmlformats.org/drawingml/2006/main">
               <a:ext uri="{FF2B5EF4-FFF2-40B4-BE49-F238E27FC236}">
-                <a16:creationId xmlns:a16="http://schemas.microsoft.com/office/drawing/2014/main" id="{97263737-1689-4AB4-9E41-5841EC6AA1FD}"/>
+                <a16:creationId xmlns:a16="http://schemas.microsoft.com/office/drawing/2014/main" id="{E0C5120C-B9A1-4F7F-BEA6-901CC46D4B4A}"/>
               </a:ext>
             </a:extLst>
           </p:cNvPr>
@@ -5099,7 +4927,7 @@
                 <a:ea typeface="Arial"/>
                 <a:cs typeface="Arial"/>
               </a:rPr>
-              <a:t>Mẫu bài giảng song ngữ</a:t>
+              <a:t>Cấp số cộng</a:t>
             </a:r>
           </a:p>
         </p:txBody>
@@ -5109,7 +4937,7 @@
           <p:cNvPr id="3" name="warmup-2">
             <a:extLst xmlns:a="http://schemas.openxmlformats.org/drawingml/2006/main">
               <a:ext uri="{FF2B5EF4-FFF2-40B4-BE49-F238E27FC236}">
-                <a16:creationId xmlns:a16="http://schemas.microsoft.com/office/drawing/2014/main" id="{142A0499-586C-474C-8B81-AA4D61ACEDFE}"/>
+                <a16:creationId xmlns:a16="http://schemas.microsoft.com/office/drawing/2014/main" id="{B22CA791-AE29-4B66-8E3D-ADADFB0387E8}"/>
               </a:ext>
             </a:extLst>
           </p:cNvPr>
@@ -5166,7 +4994,7 @@
           <p:cNvPr id="4" name="warmup-3">
             <a:extLst xmlns:a="http://schemas.openxmlformats.org/drawingml/2006/main">
               <a:ext uri="{FF2B5EF4-FFF2-40B4-BE49-F238E27FC236}">
-                <a16:creationId xmlns:a16="http://schemas.microsoft.com/office/drawing/2014/main" id="{D5F2861C-F674-4A2E-86A4-E5BCDE717247}"/>
+                <a16:creationId xmlns:a16="http://schemas.microsoft.com/office/drawing/2014/main" id="{DE03B635-17ED-4F89-AABA-3594FE109998}"/>
               </a:ext>
             </a:extLst>
           </p:cNvPr>
@@ -5213,7 +5041,7 @@
                 <a:ea typeface="Arial"/>
                 <a:cs typeface="Arial"/>
               </a:rPr>
-              <a:t>Mẫu cấu trúc · Thay bằng nội dung bài học</a:t>
+              <a:t>Ví dụ để xem thiết kế · Bài của thầy cô dùng nội dung và hình từ nguồn</a:t>
             </a:r>
           </a:p>
         </p:txBody>
@@ -5223,7 +5051,7 @@
           <p:cNvPr id="5" name="warmup-4">
             <a:extLst xmlns:a="http://schemas.openxmlformats.org/drawingml/2006/main">
               <a:ext uri="{FF2B5EF4-FFF2-40B4-BE49-F238E27FC236}">
-                <a16:creationId xmlns:a16="http://schemas.microsoft.com/office/drawing/2014/main" id="{9DCE849E-F202-46B6-A31B-5B885AAC1677}"/>
+                <a16:creationId xmlns:a16="http://schemas.microsoft.com/office/drawing/2014/main" id="{5E521B38-5C55-48CE-A30C-8EA9610803BB}"/>
               </a:ext>
             </a:extLst>
           </p:cNvPr>
@@ -5235,24 +5063,24 @@
         <p:spPr>
           <a:xfrm xmlns:a="http://schemas.openxmlformats.org/drawingml/2006/main">
             <a:off x="609600" y="2038350"/>
-            <a:ext cx="10972800" cy="1790700"/>
-          </a:xfrm>
-          <a:prstGeom xmlns:a="http://schemas.openxmlformats.org/drawingml/2006/main" prst="rect">
-            <a:avLst/>
-          </a:prstGeom>
-          <a:noFill xmlns:a="http://schemas.openxmlformats.org/drawingml/2006/main"/>
-          <a:ln xmlns:a="http://schemas.openxmlformats.org/drawingml/2006/main" w="0">
-            <a:noFill/>
-          </a:ln>
-        </p:spPr>
-        <p:txBody>
-          <a:bodyPr xmlns:a="http://schemas.openxmlformats.org/drawingml/2006/main">
-            <a:noAutofit/>
-          </a:bodyPr>
-          <a:lstStyle xmlns:a="http://schemas.openxmlformats.org/drawingml/2006/main"/>
-          <a:p xmlns:a="http://schemas.openxmlformats.org/drawingml/2006/main">
-            <a:pPr algn="l">
-              <a:defRPr sz="3150" b="1" i="0">
+            <a:ext cx="5219700" cy="1790700"/>
+          </a:xfrm>
+          <a:prstGeom xmlns:a="http://schemas.openxmlformats.org/drawingml/2006/main" prst="rect">
+            <a:avLst/>
+          </a:prstGeom>
+          <a:noFill xmlns:a="http://schemas.openxmlformats.org/drawingml/2006/main"/>
+          <a:ln xmlns:a="http://schemas.openxmlformats.org/drawingml/2006/main" w="0">
+            <a:noFill/>
+          </a:ln>
+        </p:spPr>
+        <p:txBody>
+          <a:bodyPr xmlns:a="http://schemas.openxmlformats.org/drawingml/2006/main">
+            <a:noAutofit/>
+          </a:bodyPr>
+          <a:lstStyle xmlns:a="http://schemas.openxmlformats.org/drawingml/2006/main"/>
+          <a:p xmlns:a="http://schemas.openxmlformats.org/drawingml/2006/main">
+            <a:pPr algn="l">
+              <a:defRPr sz="2100" b="1" i="0">
                 <a:solidFill>
                   <a:srgbClr val="422D1A"/>
                 </a:solidFill>
@@ -5262,7 +5090,7 @@
               </a:defRPr>
             </a:pPr>
             <a:r>
-              <a:rPr sz="3150" b="1" i="0">
+              <a:rPr sz="2100" b="1" i="0">
                 <a:solidFill>
                   <a:srgbClr val="422D1A"/>
                 </a:solidFill>
@@ -5270,30 +5098,7 @@
                 <a:ea typeface="Arial"/>
                 <a:cs typeface="Arial"/>
               </a:rPr>
-              <a:t>[Câu hỏi mở đầu từ bài học]</a:t>
-            </a:r>
-          </a:p>
-          <a:p xmlns:a="http://schemas.openxmlformats.org/drawingml/2006/main">
-            <a:pPr algn="l">
-              <a:defRPr sz="3150" b="1" i="0">
-                <a:solidFill>
-                  <a:srgbClr val="422D1A"/>
-                </a:solidFill>
-                <a:latin typeface="Arial"/>
-                <a:ea typeface="Arial"/>
-                <a:cs typeface="Arial"/>
-              </a:defRPr>
-            </a:pPr>
-            <a:r>
-              <a:rPr sz="3150" b="1" i="0">
-                <a:solidFill>
-                  <a:srgbClr val="422D1A"/>
-                </a:solidFill>
-                <a:latin typeface="Arial"/>
-                <a:ea typeface="Arial"/>
-                <a:cs typeface="Arial"/>
-              </a:rPr>
-              <a:t>[Thông tin để học sinh quan sát]</a:t>
+              <a:t>2, 5, 8, 11… Số tiếp theo là gì?</a:t>
             </a:r>
           </a:p>
         </p:txBody>
@@ -5303,7 +5108,7 @@
           <p:cNvPr id="6" name="warmup-5">
             <a:extLst xmlns:a="http://schemas.openxmlformats.org/drawingml/2006/main">
               <a:ext uri="{FF2B5EF4-FFF2-40B4-BE49-F238E27FC236}">
-                <a16:creationId xmlns:a16="http://schemas.microsoft.com/office/drawing/2014/main" id="{BC83ECD5-81B7-4462-B658-25F0FAB6B341}"/>
+                <a16:creationId xmlns:a16="http://schemas.microsoft.com/office/drawing/2014/main" id="{3F9DA156-33E3-4D7D-93B0-AC842CE20F83}"/>
               </a:ext>
             </a:extLst>
           </p:cNvPr>
@@ -5315,24 +5120,24 @@
         <p:spPr>
           <a:xfrm xmlns:a="http://schemas.openxmlformats.org/drawingml/2006/main">
             <a:off x="609600" y="4152900"/>
-            <a:ext cx="10972800" cy="1790700"/>
-          </a:xfrm>
-          <a:prstGeom xmlns:a="http://schemas.openxmlformats.org/drawingml/2006/main" prst="rect">
-            <a:avLst/>
-          </a:prstGeom>
-          <a:noFill xmlns:a="http://schemas.openxmlformats.org/drawingml/2006/main"/>
-          <a:ln xmlns:a="http://schemas.openxmlformats.org/drawingml/2006/main" w="0">
-            <a:noFill/>
-          </a:ln>
-        </p:spPr>
-        <p:txBody>
-          <a:bodyPr xmlns:a="http://schemas.openxmlformats.org/drawingml/2006/main">
-            <a:noAutofit/>
-          </a:bodyPr>
-          <a:lstStyle xmlns:a="http://schemas.openxmlformats.org/drawingml/2006/main"/>
-          <a:p xmlns:a="http://schemas.openxmlformats.org/drawingml/2006/main">
-            <a:pPr algn="l">
-              <a:defRPr sz="3150" b="1" i="1">
+            <a:ext cx="5219700" cy="1790700"/>
+          </a:xfrm>
+          <a:prstGeom xmlns:a="http://schemas.openxmlformats.org/drawingml/2006/main" prst="rect">
+            <a:avLst/>
+          </a:prstGeom>
+          <a:noFill xmlns:a="http://schemas.openxmlformats.org/drawingml/2006/main"/>
+          <a:ln xmlns:a="http://schemas.openxmlformats.org/drawingml/2006/main" w="0">
+            <a:noFill/>
+          </a:ln>
+        </p:spPr>
+        <p:txBody>
+          <a:bodyPr xmlns:a="http://schemas.openxmlformats.org/drawingml/2006/main">
+            <a:noAutofit/>
+          </a:bodyPr>
+          <a:lstStyle xmlns:a="http://schemas.openxmlformats.org/drawingml/2006/main"/>
+          <a:p xmlns:a="http://schemas.openxmlformats.org/drawingml/2006/main">
+            <a:pPr algn="l">
+              <a:defRPr sz="2100" b="1" i="1">
                 <a:solidFill>
                   <a:srgbClr val="B85B14"/>
                 </a:solidFill>
@@ -5342,7 +5147,7 @@
               </a:defRPr>
             </a:pPr>
             <a:r>
-              <a:rPr sz="3150" b="1" i="1">
+              <a:rPr sz="2100" b="1" i="1">
                 <a:solidFill>
                   <a:srgbClr val="B85B14"/>
                 </a:solidFill>
@@ -5350,38 +5155,43 @@
                 <a:ea typeface="Arial"/>
                 <a:cs typeface="Arial"/>
               </a:rPr>
-              <a:t>[Opening question from the lesson]</a:t>
-            </a:r>
-          </a:p>
-          <a:p xmlns:a="http://schemas.openxmlformats.org/drawingml/2006/main">
-            <a:pPr algn="l">
-              <a:defRPr sz="3150" b="1" i="1">
-                <a:solidFill>
-                  <a:srgbClr val="B85B14"/>
-                </a:solidFill>
-                <a:latin typeface="Arial"/>
-                <a:ea typeface="Arial"/>
-                <a:cs typeface="Arial"/>
-              </a:defRPr>
-            </a:pPr>
-            <a:r>
-              <a:rPr sz="3150" b="1" i="1">
-                <a:solidFill>
-                  <a:srgbClr val="B85B14"/>
-                </a:solidFill>
-                <a:latin typeface="Arial"/>
-                <a:ea typeface="Arial"/>
-                <a:cs typeface="Arial"/>
-              </a:rPr>
-              <a:t>[Information for students to observe]</a:t>
-            </a:r>
-          </a:p>
-        </p:txBody>
-      </p:sp>
+              <a:t>2, 5, 8, 11… What comes next?</a:t>
+            </a:r>
+          </a:p>
+        </p:txBody>
+      </p:sp>
+      <p:pic>
+        <p:nvPicPr>
+          <p:cNvPr id="14" name=""/>
+          <p:cNvPicPr>
+            <a:picLocks xmlns:a="http://schemas.openxmlformats.org/drawingml/2006/main" noChangeAspect="1"/>
+          </p:cNvPicPr>
+          <p:nvPr/>
+        </p:nvPicPr>
+        <p:blipFill>
+          <a:blip xmlns:r="http://schemas.openxmlformats.org/officeDocument/2006/relationships" xmlns:a="http://schemas.openxmlformats.org/drawingml/2006/main" r:embed="R2b25c15dd7be4c57">
+            <a:extLst>
+              <a:ext uri="{96DAC541-7B7A-43D3-8B79-37D633B846F1}">
+                <asvg:svgBlip xmlns:asvg="http://schemas.microsoft.com/office/drawing/2016/SVG/main" r:embed="R5caa6a0f127e4866"/>
+              </a:ext>
+            </a:extLst>
+          </a:blip>
+          <a:stretch xmlns:a="http://schemas.openxmlformats.org/drawingml/2006/main"/>
+        </p:blipFill>
+        <p:spPr>
+          <a:xfrm xmlns:a="http://schemas.openxmlformats.org/drawingml/2006/main">
+            <a:off x="6629400" y="2038350"/>
+            <a:ext cx="4953000" cy="3905250"/>
+          </a:xfrm>
+          <a:prstGeom xmlns:a="http://schemas.openxmlformats.org/drawingml/2006/main" prst="rect">
+            <a:avLst/>
+          </a:prstGeom>
+        </p:spPr>
+      </p:pic>
     </p:spTree>
     <p:extLst>
       <p:ext uri="{BB962C8B-B14F-4D97-AF65-F5344CB8AC3E}">
-        <p14:creationId xmlns:p14="http://schemas.microsoft.com/office/powerpoint/2010/main" val="646968881"/>
+        <p14:creationId xmlns:p14="http://schemas.microsoft.com/office/powerpoint/2010/main" val="1761762588"/>
       </p:ext>
     </p:extLst>
   </p:cSld>
@@ -5409,10 +5219,10 @@
       </p:grpSpPr>
       <p:sp>
         <p:nvSpPr>
-          <p:cNvPr id="7" name="vocabulary-0">
-            <a:extLst xmlns:a="http://schemas.openxmlformats.org/drawingml/2006/main">
-              <a:ext uri="{FF2B5EF4-FFF2-40B4-BE49-F238E27FC236}">
-                <a16:creationId xmlns:a16="http://schemas.microsoft.com/office/drawing/2014/main" id="{DF1677CD-12CE-4ADE-B167-662E560EFAAD}"/>
+          <p:cNvPr id="8" name="vocabulary-0">
+            <a:extLst xmlns:a="http://schemas.openxmlformats.org/drawingml/2006/main">
+              <a:ext uri="{FF2B5EF4-FFF2-40B4-BE49-F238E27FC236}">
+                <a16:creationId xmlns:a16="http://schemas.microsoft.com/office/drawing/2014/main" id="{F7A10079-6C11-4B9B-98DB-E7AE1D487C97}"/>
               </a:ext>
             </a:extLst>
           </p:cNvPr>
@@ -5459,7 +5269,7 @@
                 <a:ea typeface="Arial"/>
                 <a:cs typeface="Arial"/>
               </a:rPr>
-              <a:t>BiliClass   /   Môn học của thầy cô   /   10–12</a:t>
+              <a:t>BiliClass   /   Toán · ví dụ minh họa   /   11</a:t>
             </a:r>
           </a:p>
         </p:txBody>
@@ -5469,7 +5279,7 @@
           <p:cNvPr id="2" name="vocabulary-1">
             <a:extLst xmlns:a="http://schemas.openxmlformats.org/drawingml/2006/main">
               <a:ext uri="{FF2B5EF4-FFF2-40B4-BE49-F238E27FC236}">
-                <a16:creationId xmlns:a16="http://schemas.microsoft.com/office/drawing/2014/main" id="{77E186D8-95D4-4C32-825B-7AB362565E0B}"/>
+                <a16:creationId xmlns:a16="http://schemas.microsoft.com/office/drawing/2014/main" id="{AF55E7CD-F3C3-4C42-8721-8E7B9D3D9D5E}"/>
               </a:ext>
             </a:extLst>
           </p:cNvPr>
@@ -5516,7 +5326,7 @@
                 <a:ea typeface="Arial"/>
                 <a:cs typeface="Arial"/>
               </a:rPr>
-              <a:t>Mẫu bài giảng song ngữ</a:t>
+              <a:t>Cấp số cộng</a:t>
             </a:r>
           </a:p>
         </p:txBody>
@@ -5526,7 +5336,7 @@
           <p:cNvPr id="3" name="vocabulary-2">
             <a:extLst xmlns:a="http://schemas.openxmlformats.org/drawingml/2006/main">
               <a:ext uri="{FF2B5EF4-FFF2-40B4-BE49-F238E27FC236}">
-                <a16:creationId xmlns:a16="http://schemas.microsoft.com/office/drawing/2014/main" id="{CD96132F-2615-48C7-B115-B6A5E73425E4}"/>
+                <a16:creationId xmlns:a16="http://schemas.microsoft.com/office/drawing/2014/main" id="{07572A38-BA81-4FAB-AA2B-53A63A971E56}"/>
               </a:ext>
             </a:extLst>
           </p:cNvPr>
@@ -5583,7 +5393,7 @@
           <p:cNvPr id="4" name="vocabulary-3">
             <a:extLst xmlns:a="http://schemas.openxmlformats.org/drawingml/2006/main">
               <a:ext uri="{FF2B5EF4-FFF2-40B4-BE49-F238E27FC236}">
-                <a16:creationId xmlns:a16="http://schemas.microsoft.com/office/drawing/2014/main" id="{CF5DF84B-11D3-4A78-BDE7-E5AA135B6D7B}"/>
+                <a16:creationId xmlns:a16="http://schemas.microsoft.com/office/drawing/2014/main" id="{5E161AB4-1922-4B99-86DA-A05AEBCCA8A3}"/>
               </a:ext>
             </a:extLst>
           </p:cNvPr>
@@ -5630,7 +5440,7 @@
                 <a:ea typeface="Arial"/>
                 <a:cs typeface="Arial"/>
               </a:rPr>
-              <a:t>Mẫu cấu trúc · Thay bằng nội dung bài học</a:t>
+              <a:t>Ví dụ để xem thiết kế · Bài của thầy cô dùng nội dung và hình từ nguồn</a:t>
             </a:r>
           </a:p>
         </p:txBody>
@@ -5640,7 +5450,7 @@
           <p:cNvPr id="5" name="vocabulary-4">
             <a:extLst xmlns:a="http://schemas.openxmlformats.org/drawingml/2006/main">
               <a:ext uri="{FF2B5EF4-FFF2-40B4-BE49-F238E27FC236}">
-                <a16:creationId xmlns:a16="http://schemas.microsoft.com/office/drawing/2014/main" id="{A5194CD1-AFC1-4CE7-8364-EF162E368FFB}"/>
+                <a16:creationId xmlns:a16="http://schemas.microsoft.com/office/drawing/2014/main" id="{8EAFC351-306B-4BBD-BEB1-A7B79745B408}"/>
               </a:ext>
             </a:extLst>
           </p:cNvPr>
@@ -5652,24 +5462,24 @@
         <p:spPr>
           <a:xfrm xmlns:a="http://schemas.openxmlformats.org/drawingml/2006/main">
             <a:off x="609600" y="2038350"/>
-            <a:ext cx="10972800" cy="1790700"/>
-          </a:xfrm>
-          <a:prstGeom xmlns:a="http://schemas.openxmlformats.org/drawingml/2006/main" prst="rect">
-            <a:avLst/>
-          </a:prstGeom>
-          <a:noFill xmlns:a="http://schemas.openxmlformats.org/drawingml/2006/main"/>
-          <a:ln xmlns:a="http://schemas.openxmlformats.org/drawingml/2006/main" w="0">
-            <a:noFill/>
-          </a:ln>
-        </p:spPr>
-        <p:txBody>
-          <a:bodyPr xmlns:a="http://schemas.openxmlformats.org/drawingml/2006/main">
-            <a:noAutofit/>
-          </a:bodyPr>
-          <a:lstStyle xmlns:a="http://schemas.openxmlformats.org/drawingml/2006/main"/>
-          <a:p xmlns:a="http://schemas.openxmlformats.org/drawingml/2006/main">
-            <a:pPr algn="l">
-              <a:defRPr sz="2550" b="0" i="0">
+            <a:ext cx="5219700" cy="1790700"/>
+          </a:xfrm>
+          <a:prstGeom xmlns:a="http://schemas.openxmlformats.org/drawingml/2006/main" prst="rect">
+            <a:avLst/>
+          </a:prstGeom>
+          <a:noFill xmlns:a="http://schemas.openxmlformats.org/drawingml/2006/main"/>
+          <a:ln xmlns:a="http://schemas.openxmlformats.org/drawingml/2006/main" w="0">
+            <a:noFill/>
+          </a:ln>
+        </p:spPr>
+        <p:txBody>
+          <a:bodyPr xmlns:a="http://schemas.openxmlformats.org/drawingml/2006/main">
+            <a:noAutofit/>
+          </a:bodyPr>
+          <a:lstStyle xmlns:a="http://schemas.openxmlformats.org/drawingml/2006/main"/>
+          <a:p xmlns:a="http://schemas.openxmlformats.org/drawingml/2006/main">
+            <a:pPr algn="l">
+              <a:defRPr sz="2100" b="0" i="0">
                 <a:solidFill>
                   <a:srgbClr val="422D1A"/>
                 </a:solidFill>
@@ -5679,7 +5489,7 @@
               </a:defRPr>
             </a:pPr>
             <a:r>
-              <a:rPr sz="2550" b="0" i="0">
+              <a:rPr sz="2100" b="0" i="0">
                 <a:solidFill>
                   <a:srgbClr val="422D1A"/>
                 </a:solidFill>
@@ -5687,53 +5497,7 @@
                 <a:ea typeface="Arial"/>
                 <a:cs typeface="Arial"/>
               </a:rPr>
-              <a:t>[Thuật ngữ thứ nhất]</a:t>
-            </a:r>
-          </a:p>
-          <a:p xmlns:a="http://schemas.openxmlformats.org/drawingml/2006/main">
-            <a:pPr algn="l">
-              <a:defRPr sz="2550" b="0" i="0">
-                <a:solidFill>
-                  <a:srgbClr val="422D1A"/>
-                </a:solidFill>
-                <a:latin typeface="Arial"/>
-                <a:ea typeface="Arial"/>
-                <a:cs typeface="Arial"/>
-              </a:defRPr>
-            </a:pPr>
-            <a:r>
-              <a:rPr sz="2550" b="0" i="0">
-                <a:solidFill>
-                  <a:srgbClr val="422D1A"/>
-                </a:solidFill>
-                <a:latin typeface="Arial"/>
-                <a:ea typeface="Arial"/>
-                <a:cs typeface="Arial"/>
-              </a:rPr>
-              <a:t>[Thuật ngữ thứ hai]</a:t>
-            </a:r>
-          </a:p>
-          <a:p xmlns:a="http://schemas.openxmlformats.org/drawingml/2006/main">
-            <a:pPr algn="l">
-              <a:defRPr sz="2550" b="0" i="0">
-                <a:solidFill>
-                  <a:srgbClr val="422D1A"/>
-                </a:solidFill>
-                <a:latin typeface="Arial"/>
-                <a:ea typeface="Arial"/>
-                <a:cs typeface="Arial"/>
-              </a:defRPr>
-            </a:pPr>
-            <a:r>
-              <a:rPr sz="2550" b="0" i="0">
-                <a:solidFill>
-                  <a:srgbClr val="422D1A"/>
-                </a:solidFill>
-                <a:latin typeface="Arial"/>
-                <a:ea typeface="Arial"/>
-                <a:cs typeface="Arial"/>
-              </a:rPr>
-              <a:t>[Thuật ngữ thứ ba]</a:t>
+              <a:t>Số hạng · Công sai</a:t>
             </a:r>
           </a:p>
         </p:txBody>
@@ -5743,7 +5507,7 @@
           <p:cNvPr id="6" name="vocabulary-5">
             <a:extLst xmlns:a="http://schemas.openxmlformats.org/drawingml/2006/main">
               <a:ext uri="{FF2B5EF4-FFF2-40B4-BE49-F238E27FC236}">
-                <a16:creationId xmlns:a16="http://schemas.microsoft.com/office/drawing/2014/main" id="{D207BACA-50D7-4A7E-A8F5-D96DD3EC8B5A}"/>
+                <a16:creationId xmlns:a16="http://schemas.microsoft.com/office/drawing/2014/main" id="{0AD86F06-7686-43B6-AE38-06615C9A8F58}"/>
               </a:ext>
             </a:extLst>
           </p:cNvPr>
@@ -5755,24 +5519,24 @@
         <p:spPr>
           <a:xfrm xmlns:a="http://schemas.openxmlformats.org/drawingml/2006/main">
             <a:off x="609600" y="4152900"/>
-            <a:ext cx="10972800" cy="1790700"/>
-          </a:xfrm>
-          <a:prstGeom xmlns:a="http://schemas.openxmlformats.org/drawingml/2006/main" prst="rect">
-            <a:avLst/>
-          </a:prstGeom>
-          <a:noFill xmlns:a="http://schemas.openxmlformats.org/drawingml/2006/main"/>
-          <a:ln xmlns:a="http://schemas.openxmlformats.org/drawingml/2006/main" w="0">
-            <a:noFill/>
-          </a:ln>
-        </p:spPr>
-        <p:txBody>
-          <a:bodyPr xmlns:a="http://schemas.openxmlformats.org/drawingml/2006/main">
-            <a:noAutofit/>
-          </a:bodyPr>
-          <a:lstStyle xmlns:a="http://schemas.openxmlformats.org/drawingml/2006/main"/>
-          <a:p xmlns:a="http://schemas.openxmlformats.org/drawingml/2006/main">
-            <a:pPr algn="l">
-              <a:defRPr sz="2550" b="0" i="1">
+            <a:ext cx="5219700" cy="1790700"/>
+          </a:xfrm>
+          <a:prstGeom xmlns:a="http://schemas.openxmlformats.org/drawingml/2006/main" prst="rect">
+            <a:avLst/>
+          </a:prstGeom>
+          <a:noFill xmlns:a="http://schemas.openxmlformats.org/drawingml/2006/main"/>
+          <a:ln xmlns:a="http://schemas.openxmlformats.org/drawingml/2006/main" w="0">
+            <a:noFill/>
+          </a:ln>
+        </p:spPr>
+        <p:txBody>
+          <a:bodyPr xmlns:a="http://schemas.openxmlformats.org/drawingml/2006/main">
+            <a:noAutofit/>
+          </a:bodyPr>
+          <a:lstStyle xmlns:a="http://schemas.openxmlformats.org/drawingml/2006/main"/>
+          <a:p xmlns:a="http://schemas.openxmlformats.org/drawingml/2006/main">
+            <a:pPr algn="l">
+              <a:defRPr sz="2100" b="0" i="1">
                 <a:solidFill>
                   <a:srgbClr val="B85B14"/>
                 </a:solidFill>
@@ -5782,7 +5546,7 @@
               </a:defRPr>
             </a:pPr>
             <a:r>
-              <a:rPr sz="2550" b="0" i="1">
+              <a:rPr sz="2100" b="0" i="1">
                 <a:solidFill>
                   <a:srgbClr val="B85B14"/>
                 </a:solidFill>
@@ -5790,61 +5554,43 @@
                 <a:ea typeface="Arial"/>
                 <a:cs typeface="Arial"/>
               </a:rPr>
-              <a:t>[First term]</a:t>
-            </a:r>
-          </a:p>
-          <a:p xmlns:a="http://schemas.openxmlformats.org/drawingml/2006/main">
-            <a:pPr algn="l">
-              <a:defRPr sz="2550" b="0" i="1">
-                <a:solidFill>
-                  <a:srgbClr val="B85B14"/>
-                </a:solidFill>
-                <a:latin typeface="Arial"/>
-                <a:ea typeface="Arial"/>
-                <a:cs typeface="Arial"/>
-              </a:defRPr>
-            </a:pPr>
-            <a:r>
-              <a:rPr sz="2550" b="0" i="1">
-                <a:solidFill>
-                  <a:srgbClr val="B85B14"/>
-                </a:solidFill>
-                <a:latin typeface="Arial"/>
-                <a:ea typeface="Arial"/>
-                <a:cs typeface="Arial"/>
-              </a:rPr>
-              <a:t>[Second term]</a:t>
-            </a:r>
-          </a:p>
-          <a:p xmlns:a="http://schemas.openxmlformats.org/drawingml/2006/main">
-            <a:pPr algn="l">
-              <a:defRPr sz="2550" b="0" i="1">
-                <a:solidFill>
-                  <a:srgbClr val="B85B14"/>
-                </a:solidFill>
-                <a:latin typeface="Arial"/>
-                <a:ea typeface="Arial"/>
-                <a:cs typeface="Arial"/>
-              </a:defRPr>
-            </a:pPr>
-            <a:r>
-              <a:rPr sz="2550" b="0" i="1">
-                <a:solidFill>
-                  <a:srgbClr val="B85B14"/>
-                </a:solidFill>
-                <a:latin typeface="Arial"/>
-                <a:ea typeface="Arial"/>
-                <a:cs typeface="Arial"/>
-              </a:rPr>
-              <a:t>[Third term]</a:t>
-            </a:r>
-          </a:p>
-        </p:txBody>
-      </p:sp>
+              <a:t>Term · Common difference</a:t>
+            </a:r>
+          </a:p>
+        </p:txBody>
+      </p:sp>
+      <p:pic>
+        <p:nvPicPr>
+          <p:cNvPr id="14" name=""/>
+          <p:cNvPicPr>
+            <a:picLocks xmlns:a="http://schemas.openxmlformats.org/drawingml/2006/main" noChangeAspect="1"/>
+          </p:cNvPicPr>
+          <p:nvPr/>
+        </p:nvPicPr>
+        <p:blipFill>
+          <a:blip xmlns:r="http://schemas.openxmlformats.org/officeDocument/2006/relationships" xmlns:a="http://schemas.openxmlformats.org/drawingml/2006/main" r:embed="R145305cbede54b47">
+            <a:extLst>
+              <a:ext uri="{96DAC541-7B7A-43D3-8B79-37D633B846F1}">
+                <asvg:svgBlip xmlns:asvg="http://schemas.microsoft.com/office/drawing/2016/SVG/main" r:embed="Ra0cd15739ee846d6"/>
+              </a:ext>
+            </a:extLst>
+          </a:blip>
+          <a:stretch xmlns:a="http://schemas.openxmlformats.org/drawingml/2006/main"/>
+        </p:blipFill>
+        <p:spPr>
+          <a:xfrm xmlns:a="http://schemas.openxmlformats.org/drawingml/2006/main">
+            <a:off x="6629400" y="2038350"/>
+            <a:ext cx="4953000" cy="3905250"/>
+          </a:xfrm>
+          <a:prstGeom xmlns:a="http://schemas.openxmlformats.org/drawingml/2006/main" prst="rect">
+            <a:avLst/>
+          </a:prstGeom>
+        </p:spPr>
+      </p:pic>
     </p:spTree>
     <p:extLst>
       <p:ext uri="{BB962C8B-B14F-4D97-AF65-F5344CB8AC3E}">
-        <p14:creationId xmlns:p14="http://schemas.microsoft.com/office/powerpoint/2010/main" val="1520274699"/>
+        <p14:creationId xmlns:p14="http://schemas.microsoft.com/office/powerpoint/2010/main" val="891247917"/>
       </p:ext>
     </p:extLst>
   </p:cSld>
@@ -5872,10 +5618,10 @@
       </p:grpSpPr>
       <p:sp>
         <p:nvSpPr>
-          <p:cNvPr id="7" name="concept-0">
-            <a:extLst xmlns:a="http://schemas.openxmlformats.org/drawingml/2006/main">
-              <a:ext uri="{FF2B5EF4-FFF2-40B4-BE49-F238E27FC236}">
-                <a16:creationId xmlns:a16="http://schemas.microsoft.com/office/drawing/2014/main" id="{2B95D320-930D-4DDA-AF1E-4DB18F762E10}"/>
+          <p:cNvPr id="8" name="concept-0">
+            <a:extLst xmlns:a="http://schemas.openxmlformats.org/drawingml/2006/main">
+              <a:ext uri="{FF2B5EF4-FFF2-40B4-BE49-F238E27FC236}">
+                <a16:creationId xmlns:a16="http://schemas.microsoft.com/office/drawing/2014/main" id="{829369E8-3D39-43DE-9E1D-0903CFF47A07}"/>
               </a:ext>
             </a:extLst>
           </p:cNvPr>
@@ -5922,7 +5668,7 @@
                 <a:ea typeface="Arial"/>
                 <a:cs typeface="Arial"/>
               </a:rPr>
-              <a:t>BiliClass   /   Môn học của thầy cô   /   10–12</a:t>
+              <a:t>BiliClass   /   Toán · ví dụ minh họa   /   11</a:t>
             </a:r>
           </a:p>
         </p:txBody>
@@ -5932,7 +5678,7 @@
           <p:cNvPr id="2" name="concept-1">
             <a:extLst xmlns:a="http://schemas.openxmlformats.org/drawingml/2006/main">
               <a:ext uri="{FF2B5EF4-FFF2-40B4-BE49-F238E27FC236}">
-                <a16:creationId xmlns:a16="http://schemas.microsoft.com/office/drawing/2014/main" id="{D5FA9477-B1B0-4732-868A-783074D9F15E}"/>
+                <a16:creationId xmlns:a16="http://schemas.microsoft.com/office/drawing/2014/main" id="{AEEAC693-DEB6-4556-B608-D469810AF774}"/>
               </a:ext>
             </a:extLst>
           </p:cNvPr>
@@ -5979,7 +5725,7 @@
                 <a:ea typeface="Arial"/>
                 <a:cs typeface="Arial"/>
               </a:rPr>
-              <a:t>Mẫu bài giảng song ngữ</a:t>
+              <a:t>Cấp số cộng</a:t>
             </a:r>
           </a:p>
         </p:txBody>
@@ -5989,7 +5735,7 @@
           <p:cNvPr id="3" name="concept-2">
             <a:extLst xmlns:a="http://schemas.openxmlformats.org/drawingml/2006/main">
               <a:ext uri="{FF2B5EF4-FFF2-40B4-BE49-F238E27FC236}">
-                <a16:creationId xmlns:a16="http://schemas.microsoft.com/office/drawing/2014/main" id="{BBB3C6D4-723E-49D3-9B21-B0FE644A3446}"/>
+                <a16:creationId xmlns:a16="http://schemas.microsoft.com/office/drawing/2014/main" id="{D55535BB-C274-440F-964E-3674AC134F89}"/>
               </a:ext>
             </a:extLst>
           </p:cNvPr>
@@ -6046,7 +5792,7 @@
           <p:cNvPr id="4" name="concept-3">
             <a:extLst xmlns:a="http://schemas.openxmlformats.org/drawingml/2006/main">
               <a:ext uri="{FF2B5EF4-FFF2-40B4-BE49-F238E27FC236}">
-                <a16:creationId xmlns:a16="http://schemas.microsoft.com/office/drawing/2014/main" id="{F1C8EA6C-D4C4-4279-8C1E-ECFDFD722B8C}"/>
+                <a16:creationId xmlns:a16="http://schemas.microsoft.com/office/drawing/2014/main" id="{CE4C6CD6-F9E0-4EBF-AC31-62FD0157BB9C}"/>
               </a:ext>
             </a:extLst>
           </p:cNvPr>
@@ -6093,7 +5839,7 @@
                 <a:ea typeface="Arial"/>
                 <a:cs typeface="Arial"/>
               </a:rPr>
-              <a:t>Mẫu cấu trúc · Thay bằng nội dung bài học</a:t>
+              <a:t>Ví dụ để xem thiết kế · Bài của thầy cô dùng nội dung và hình từ nguồn</a:t>
             </a:r>
           </a:p>
         </p:txBody>
@@ -6103,7 +5849,7 @@
           <p:cNvPr id="5" name="concept-4">
             <a:extLst xmlns:a="http://schemas.openxmlformats.org/drawingml/2006/main">
               <a:ext uri="{FF2B5EF4-FFF2-40B4-BE49-F238E27FC236}">
-                <a16:creationId xmlns:a16="http://schemas.microsoft.com/office/drawing/2014/main" id="{998A5596-5733-4C74-918B-A4E50C8BFF21}"/>
+                <a16:creationId xmlns:a16="http://schemas.microsoft.com/office/drawing/2014/main" id="{CEBDC2CE-7EBF-429C-AB76-6DC54505F8F2}"/>
               </a:ext>
             </a:extLst>
           </p:cNvPr>
@@ -6115,24 +5861,24 @@
         <p:spPr>
           <a:xfrm xmlns:a="http://schemas.openxmlformats.org/drawingml/2006/main">
             <a:off x="609600" y="2038350"/>
-            <a:ext cx="10972800" cy="1790700"/>
-          </a:xfrm>
-          <a:prstGeom xmlns:a="http://schemas.openxmlformats.org/drawingml/2006/main" prst="rect">
-            <a:avLst/>
-          </a:prstGeom>
-          <a:noFill xmlns:a="http://schemas.openxmlformats.org/drawingml/2006/main"/>
-          <a:ln xmlns:a="http://schemas.openxmlformats.org/drawingml/2006/main" w="0">
-            <a:noFill/>
-          </a:ln>
-        </p:spPr>
-        <p:txBody>
-          <a:bodyPr xmlns:a="http://schemas.openxmlformats.org/drawingml/2006/main">
-            <a:noAutofit/>
-          </a:bodyPr>
-          <a:lstStyle xmlns:a="http://schemas.openxmlformats.org/drawingml/2006/main"/>
-          <a:p xmlns:a="http://schemas.openxmlformats.org/drawingml/2006/main">
-            <a:pPr algn="l">
-              <a:defRPr sz="2550" b="0" i="0">
+            <a:ext cx="5219700" cy="1790700"/>
+          </a:xfrm>
+          <a:prstGeom xmlns:a="http://schemas.openxmlformats.org/drawingml/2006/main" prst="rect">
+            <a:avLst/>
+          </a:prstGeom>
+          <a:noFill xmlns:a="http://schemas.openxmlformats.org/drawingml/2006/main"/>
+          <a:ln xmlns:a="http://schemas.openxmlformats.org/drawingml/2006/main" w="0">
+            <a:noFill/>
+          </a:ln>
+        </p:spPr>
+        <p:txBody>
+          <a:bodyPr xmlns:a="http://schemas.openxmlformats.org/drawingml/2006/main">
+            <a:noAutofit/>
+          </a:bodyPr>
+          <a:lstStyle xmlns:a="http://schemas.openxmlformats.org/drawingml/2006/main"/>
+          <a:p xmlns:a="http://schemas.openxmlformats.org/drawingml/2006/main">
+            <a:pPr algn="l">
+              <a:defRPr sz="2100" b="0" i="0">
                 <a:solidFill>
                   <a:srgbClr val="422D1A"/>
                 </a:solidFill>
@@ -6142,7 +5888,7 @@
               </a:defRPr>
             </a:pPr>
             <a:r>
-              <a:rPr sz="2550" b="0" i="0">
+              <a:rPr sz="2100" b="0" i="0">
                 <a:solidFill>
                   <a:srgbClr val="422D1A"/>
                 </a:solidFill>
@@ -6150,30 +5896,7 @@
                 <a:ea typeface="Arial"/>
                 <a:cs typeface="Arial"/>
               </a:rPr>
-              <a:t>[Tên khái niệm]</a:t>
-            </a:r>
-          </a:p>
-          <a:p xmlns:a="http://schemas.openxmlformats.org/drawingml/2006/main">
-            <a:pPr algn="l">
-              <a:defRPr sz="2550" b="0" i="0">
-                <a:solidFill>
-                  <a:srgbClr val="422D1A"/>
-                </a:solidFill>
-                <a:latin typeface="Arial"/>
-                <a:ea typeface="Arial"/>
-                <a:cs typeface="Arial"/>
-              </a:defRPr>
-            </a:pPr>
-            <a:r>
-              <a:rPr sz="2550" b="0" i="0">
-                <a:solidFill>
-                  <a:srgbClr val="422D1A"/>
-                </a:solidFill>
-                <a:latin typeface="Arial"/>
-                <a:ea typeface="Arial"/>
-                <a:cs typeface="Arial"/>
-              </a:rPr>
-              <a:t>[Định nghĩa lấy từ tài liệu đã kiểm tra]</a:t>
+              <a:t>Hai số hạng liên tiếp hơn kém nhau d.</a:t>
             </a:r>
           </a:p>
         </p:txBody>
@@ -6183,7 +5906,7 @@
           <p:cNvPr id="6" name="concept-5">
             <a:extLst xmlns:a="http://schemas.openxmlformats.org/drawingml/2006/main">
               <a:ext uri="{FF2B5EF4-FFF2-40B4-BE49-F238E27FC236}">
-                <a16:creationId xmlns:a16="http://schemas.microsoft.com/office/drawing/2014/main" id="{4410D66B-2B98-4ABE-9D29-EE530D23B818}"/>
+                <a16:creationId xmlns:a16="http://schemas.microsoft.com/office/drawing/2014/main" id="{1BEEE71A-D5FE-4279-B664-8CA379B23C6D}"/>
               </a:ext>
             </a:extLst>
           </p:cNvPr>
@@ -6195,24 +5918,24 @@
         <p:spPr>
           <a:xfrm xmlns:a="http://schemas.openxmlformats.org/drawingml/2006/main">
             <a:off x="609600" y="4152900"/>
-            <a:ext cx="10972800" cy="1790700"/>
-          </a:xfrm>
-          <a:prstGeom xmlns:a="http://schemas.openxmlformats.org/drawingml/2006/main" prst="rect">
-            <a:avLst/>
-          </a:prstGeom>
-          <a:noFill xmlns:a="http://schemas.openxmlformats.org/drawingml/2006/main"/>
-          <a:ln xmlns:a="http://schemas.openxmlformats.org/drawingml/2006/main" w="0">
-            <a:noFill/>
-          </a:ln>
-        </p:spPr>
-        <p:txBody>
-          <a:bodyPr xmlns:a="http://schemas.openxmlformats.org/drawingml/2006/main">
-            <a:noAutofit/>
-          </a:bodyPr>
-          <a:lstStyle xmlns:a="http://schemas.openxmlformats.org/drawingml/2006/main"/>
-          <a:p xmlns:a="http://schemas.openxmlformats.org/drawingml/2006/main">
-            <a:pPr algn="l">
-              <a:defRPr sz="2550" b="0" i="1">
+            <a:ext cx="5219700" cy="1790700"/>
+          </a:xfrm>
+          <a:prstGeom xmlns:a="http://schemas.openxmlformats.org/drawingml/2006/main" prst="rect">
+            <a:avLst/>
+          </a:prstGeom>
+          <a:noFill xmlns:a="http://schemas.openxmlformats.org/drawingml/2006/main"/>
+          <a:ln xmlns:a="http://schemas.openxmlformats.org/drawingml/2006/main" w="0">
+            <a:noFill/>
+          </a:ln>
+        </p:spPr>
+        <p:txBody>
+          <a:bodyPr xmlns:a="http://schemas.openxmlformats.org/drawingml/2006/main">
+            <a:noAutofit/>
+          </a:bodyPr>
+          <a:lstStyle xmlns:a="http://schemas.openxmlformats.org/drawingml/2006/main"/>
+          <a:p xmlns:a="http://schemas.openxmlformats.org/drawingml/2006/main">
+            <a:pPr algn="l">
+              <a:defRPr sz="2100" b="0" i="1">
                 <a:solidFill>
                   <a:srgbClr val="B85B14"/>
                 </a:solidFill>
@@ -6222,7 +5945,7 @@
               </a:defRPr>
             </a:pPr>
             <a:r>
-              <a:rPr sz="2550" b="0" i="1">
+              <a:rPr sz="2100" b="0" i="1">
                 <a:solidFill>
                   <a:srgbClr val="B85B14"/>
                 </a:solidFill>
@@ -6230,38 +5953,43 @@
                 <a:ea typeface="Arial"/>
                 <a:cs typeface="Arial"/>
               </a:rPr>
-              <a:t>[Concept name]</a:t>
-            </a:r>
-          </a:p>
-          <a:p xmlns:a="http://schemas.openxmlformats.org/drawingml/2006/main">
-            <a:pPr algn="l">
-              <a:defRPr sz="2550" b="0" i="1">
-                <a:solidFill>
-                  <a:srgbClr val="B85B14"/>
-                </a:solidFill>
-                <a:latin typeface="Arial"/>
-                <a:ea typeface="Arial"/>
-                <a:cs typeface="Arial"/>
-              </a:defRPr>
-            </a:pPr>
-            <a:r>
-              <a:rPr sz="2550" b="0" i="1">
-                <a:solidFill>
-                  <a:srgbClr val="B85B14"/>
-                </a:solidFill>
-                <a:latin typeface="Arial"/>
-                <a:ea typeface="Arial"/>
-                <a:cs typeface="Arial"/>
-              </a:rPr>
-              <a:t>[Definition from the checked source]</a:t>
-            </a:r>
-          </a:p>
-        </p:txBody>
-      </p:sp>
+              <a:t>Consecutive terms differ by d.</a:t>
+            </a:r>
+          </a:p>
+        </p:txBody>
+      </p:sp>
+      <p:pic>
+        <p:nvPicPr>
+          <p:cNvPr id="14" name=""/>
+          <p:cNvPicPr>
+            <a:picLocks xmlns:a="http://schemas.openxmlformats.org/drawingml/2006/main" noChangeAspect="1"/>
+          </p:cNvPicPr>
+          <p:nvPr/>
+        </p:nvPicPr>
+        <p:blipFill>
+          <a:blip xmlns:r="http://schemas.openxmlformats.org/officeDocument/2006/relationships" xmlns:a="http://schemas.openxmlformats.org/drawingml/2006/main" r:embed="Rf362bbc33a2a4fb4">
+            <a:extLst>
+              <a:ext uri="{96DAC541-7B7A-43D3-8B79-37D633B846F1}">
+                <asvg:svgBlip xmlns:asvg="http://schemas.microsoft.com/office/drawing/2016/SVG/main" r:embed="R1928322729444250"/>
+              </a:ext>
+            </a:extLst>
+          </a:blip>
+          <a:stretch xmlns:a="http://schemas.openxmlformats.org/drawingml/2006/main"/>
+        </p:blipFill>
+        <p:spPr>
+          <a:xfrm xmlns:a="http://schemas.openxmlformats.org/drawingml/2006/main">
+            <a:off x="6629400" y="2038350"/>
+            <a:ext cx="4953000" cy="3905250"/>
+          </a:xfrm>
+          <a:prstGeom xmlns:a="http://schemas.openxmlformats.org/drawingml/2006/main" prst="rect">
+            <a:avLst/>
+          </a:prstGeom>
+        </p:spPr>
+      </p:pic>
     </p:spTree>
     <p:extLst>
       <p:ext uri="{BB962C8B-B14F-4D97-AF65-F5344CB8AC3E}">
-        <p14:creationId xmlns:p14="http://schemas.microsoft.com/office/powerpoint/2010/main" val="979309964"/>
+        <p14:creationId xmlns:p14="http://schemas.microsoft.com/office/powerpoint/2010/main" val="12716217"/>
       </p:ext>
     </p:extLst>
   </p:cSld>
@@ -6289,10 +6017,10 @@
       </p:grpSpPr>
       <p:sp>
         <p:nvSpPr>
-          <p:cNvPr id="7" name="explanation-0">
-            <a:extLst xmlns:a="http://schemas.openxmlformats.org/drawingml/2006/main">
-              <a:ext uri="{FF2B5EF4-FFF2-40B4-BE49-F238E27FC236}">
-                <a16:creationId xmlns:a16="http://schemas.microsoft.com/office/drawing/2014/main" id="{57EB9083-62F1-441D-B48C-4E313C82ECFB}"/>
+          <p:cNvPr id="8" name="explanation-0">
+            <a:extLst xmlns:a="http://schemas.openxmlformats.org/drawingml/2006/main">
+              <a:ext uri="{FF2B5EF4-FFF2-40B4-BE49-F238E27FC236}">
+                <a16:creationId xmlns:a16="http://schemas.microsoft.com/office/drawing/2014/main" id="{7E25F3B7-FBD5-4041-8DC0-C4A45326058A}"/>
               </a:ext>
             </a:extLst>
           </p:cNvPr>
@@ -6339,7 +6067,7 @@
                 <a:ea typeface="Arial"/>
                 <a:cs typeface="Arial"/>
               </a:rPr>
-              <a:t>BiliClass   /   Môn học của thầy cô   /   10–12</a:t>
+              <a:t>BiliClass   /   Toán · ví dụ minh họa   /   11</a:t>
             </a:r>
           </a:p>
         </p:txBody>
@@ -6349,7 +6077,7 @@
           <p:cNvPr id="2" name="explanation-1">
             <a:extLst xmlns:a="http://schemas.openxmlformats.org/drawingml/2006/main">
               <a:ext uri="{FF2B5EF4-FFF2-40B4-BE49-F238E27FC236}">
-                <a16:creationId xmlns:a16="http://schemas.microsoft.com/office/drawing/2014/main" id="{84043A1C-8DBB-4921-900A-3D545784BD84}"/>
+                <a16:creationId xmlns:a16="http://schemas.microsoft.com/office/drawing/2014/main" id="{226726BD-BD33-4EC4-BD44-7912470CA4B7}"/>
               </a:ext>
             </a:extLst>
           </p:cNvPr>
@@ -6396,7 +6124,7 @@
                 <a:ea typeface="Arial"/>
                 <a:cs typeface="Arial"/>
               </a:rPr>
-              <a:t>Mẫu bài giảng song ngữ</a:t>
+              <a:t>Cấp số cộng</a:t>
             </a:r>
           </a:p>
         </p:txBody>
@@ -6406,7 +6134,7 @@
           <p:cNvPr id="3" name="explanation-2">
             <a:extLst xmlns:a="http://schemas.openxmlformats.org/drawingml/2006/main">
               <a:ext uri="{FF2B5EF4-FFF2-40B4-BE49-F238E27FC236}">
-                <a16:creationId xmlns:a16="http://schemas.microsoft.com/office/drawing/2014/main" id="{35DAAEA9-3BE1-4FDE-A563-2CAF454D1267}"/>
+                <a16:creationId xmlns:a16="http://schemas.microsoft.com/office/drawing/2014/main" id="{015976B6-254D-4623-9418-C9639EEF1E8C}"/>
               </a:ext>
             </a:extLst>
           </p:cNvPr>
@@ -6463,7 +6191,7 @@
           <p:cNvPr id="4" name="explanation-3">
             <a:extLst xmlns:a="http://schemas.openxmlformats.org/drawingml/2006/main">
               <a:ext uri="{FF2B5EF4-FFF2-40B4-BE49-F238E27FC236}">
-                <a16:creationId xmlns:a16="http://schemas.microsoft.com/office/drawing/2014/main" id="{0F32BCD4-EBE2-43C7-B32E-559639563D9E}"/>
+                <a16:creationId xmlns:a16="http://schemas.microsoft.com/office/drawing/2014/main" id="{1B01A45F-91A2-47D0-89BB-C62D27A101F8}"/>
               </a:ext>
             </a:extLst>
           </p:cNvPr>
@@ -6510,7 +6238,7 @@
                 <a:ea typeface="Arial"/>
                 <a:cs typeface="Arial"/>
               </a:rPr>
-              <a:t>Mẫu cấu trúc · Thay bằng nội dung bài học</a:t>
+              <a:t>Ví dụ để xem thiết kế · Bài của thầy cô dùng nội dung và hình từ nguồn</a:t>
             </a:r>
           </a:p>
         </p:txBody>
@@ -6520,7 +6248,7 @@
           <p:cNvPr id="5" name="explanation-4">
             <a:extLst xmlns:a="http://schemas.openxmlformats.org/drawingml/2006/main">
               <a:ext uri="{FF2B5EF4-FFF2-40B4-BE49-F238E27FC236}">
-                <a16:creationId xmlns:a16="http://schemas.microsoft.com/office/drawing/2014/main" id="{CC3361B6-7C59-4CAB-8168-4019945E6E7E}"/>
+                <a16:creationId xmlns:a16="http://schemas.microsoft.com/office/drawing/2014/main" id="{AB6CBF36-39A4-4A02-83D8-CD187EB64E13}"/>
               </a:ext>
             </a:extLst>
           </p:cNvPr>
@@ -6532,24 +6260,24 @@
         <p:spPr>
           <a:xfrm xmlns:a="http://schemas.openxmlformats.org/drawingml/2006/main">
             <a:off x="609600" y="2038350"/>
-            <a:ext cx="10972800" cy="1790700"/>
-          </a:xfrm>
-          <a:prstGeom xmlns:a="http://schemas.openxmlformats.org/drawingml/2006/main" prst="rect">
-            <a:avLst/>
-          </a:prstGeom>
-          <a:noFill xmlns:a="http://schemas.openxmlformats.org/drawingml/2006/main"/>
-          <a:ln xmlns:a="http://schemas.openxmlformats.org/drawingml/2006/main" w="0">
-            <a:noFill/>
-          </a:ln>
-        </p:spPr>
-        <p:txBody>
-          <a:bodyPr xmlns:a="http://schemas.openxmlformats.org/drawingml/2006/main">
-            <a:noAutofit/>
-          </a:bodyPr>
-          <a:lstStyle xmlns:a="http://schemas.openxmlformats.org/drawingml/2006/main"/>
-          <a:p xmlns:a="http://schemas.openxmlformats.org/drawingml/2006/main">
-            <a:pPr algn="l">
-              <a:defRPr sz="2400" b="0" i="0">
+            <a:ext cx="5219700" cy="1790700"/>
+          </a:xfrm>
+          <a:prstGeom xmlns:a="http://schemas.openxmlformats.org/drawingml/2006/main" prst="rect">
+            <a:avLst/>
+          </a:prstGeom>
+          <a:noFill xmlns:a="http://schemas.openxmlformats.org/drawingml/2006/main"/>
+          <a:ln xmlns:a="http://schemas.openxmlformats.org/drawingml/2006/main" w="0">
+            <a:noFill/>
+          </a:ln>
+        </p:spPr>
+        <p:txBody>
+          <a:bodyPr xmlns:a="http://schemas.openxmlformats.org/drawingml/2006/main">
+            <a:noAutofit/>
+          </a:bodyPr>
+          <a:lstStyle xmlns:a="http://schemas.openxmlformats.org/drawingml/2006/main"/>
+          <a:p xmlns:a="http://schemas.openxmlformats.org/drawingml/2006/main">
+            <a:pPr algn="l">
+              <a:defRPr sz="2100" b="0" i="0">
                 <a:solidFill>
                   <a:srgbClr val="422D1A"/>
                 </a:solidFill>
@@ -6559,7 +6287,7 @@
               </a:defRPr>
             </a:pPr>
             <a:r>
-              <a:rPr sz="2400" b="0" i="0">
+              <a:rPr sz="2100" b="0" i="0">
                 <a:solidFill>
                   <a:srgbClr val="422D1A"/>
                 </a:solidFill>
@@ -6567,30 +6295,7 @@
                 <a:ea typeface="Arial"/>
                 <a:cs typeface="Arial"/>
               </a:rPr>
-              <a:t>[Ý chính cần giải thích]</a:t>
-            </a:r>
-          </a:p>
-          <a:p xmlns:a="http://schemas.openxmlformats.org/drawingml/2006/main">
-            <a:pPr algn="l">
-              <a:defRPr sz="2400" b="0" i="0">
-                <a:solidFill>
-                  <a:srgbClr val="422D1A"/>
-                </a:solidFill>
-                <a:latin typeface="Arial"/>
-                <a:ea typeface="Arial"/>
-                <a:cs typeface="Arial"/>
-              </a:defRPr>
-            </a:pPr>
-            <a:r>
-              <a:rPr sz="2400" b="0" i="0">
-                <a:solidFill>
-                  <a:srgbClr val="422D1A"/>
-                </a:solidFill>
-                <a:latin typeface="Arial"/>
-                <a:ea typeface="Arial"/>
-                <a:cs typeface="Arial"/>
-              </a:rPr>
-              <a:t>[Mối liên hệ trong nội dung bài học]</a:t>
+              <a:t>Mỗi bước trong hình cộng thêm 3.</a:t>
             </a:r>
           </a:p>
         </p:txBody>
@@ -6600,7 +6305,7 @@
           <p:cNvPr id="6" name="explanation-5">
             <a:extLst xmlns:a="http://schemas.openxmlformats.org/drawingml/2006/main">
               <a:ext uri="{FF2B5EF4-FFF2-40B4-BE49-F238E27FC236}">
-                <a16:creationId xmlns:a16="http://schemas.microsoft.com/office/drawing/2014/main" id="{BF04B58D-2446-4BF5-9161-E766E407DBFF}"/>
+                <a16:creationId xmlns:a16="http://schemas.microsoft.com/office/drawing/2014/main" id="{F4427A4E-1942-44F7-B4D8-C7777B38BE3B}"/>
               </a:ext>
             </a:extLst>
           </p:cNvPr>
@@ -6612,24 +6317,24 @@
         <p:spPr>
           <a:xfrm xmlns:a="http://schemas.openxmlformats.org/drawingml/2006/main">
             <a:off x="609600" y="4152900"/>
-            <a:ext cx="10972800" cy="1790700"/>
-          </a:xfrm>
-          <a:prstGeom xmlns:a="http://schemas.openxmlformats.org/drawingml/2006/main" prst="rect">
-            <a:avLst/>
-          </a:prstGeom>
-          <a:noFill xmlns:a="http://schemas.openxmlformats.org/drawingml/2006/main"/>
-          <a:ln xmlns:a="http://schemas.openxmlformats.org/drawingml/2006/main" w="0">
-            <a:noFill/>
-          </a:ln>
-        </p:spPr>
-        <p:txBody>
-          <a:bodyPr xmlns:a="http://schemas.openxmlformats.org/drawingml/2006/main">
-            <a:noAutofit/>
-          </a:bodyPr>
-          <a:lstStyle xmlns:a="http://schemas.openxmlformats.org/drawingml/2006/main"/>
-          <a:p xmlns:a="http://schemas.openxmlformats.org/drawingml/2006/main">
-            <a:pPr algn="l">
-              <a:defRPr sz="2400" b="0" i="1">
+            <a:ext cx="5219700" cy="1790700"/>
+          </a:xfrm>
+          <a:prstGeom xmlns:a="http://schemas.openxmlformats.org/drawingml/2006/main" prst="rect">
+            <a:avLst/>
+          </a:prstGeom>
+          <a:noFill xmlns:a="http://schemas.openxmlformats.org/drawingml/2006/main"/>
+          <a:ln xmlns:a="http://schemas.openxmlformats.org/drawingml/2006/main" w="0">
+            <a:noFill/>
+          </a:ln>
+        </p:spPr>
+        <p:txBody>
+          <a:bodyPr xmlns:a="http://schemas.openxmlformats.org/drawingml/2006/main">
+            <a:noAutofit/>
+          </a:bodyPr>
+          <a:lstStyle xmlns:a="http://schemas.openxmlformats.org/drawingml/2006/main"/>
+          <a:p xmlns:a="http://schemas.openxmlformats.org/drawingml/2006/main">
+            <a:pPr algn="l">
+              <a:defRPr sz="2100" b="0" i="1">
                 <a:solidFill>
                   <a:srgbClr val="B85B14"/>
                 </a:solidFill>
@@ -6639,7 +6344,7 @@
               </a:defRPr>
             </a:pPr>
             <a:r>
-              <a:rPr sz="2400" b="0" i="1">
+              <a:rPr sz="2100" b="0" i="1">
                 <a:solidFill>
                   <a:srgbClr val="B85B14"/>
                 </a:solidFill>
@@ -6647,38 +6352,43 @@
                 <a:ea typeface="Arial"/>
                 <a:cs typeface="Arial"/>
               </a:rPr>
-              <a:t>[Main idea to explain]</a:t>
-            </a:r>
-          </a:p>
-          <a:p xmlns:a="http://schemas.openxmlformats.org/drawingml/2006/main">
-            <a:pPr algn="l">
-              <a:defRPr sz="2400" b="0" i="1">
-                <a:solidFill>
-                  <a:srgbClr val="B85B14"/>
-                </a:solidFill>
-                <a:latin typeface="Arial"/>
-                <a:ea typeface="Arial"/>
-                <a:cs typeface="Arial"/>
-              </a:defRPr>
-            </a:pPr>
-            <a:r>
-              <a:rPr sz="2400" b="0" i="1">
-                <a:solidFill>
-                  <a:srgbClr val="B85B14"/>
-                </a:solidFill>
-                <a:latin typeface="Arial"/>
-                <a:ea typeface="Arial"/>
-                <a:cs typeface="Arial"/>
-              </a:rPr>
-              <a:t>[Relationship within the lesson content]</a:t>
-            </a:r>
-          </a:p>
-        </p:txBody>
-      </p:sp>
+              <a:t>Each step in the diagram adds 3.</a:t>
+            </a:r>
+          </a:p>
+        </p:txBody>
+      </p:sp>
+      <p:pic>
+        <p:nvPicPr>
+          <p:cNvPr id="14" name=""/>
+          <p:cNvPicPr>
+            <a:picLocks xmlns:a="http://schemas.openxmlformats.org/drawingml/2006/main" noChangeAspect="1"/>
+          </p:cNvPicPr>
+          <p:nvPr/>
+        </p:nvPicPr>
+        <p:blipFill>
+          <a:blip xmlns:r="http://schemas.openxmlformats.org/officeDocument/2006/relationships" xmlns:a="http://schemas.openxmlformats.org/drawingml/2006/main" r:embed="R7c47a283927b4b10">
+            <a:extLst>
+              <a:ext uri="{96DAC541-7B7A-43D3-8B79-37D633B846F1}">
+                <asvg:svgBlip xmlns:asvg="http://schemas.microsoft.com/office/drawing/2016/SVG/main" r:embed="R5f2ef5c109fe4f64"/>
+              </a:ext>
+            </a:extLst>
+          </a:blip>
+          <a:stretch xmlns:a="http://schemas.openxmlformats.org/drawingml/2006/main"/>
+        </p:blipFill>
+        <p:spPr>
+          <a:xfrm xmlns:a="http://schemas.openxmlformats.org/drawingml/2006/main">
+            <a:off x="6629400" y="2038350"/>
+            <a:ext cx="4953000" cy="3905250"/>
+          </a:xfrm>
+          <a:prstGeom xmlns:a="http://schemas.openxmlformats.org/drawingml/2006/main" prst="rect">
+            <a:avLst/>
+          </a:prstGeom>
+        </p:spPr>
+      </p:pic>
     </p:spTree>
     <p:extLst>
       <p:ext uri="{BB962C8B-B14F-4D97-AF65-F5344CB8AC3E}">
-        <p14:creationId xmlns:p14="http://schemas.microsoft.com/office/powerpoint/2010/main" val="599979141"/>
+        <p14:creationId xmlns:p14="http://schemas.microsoft.com/office/powerpoint/2010/main" val="890622977"/>
       </p:ext>
     </p:extLst>
   </p:cSld>
@@ -6709,7 +6419,7 @@
           <p:cNvPr id="8" name="visual-0">
             <a:extLst xmlns:a="http://schemas.openxmlformats.org/drawingml/2006/main">
               <a:ext uri="{FF2B5EF4-FFF2-40B4-BE49-F238E27FC236}">
-                <a16:creationId xmlns:a16="http://schemas.microsoft.com/office/drawing/2014/main" id="{A6F04AA9-6F6A-4697-9E96-AEB7D3594C6C}"/>
+                <a16:creationId xmlns:a16="http://schemas.microsoft.com/office/drawing/2014/main" id="{AAEBFBAE-09EF-43AB-AA1A-4DB6C0177737}"/>
               </a:ext>
             </a:extLst>
           </p:cNvPr>
@@ -6756,7 +6466,7 @@
                 <a:ea typeface="Arial"/>
                 <a:cs typeface="Arial"/>
               </a:rPr>
-              <a:t>BiliClass   /   Môn học của thầy cô   /   10–12</a:t>
+              <a:t>BiliClass   /   Toán · ví dụ minh họa   /   11</a:t>
             </a:r>
           </a:p>
         </p:txBody>
@@ -6766,7 +6476,7 @@
           <p:cNvPr id="2" name="visual-1">
             <a:extLst xmlns:a="http://schemas.openxmlformats.org/drawingml/2006/main">
               <a:ext uri="{FF2B5EF4-FFF2-40B4-BE49-F238E27FC236}">
-                <a16:creationId xmlns:a16="http://schemas.microsoft.com/office/drawing/2014/main" id="{2F9F6A34-9308-4346-8B43-D96142CDD58B}"/>
+                <a16:creationId xmlns:a16="http://schemas.microsoft.com/office/drawing/2014/main" id="{7460AE5E-8884-4445-9819-229C606E8FBF}"/>
               </a:ext>
             </a:extLst>
           </p:cNvPr>
@@ -6813,7 +6523,7 @@
                 <a:ea typeface="Arial"/>
                 <a:cs typeface="Arial"/>
               </a:rPr>
-              <a:t>Mẫu bài giảng song ngữ</a:t>
+              <a:t>Cấp số cộng</a:t>
             </a:r>
           </a:p>
         </p:txBody>
@@ -6823,7 +6533,7 @@
           <p:cNvPr id="3" name="visual-2">
             <a:extLst xmlns:a="http://schemas.openxmlformats.org/drawingml/2006/main">
               <a:ext uri="{FF2B5EF4-FFF2-40B4-BE49-F238E27FC236}">
-                <a16:creationId xmlns:a16="http://schemas.microsoft.com/office/drawing/2014/main" id="{A7FE83C5-2B19-454A-A1D5-DBA4D9AD5893}"/>
+                <a16:creationId xmlns:a16="http://schemas.microsoft.com/office/drawing/2014/main" id="{B52A747F-C603-4A0A-BC74-D2D05106F10B}"/>
               </a:ext>
             </a:extLst>
           </p:cNvPr>
@@ -6880,7 +6590,7 @@
           <p:cNvPr id="4" name="visual-3">
             <a:extLst xmlns:a="http://schemas.openxmlformats.org/drawingml/2006/main">
               <a:ext uri="{FF2B5EF4-FFF2-40B4-BE49-F238E27FC236}">
-                <a16:creationId xmlns:a16="http://schemas.microsoft.com/office/drawing/2014/main" id="{43E9D0C3-0DC0-41A3-B02C-91D67F83D9ED}"/>
+                <a16:creationId xmlns:a16="http://schemas.microsoft.com/office/drawing/2014/main" id="{6CCA3CFC-F612-4276-9A68-980B9F4683FF}"/>
               </a:ext>
             </a:extLst>
           </p:cNvPr>
@@ -6927,7 +6637,7 @@
                 <a:ea typeface="Arial"/>
                 <a:cs typeface="Arial"/>
               </a:rPr>
-              <a:t>Mẫu cấu trúc · Thay bằng nội dung bài học</a:t>
+              <a:t>Ví dụ để xem thiết kế · Bài của thầy cô dùng nội dung và hình từ nguồn</a:t>
             </a:r>
           </a:p>
         </p:txBody>
@@ -6937,87 +6647,7 @@
           <p:cNvPr id="5" name="visual-4">
             <a:extLst xmlns:a="http://schemas.openxmlformats.org/drawingml/2006/main">
               <a:ext uri="{FF2B5EF4-FFF2-40B4-BE49-F238E27FC236}">
-                <a16:creationId xmlns:a16="http://schemas.microsoft.com/office/drawing/2014/main" id="{118D6F3F-16C2-424E-8693-730DF8173D23}"/>
-              </a:ext>
-            </a:extLst>
-          </p:cNvPr>
-          <p:cNvSpPr>
-            <a:spLocks xmlns:a="http://schemas.openxmlformats.org/drawingml/2006/main" noGrp="1"/>
-          </p:cNvSpPr>
-          <p:nvPr/>
-        </p:nvSpPr>
-        <p:spPr>
-          <a:xfrm xmlns:a="http://schemas.openxmlformats.org/drawingml/2006/main">
-            <a:off x="6934200" y="3048000"/>
-            <a:ext cx="4343400" cy="1714500"/>
-          </a:xfrm>
-          <a:prstGeom xmlns:a="http://schemas.openxmlformats.org/drawingml/2006/main" prst="rect">
-            <a:avLst/>
-          </a:prstGeom>
-          <a:noFill xmlns:a="http://schemas.openxmlformats.org/drawingml/2006/main"/>
-          <a:ln xmlns:a="http://schemas.openxmlformats.org/drawingml/2006/main" w="0">
-            <a:noFill/>
-          </a:ln>
-        </p:spPr>
-        <p:txBody>
-          <a:bodyPr xmlns:a="http://schemas.openxmlformats.org/drawingml/2006/main">
-            <a:noAutofit/>
-          </a:bodyPr>
-          <a:lstStyle xmlns:a="http://schemas.openxmlformats.org/drawingml/2006/main"/>
-          <a:p xmlns:a="http://schemas.openxmlformats.org/drawingml/2006/main">
-            <a:pPr algn="ctr">
-              <a:defRPr sz="2100" b="0" i="0">
-                <a:solidFill>
-                  <a:srgbClr val="8B725A"/>
-                </a:solidFill>
-                <a:latin typeface="Arial"/>
-                <a:ea typeface="Arial"/>
-                <a:cs typeface="Arial"/>
-              </a:defRPr>
-            </a:pPr>
-            <a:r>
-              <a:rPr sz="2100" b="0" i="0">
-                <a:solidFill>
-                  <a:srgbClr val="8B725A"/>
-                </a:solidFill>
-                <a:latin typeface="Arial"/>
-                <a:ea typeface="Arial"/>
-                <a:cs typeface="Arial"/>
-              </a:rPr>
-              <a:t>[Hình từ tài liệu bài học]</a:t>
-            </a:r>
-          </a:p>
-          <a:p xmlns:a="http://schemas.openxmlformats.org/drawingml/2006/main">
-            <a:pPr algn="ctr">
-              <a:defRPr sz="2100" b="0" i="0">
-                <a:solidFill>
-                  <a:srgbClr val="8B725A"/>
-                </a:solidFill>
-                <a:latin typeface="Arial"/>
-                <a:ea typeface="Arial"/>
-                <a:cs typeface="Arial"/>
-              </a:defRPr>
-            </a:pPr>
-            <a:r>
-              <a:rPr sz="2100" b="0" i="0">
-                <a:solidFill>
-                  <a:srgbClr val="8B725A"/>
-                </a:solidFill>
-                <a:latin typeface="Arial"/>
-                <a:ea typeface="Arial"/>
-                <a:cs typeface="Arial"/>
-              </a:rPr>
-              <a:t>[Image from the lesson source]</a:t>
-            </a:r>
-          </a:p>
-        </p:txBody>
-      </p:sp>
-      <p:sp>
-        <p:nvSpPr>
-          <p:cNvPr id="6" name="visual-5">
-            <a:extLst xmlns:a="http://schemas.openxmlformats.org/drawingml/2006/main">
-              <a:ext uri="{FF2B5EF4-FFF2-40B4-BE49-F238E27FC236}">
-                <a16:creationId xmlns:a16="http://schemas.microsoft.com/office/drawing/2014/main" id="{53BC3F2C-72DA-4B63-9A0F-F7D989157EB9}"/>
+                <a16:creationId xmlns:a16="http://schemas.microsoft.com/office/drawing/2014/main" id="{3C27906F-2EA1-40AF-894D-B08E654A26AF}"/>
               </a:ext>
             </a:extLst>
           </p:cNvPr>
@@ -7046,7 +6676,7 @@
           <a:lstStyle xmlns:a="http://schemas.openxmlformats.org/drawingml/2006/main"/>
           <a:p xmlns:a="http://schemas.openxmlformats.org/drawingml/2006/main">
             <a:pPr algn="l">
-              <a:defRPr sz="2250" b="0" i="0">
+              <a:defRPr sz="2100" b="0" i="0">
                 <a:solidFill>
                   <a:srgbClr val="422D1A"/>
                 </a:solidFill>
@@ -7056,7 +6686,7 @@
               </a:defRPr>
             </a:pPr>
             <a:r>
-              <a:rPr sz="2250" b="0" i="0">
+              <a:rPr sz="2100" b="0" i="0">
                 <a:solidFill>
                   <a:srgbClr val="422D1A"/>
                 </a:solidFill>
@@ -7064,40 +6694,17 @@
                 <a:ea typeface="Arial"/>
                 <a:cs typeface="Arial"/>
               </a:rPr>
-              <a:t>[Điều cần quan sát trong hình]</a:t>
-            </a:r>
-          </a:p>
-          <a:p xmlns:a="http://schemas.openxmlformats.org/drawingml/2006/main">
-            <a:pPr algn="l">
-              <a:defRPr sz="2250" b="0" i="0">
-                <a:solidFill>
-                  <a:srgbClr val="422D1A"/>
-                </a:solidFill>
-                <a:latin typeface="Arial"/>
-                <a:ea typeface="Arial"/>
-                <a:cs typeface="Arial"/>
-              </a:defRPr>
-            </a:pPr>
-            <a:r>
-              <a:rPr sz="2250" b="0" i="0">
-                <a:solidFill>
-                  <a:srgbClr val="422D1A"/>
-                </a:solidFill>
-                <a:latin typeface="Arial"/>
-                <a:ea typeface="Arial"/>
-                <a:cs typeface="Arial"/>
-              </a:rPr>
-              <a:t>[Chú thích từ tài liệu nguồn]</a:t>
-            </a:r>
-          </a:p>
-        </p:txBody>
-      </p:sp>
-      <p:sp>
-        <p:nvSpPr>
-          <p:cNvPr id="7" name="visual-6">
-            <a:extLst xmlns:a="http://schemas.openxmlformats.org/drawingml/2006/main">
-              <a:ext uri="{FF2B5EF4-FFF2-40B4-BE49-F238E27FC236}">
-                <a16:creationId xmlns:a16="http://schemas.microsoft.com/office/drawing/2014/main" id="{E6FA5161-21AE-4FC7-B16D-031370C291FE}"/>
+              <a:t>Theo dõi bước nhảy +3.</a:t>
+            </a:r>
+          </a:p>
+        </p:txBody>
+      </p:sp>
+      <p:sp>
+        <p:nvSpPr>
+          <p:cNvPr id="6" name="visual-5">
+            <a:extLst xmlns:a="http://schemas.openxmlformats.org/drawingml/2006/main">
+              <a:ext uri="{FF2B5EF4-FFF2-40B4-BE49-F238E27FC236}">
+                <a16:creationId xmlns:a16="http://schemas.microsoft.com/office/drawing/2014/main" id="{98B0D637-D84E-4C9D-89A1-78333A20DCF7}"/>
               </a:ext>
             </a:extLst>
           </p:cNvPr>
@@ -7126,7 +6733,7 @@
           <a:lstStyle xmlns:a="http://schemas.openxmlformats.org/drawingml/2006/main"/>
           <a:p xmlns:a="http://schemas.openxmlformats.org/drawingml/2006/main">
             <a:pPr algn="l">
-              <a:defRPr sz="2250" b="0" i="1">
+              <a:defRPr sz="2100" b="0" i="1">
                 <a:solidFill>
                   <a:srgbClr val="B85B14"/>
                 </a:solidFill>
@@ -7136,7 +6743,7 @@
               </a:defRPr>
             </a:pPr>
             <a:r>
-              <a:rPr sz="2250" b="0" i="1">
+              <a:rPr sz="2100" b="0" i="1">
                 <a:solidFill>
                   <a:srgbClr val="B85B14"/>
                 </a:solidFill>
@@ -7144,38 +6751,43 @@
                 <a:ea typeface="Arial"/>
                 <a:cs typeface="Arial"/>
               </a:rPr>
-              <a:t>[What to observe in the image]</a:t>
-            </a:r>
-          </a:p>
-          <a:p xmlns:a="http://schemas.openxmlformats.org/drawingml/2006/main">
-            <a:pPr algn="l">
-              <a:defRPr sz="2250" b="0" i="1">
-                <a:solidFill>
-                  <a:srgbClr val="B85B14"/>
-                </a:solidFill>
-                <a:latin typeface="Arial"/>
-                <a:ea typeface="Arial"/>
-                <a:cs typeface="Arial"/>
-              </a:defRPr>
-            </a:pPr>
-            <a:r>
-              <a:rPr sz="2250" b="0" i="1">
-                <a:solidFill>
-                  <a:srgbClr val="B85B14"/>
-                </a:solidFill>
-                <a:latin typeface="Arial"/>
-                <a:ea typeface="Arial"/>
-                <a:cs typeface="Arial"/>
-              </a:rPr>
-              <a:t>[Caption from the source document]</a:t>
-            </a:r>
-          </a:p>
-        </p:txBody>
-      </p:sp>
+              <a:t>Follow the +3 jumps.</a:t>
+            </a:r>
+          </a:p>
+        </p:txBody>
+      </p:sp>
+      <p:pic>
+        <p:nvPicPr>
+          <p:cNvPr id="14" name=""/>
+          <p:cNvPicPr>
+            <a:picLocks xmlns:a="http://schemas.openxmlformats.org/drawingml/2006/main" noChangeAspect="1"/>
+          </p:cNvPicPr>
+          <p:nvPr/>
+        </p:nvPicPr>
+        <p:blipFill>
+          <a:blip xmlns:r="http://schemas.openxmlformats.org/officeDocument/2006/relationships" xmlns:a="http://schemas.openxmlformats.org/drawingml/2006/main" r:embed="Rcefddb5bf18a4489">
+            <a:extLst>
+              <a:ext uri="{96DAC541-7B7A-43D3-8B79-37D633B846F1}">
+                <asvg:svgBlip xmlns:asvg="http://schemas.microsoft.com/office/drawing/2016/SVG/main" r:embed="R86c5404c91384cb9"/>
+              </a:ext>
+            </a:extLst>
+          </a:blip>
+          <a:stretch xmlns:a="http://schemas.openxmlformats.org/drawingml/2006/main"/>
+        </p:blipFill>
+        <p:spPr>
+          <a:xfrm xmlns:a="http://schemas.openxmlformats.org/drawingml/2006/main">
+            <a:off x="6629400" y="2038350"/>
+            <a:ext cx="4953000" cy="3905250"/>
+          </a:xfrm>
+          <a:prstGeom xmlns:a="http://schemas.openxmlformats.org/drawingml/2006/main" prst="rect">
+            <a:avLst/>
+          </a:prstGeom>
+        </p:spPr>
+      </p:pic>
     </p:spTree>
     <p:extLst>
       <p:ext uri="{BB962C8B-B14F-4D97-AF65-F5344CB8AC3E}">
-        <p14:creationId xmlns:p14="http://schemas.microsoft.com/office/powerpoint/2010/main" val="1201671355"/>
+        <p14:creationId xmlns:p14="http://schemas.microsoft.com/office/powerpoint/2010/main" val="1934317196"/>
       </p:ext>
     </p:extLst>
   </p:cSld>
@@ -7203,10 +6815,10 @@
       </p:grpSpPr>
       <p:sp>
         <p:nvSpPr>
-          <p:cNvPr id="7" name="compare-0">
-            <a:extLst xmlns:a="http://schemas.openxmlformats.org/drawingml/2006/main">
-              <a:ext uri="{FF2B5EF4-FFF2-40B4-BE49-F238E27FC236}">
-                <a16:creationId xmlns:a16="http://schemas.microsoft.com/office/drawing/2014/main" id="{A7701E46-DE04-4E7A-A36E-4E298B79EB5F}"/>
+          <p:cNvPr id="8" name="compare-0">
+            <a:extLst xmlns:a="http://schemas.openxmlformats.org/drawingml/2006/main">
+              <a:ext uri="{FF2B5EF4-FFF2-40B4-BE49-F238E27FC236}">
+                <a16:creationId xmlns:a16="http://schemas.microsoft.com/office/drawing/2014/main" id="{A0EE8395-CE40-4CBC-A1C1-8571A20DEF0D}"/>
               </a:ext>
             </a:extLst>
           </p:cNvPr>
@@ -7253,7 +6865,7 @@
                 <a:ea typeface="Arial"/>
                 <a:cs typeface="Arial"/>
               </a:rPr>
-              <a:t>BiliClass   /   Môn học của thầy cô   /   10–12</a:t>
+              <a:t>BiliClass   /   Toán · ví dụ minh họa   /   11</a:t>
             </a:r>
           </a:p>
         </p:txBody>
@@ -7263,7 +6875,7 @@
           <p:cNvPr id="2" name="compare-1">
             <a:extLst xmlns:a="http://schemas.openxmlformats.org/drawingml/2006/main">
               <a:ext uri="{FF2B5EF4-FFF2-40B4-BE49-F238E27FC236}">
-                <a16:creationId xmlns:a16="http://schemas.microsoft.com/office/drawing/2014/main" id="{1FB0A4D3-3834-4AF8-BE2E-DA99F060DA6B}"/>
+                <a16:creationId xmlns:a16="http://schemas.microsoft.com/office/drawing/2014/main" id="{777BF479-A5DB-4297-A725-2EF654344342}"/>
               </a:ext>
             </a:extLst>
           </p:cNvPr>
@@ -7310,7 +6922,7 @@
                 <a:ea typeface="Arial"/>
                 <a:cs typeface="Arial"/>
               </a:rPr>
-              <a:t>Mẫu bài giảng song ngữ</a:t>
+              <a:t>Cấp số cộng</a:t>
             </a:r>
           </a:p>
         </p:txBody>
@@ -7320,7 +6932,7 @@
           <p:cNvPr id="3" name="compare-2">
             <a:extLst xmlns:a="http://schemas.openxmlformats.org/drawingml/2006/main">
               <a:ext uri="{FF2B5EF4-FFF2-40B4-BE49-F238E27FC236}">
-                <a16:creationId xmlns:a16="http://schemas.microsoft.com/office/drawing/2014/main" id="{009D5A96-0731-4AD2-AAFE-7D669A12D8F3}"/>
+                <a16:creationId xmlns:a16="http://schemas.microsoft.com/office/drawing/2014/main" id="{A4B3D549-B680-42E3-8961-8FF3C9F71837}"/>
               </a:ext>
             </a:extLst>
           </p:cNvPr>
@@ -7377,7 +6989,7 @@
           <p:cNvPr id="4" name="compare-3">
             <a:extLst xmlns:a="http://schemas.openxmlformats.org/drawingml/2006/main">
               <a:ext uri="{FF2B5EF4-FFF2-40B4-BE49-F238E27FC236}">
-                <a16:creationId xmlns:a16="http://schemas.microsoft.com/office/drawing/2014/main" id="{190344E9-AC14-4EC9-B565-B7ADB5DD0CEF}"/>
+                <a16:creationId xmlns:a16="http://schemas.microsoft.com/office/drawing/2014/main" id="{D20ACDF6-B5A7-4340-8A79-1B0CDC141989}"/>
               </a:ext>
             </a:extLst>
           </p:cNvPr>
@@ -7424,7 +7036,7 @@
                 <a:ea typeface="Arial"/>
                 <a:cs typeface="Arial"/>
               </a:rPr>
-              <a:t>Mẫu cấu trúc · Thay bằng nội dung bài học</a:t>
+              <a:t>Ví dụ để xem thiết kế · Bài của thầy cô dùng nội dung và hình từ nguồn</a:t>
             </a:r>
           </a:p>
         </p:txBody>
@@ -7434,7 +7046,7 @@
           <p:cNvPr id="5" name="compare-4">
             <a:extLst xmlns:a="http://schemas.openxmlformats.org/drawingml/2006/main">
               <a:ext uri="{FF2B5EF4-FFF2-40B4-BE49-F238E27FC236}">
-                <a16:creationId xmlns:a16="http://schemas.microsoft.com/office/drawing/2014/main" id="{26AC1CA9-5CBD-4FE6-BB84-4CE516B1641C}"/>
+                <a16:creationId xmlns:a16="http://schemas.microsoft.com/office/drawing/2014/main" id="{5FFF7613-12C4-4615-A4DA-FCCC7F006B3C}"/>
               </a:ext>
             </a:extLst>
           </p:cNvPr>
@@ -7446,24 +7058,24 @@
         <p:spPr>
           <a:xfrm xmlns:a="http://schemas.openxmlformats.org/drawingml/2006/main">
             <a:off x="609600" y="2038350"/>
-            <a:ext cx="10972800" cy="1790700"/>
-          </a:xfrm>
-          <a:prstGeom xmlns:a="http://schemas.openxmlformats.org/drawingml/2006/main" prst="rect">
-            <a:avLst/>
-          </a:prstGeom>
-          <a:noFill xmlns:a="http://schemas.openxmlformats.org/drawingml/2006/main"/>
-          <a:ln xmlns:a="http://schemas.openxmlformats.org/drawingml/2006/main" w="0">
-            <a:noFill/>
-          </a:ln>
-        </p:spPr>
-        <p:txBody>
-          <a:bodyPr xmlns:a="http://schemas.openxmlformats.org/drawingml/2006/main">
-            <a:noAutofit/>
-          </a:bodyPr>
-          <a:lstStyle xmlns:a="http://schemas.openxmlformats.org/drawingml/2006/main"/>
-          <a:p xmlns:a="http://schemas.openxmlformats.org/drawingml/2006/main">
-            <a:pPr algn="l">
-              <a:defRPr sz="2400" b="0" i="0">
+            <a:ext cx="5219700" cy="1790700"/>
+          </a:xfrm>
+          <a:prstGeom xmlns:a="http://schemas.openxmlformats.org/drawingml/2006/main" prst="rect">
+            <a:avLst/>
+          </a:prstGeom>
+          <a:noFill xmlns:a="http://schemas.openxmlformats.org/drawingml/2006/main"/>
+          <a:ln xmlns:a="http://schemas.openxmlformats.org/drawingml/2006/main" w="0">
+            <a:noFill/>
+          </a:ln>
+        </p:spPr>
+        <p:txBody>
+          <a:bodyPr xmlns:a="http://schemas.openxmlformats.org/drawingml/2006/main">
+            <a:noAutofit/>
+          </a:bodyPr>
+          <a:lstStyle xmlns:a="http://schemas.openxmlformats.org/drawingml/2006/main"/>
+          <a:p xmlns:a="http://schemas.openxmlformats.org/drawingml/2006/main">
+            <a:pPr algn="l">
+              <a:defRPr sz="2100" b="0" i="0">
                 <a:solidFill>
                   <a:srgbClr val="422D1A"/>
                 </a:solidFill>
@@ -7473,7 +7085,7 @@
               </a:defRPr>
             </a:pPr>
             <a:r>
-              <a:rPr sz="2400" b="0" i="0">
+              <a:rPr sz="2100" b="0" i="0">
                 <a:solidFill>
                   <a:srgbClr val="422D1A"/>
                 </a:solidFill>
@@ -7481,53 +7093,7 @@
                 <a:ea typeface="Arial"/>
                 <a:cs typeface="Arial"/>
               </a:rPr>
-              <a:t>[Tiêu chí so sánh]</a:t>
-            </a:r>
-          </a:p>
-          <a:p xmlns:a="http://schemas.openxmlformats.org/drawingml/2006/main">
-            <a:pPr algn="l">
-              <a:defRPr sz="2400" b="0" i="0">
-                <a:solidFill>
-                  <a:srgbClr val="422D1A"/>
-                </a:solidFill>
-                <a:latin typeface="Arial"/>
-                <a:ea typeface="Arial"/>
-                <a:cs typeface="Arial"/>
-              </a:defRPr>
-            </a:pPr>
-            <a:r>
-              <a:rPr sz="2400" b="0" i="0">
-                <a:solidFill>
-                  <a:srgbClr val="422D1A"/>
-                </a:solidFill>
-                <a:latin typeface="Arial"/>
-                <a:ea typeface="Arial"/>
-                <a:cs typeface="Arial"/>
-              </a:rPr>
-              <a:t>[Điểm giống nhau]</a:t>
-            </a:r>
-          </a:p>
-          <a:p xmlns:a="http://schemas.openxmlformats.org/drawingml/2006/main">
-            <a:pPr algn="l">
-              <a:defRPr sz="2400" b="0" i="0">
-                <a:solidFill>
-                  <a:srgbClr val="422D1A"/>
-                </a:solidFill>
-                <a:latin typeface="Arial"/>
-                <a:ea typeface="Arial"/>
-                <a:cs typeface="Arial"/>
-              </a:defRPr>
-            </a:pPr>
-            <a:r>
-              <a:rPr sz="2400" b="0" i="0">
-                <a:solidFill>
-                  <a:srgbClr val="422D1A"/>
-                </a:solidFill>
-                <a:latin typeface="Arial"/>
-                <a:ea typeface="Arial"/>
-                <a:cs typeface="Arial"/>
-              </a:rPr>
-              <a:t>[Điểm khác nhau]</a:t>
+              <a:t>2, 5, 8 và 2, 4, 8: khác quy luật.</a:t>
             </a:r>
           </a:p>
         </p:txBody>
@@ -7537,7 +7103,7 @@
           <p:cNvPr id="6" name="compare-5">
             <a:extLst xmlns:a="http://schemas.openxmlformats.org/drawingml/2006/main">
               <a:ext uri="{FF2B5EF4-FFF2-40B4-BE49-F238E27FC236}">
-                <a16:creationId xmlns:a16="http://schemas.microsoft.com/office/drawing/2014/main" id="{C171E3C2-7FD5-4CA0-802A-195CAE645612}"/>
+                <a16:creationId xmlns:a16="http://schemas.microsoft.com/office/drawing/2014/main" id="{9253C3FB-5B12-4EBD-A84C-F72906131F30}"/>
               </a:ext>
             </a:extLst>
           </p:cNvPr>
@@ -7549,24 +7115,24 @@
         <p:spPr>
           <a:xfrm xmlns:a="http://schemas.openxmlformats.org/drawingml/2006/main">
             <a:off x="609600" y="4152900"/>
-            <a:ext cx="10972800" cy="1790700"/>
-          </a:xfrm>
-          <a:prstGeom xmlns:a="http://schemas.openxmlformats.org/drawingml/2006/main" prst="rect">
-            <a:avLst/>
-          </a:prstGeom>
-          <a:noFill xmlns:a="http://schemas.openxmlformats.org/drawingml/2006/main"/>
-          <a:ln xmlns:a="http://schemas.openxmlformats.org/drawingml/2006/main" w="0">
-            <a:noFill/>
-          </a:ln>
-        </p:spPr>
-        <p:txBody>
-          <a:bodyPr xmlns:a="http://schemas.openxmlformats.org/drawingml/2006/main">
-            <a:noAutofit/>
-          </a:bodyPr>
-          <a:lstStyle xmlns:a="http://schemas.openxmlformats.org/drawingml/2006/main"/>
-          <a:p xmlns:a="http://schemas.openxmlformats.org/drawingml/2006/main">
-            <a:pPr algn="l">
-              <a:defRPr sz="2400" b="0" i="1">
+            <a:ext cx="5219700" cy="1790700"/>
+          </a:xfrm>
+          <a:prstGeom xmlns:a="http://schemas.openxmlformats.org/drawingml/2006/main" prst="rect">
+            <a:avLst/>
+          </a:prstGeom>
+          <a:noFill xmlns:a="http://schemas.openxmlformats.org/drawingml/2006/main"/>
+          <a:ln xmlns:a="http://schemas.openxmlformats.org/drawingml/2006/main" w="0">
+            <a:noFill/>
+          </a:ln>
+        </p:spPr>
+        <p:txBody>
+          <a:bodyPr xmlns:a="http://schemas.openxmlformats.org/drawingml/2006/main">
+            <a:noAutofit/>
+          </a:bodyPr>
+          <a:lstStyle xmlns:a="http://schemas.openxmlformats.org/drawingml/2006/main"/>
+          <a:p xmlns:a="http://schemas.openxmlformats.org/drawingml/2006/main">
+            <a:pPr algn="l">
+              <a:defRPr sz="2100" b="0" i="1">
                 <a:solidFill>
                   <a:srgbClr val="B85B14"/>
                 </a:solidFill>
@@ -7576,7 +7142,7 @@
               </a:defRPr>
             </a:pPr>
             <a:r>
-              <a:rPr sz="2400" b="0" i="1">
+              <a:rPr sz="2100" b="0" i="1">
                 <a:solidFill>
                   <a:srgbClr val="B85B14"/>
                 </a:solidFill>
@@ -7584,61 +7150,43 @@
                 <a:ea typeface="Arial"/>
                 <a:cs typeface="Arial"/>
               </a:rPr>
-              <a:t>[Comparison criterion]</a:t>
-            </a:r>
-          </a:p>
-          <a:p xmlns:a="http://schemas.openxmlformats.org/drawingml/2006/main">
-            <a:pPr algn="l">
-              <a:defRPr sz="2400" b="0" i="1">
-                <a:solidFill>
-                  <a:srgbClr val="B85B14"/>
-                </a:solidFill>
-                <a:latin typeface="Arial"/>
-                <a:ea typeface="Arial"/>
-                <a:cs typeface="Arial"/>
-              </a:defRPr>
-            </a:pPr>
-            <a:r>
-              <a:rPr sz="2400" b="0" i="1">
-                <a:solidFill>
-                  <a:srgbClr val="B85B14"/>
-                </a:solidFill>
-                <a:latin typeface="Arial"/>
-                <a:ea typeface="Arial"/>
-                <a:cs typeface="Arial"/>
-              </a:rPr>
-              <a:t>[Similarities]</a:t>
-            </a:r>
-          </a:p>
-          <a:p xmlns:a="http://schemas.openxmlformats.org/drawingml/2006/main">
-            <a:pPr algn="l">
-              <a:defRPr sz="2400" b="0" i="1">
-                <a:solidFill>
-                  <a:srgbClr val="B85B14"/>
-                </a:solidFill>
-                <a:latin typeface="Arial"/>
-                <a:ea typeface="Arial"/>
-                <a:cs typeface="Arial"/>
-              </a:defRPr>
-            </a:pPr>
-            <a:r>
-              <a:rPr sz="2400" b="0" i="1">
-                <a:solidFill>
-                  <a:srgbClr val="B85B14"/>
-                </a:solidFill>
-                <a:latin typeface="Arial"/>
-                <a:ea typeface="Arial"/>
-                <a:cs typeface="Arial"/>
-              </a:rPr>
-              <a:t>[Differences]</a:t>
-            </a:r>
-          </a:p>
-        </p:txBody>
-      </p:sp>
+              <a:t>2, 5, 8 and 2, 4, 8 use different patterns.</a:t>
+            </a:r>
+          </a:p>
+        </p:txBody>
+      </p:sp>
+      <p:pic>
+        <p:nvPicPr>
+          <p:cNvPr id="14" name=""/>
+          <p:cNvPicPr>
+            <a:picLocks xmlns:a="http://schemas.openxmlformats.org/drawingml/2006/main" noChangeAspect="1"/>
+          </p:cNvPicPr>
+          <p:nvPr/>
+        </p:nvPicPr>
+        <p:blipFill>
+          <a:blip xmlns:r="http://schemas.openxmlformats.org/officeDocument/2006/relationships" xmlns:a="http://schemas.openxmlformats.org/drawingml/2006/main" r:embed="R334a5574bea84665">
+            <a:extLst>
+              <a:ext uri="{96DAC541-7B7A-43D3-8B79-37D633B846F1}">
+                <asvg:svgBlip xmlns:asvg="http://schemas.microsoft.com/office/drawing/2016/SVG/main" r:embed="R99d5db9a75b54f28"/>
+              </a:ext>
+            </a:extLst>
+          </a:blip>
+          <a:stretch xmlns:a="http://schemas.openxmlformats.org/drawingml/2006/main"/>
+        </p:blipFill>
+        <p:spPr>
+          <a:xfrm xmlns:a="http://schemas.openxmlformats.org/drawingml/2006/main">
+            <a:off x="6629400" y="2038350"/>
+            <a:ext cx="4953000" cy="3905250"/>
+          </a:xfrm>
+          <a:prstGeom xmlns:a="http://schemas.openxmlformats.org/drawingml/2006/main" prst="rect">
+            <a:avLst/>
+          </a:prstGeom>
+        </p:spPr>
+      </p:pic>
     </p:spTree>
     <p:extLst>
       <p:ext uri="{BB962C8B-B14F-4D97-AF65-F5344CB8AC3E}">
-        <p14:creationId xmlns:p14="http://schemas.microsoft.com/office/powerpoint/2010/main" val="1932406829"/>
+        <p14:creationId xmlns:p14="http://schemas.microsoft.com/office/powerpoint/2010/main" val="1076506380"/>
       </p:ext>
     </p:extLst>
   </p:cSld>
@@ -7666,10 +7214,10 @@
       </p:grpSpPr>
       <p:sp>
         <p:nvSpPr>
-          <p:cNvPr id="7" name="formula-0">
-            <a:extLst xmlns:a="http://schemas.openxmlformats.org/drawingml/2006/main">
-              <a:ext uri="{FF2B5EF4-FFF2-40B4-BE49-F238E27FC236}">
-                <a16:creationId xmlns:a16="http://schemas.microsoft.com/office/drawing/2014/main" id="{E697B7A7-FB5D-4A78-AF2F-0838F3D2B80B}"/>
+          <p:cNvPr id="8" name="formula-0">
+            <a:extLst xmlns:a="http://schemas.openxmlformats.org/drawingml/2006/main">
+              <a:ext uri="{FF2B5EF4-FFF2-40B4-BE49-F238E27FC236}">
+                <a16:creationId xmlns:a16="http://schemas.microsoft.com/office/drawing/2014/main" id="{060689EB-A604-476E-BAE6-F265E8C57C5C}"/>
               </a:ext>
             </a:extLst>
           </p:cNvPr>
@@ -7716,7 +7264,7 @@
                 <a:ea typeface="Arial"/>
                 <a:cs typeface="Arial"/>
               </a:rPr>
-              <a:t>BiliClass   /   Môn học của thầy cô   /   10–12</a:t>
+              <a:t>BiliClass   /   Toán · ví dụ minh họa   /   11</a:t>
             </a:r>
           </a:p>
         </p:txBody>
@@ -7726,7 +7274,7 @@
           <p:cNvPr id="2" name="formula-1">
             <a:extLst xmlns:a="http://schemas.openxmlformats.org/drawingml/2006/main">
               <a:ext uri="{FF2B5EF4-FFF2-40B4-BE49-F238E27FC236}">
-                <a16:creationId xmlns:a16="http://schemas.microsoft.com/office/drawing/2014/main" id="{2F03A345-F094-499D-8CCA-BFF0E162A544}"/>
+                <a16:creationId xmlns:a16="http://schemas.microsoft.com/office/drawing/2014/main" id="{54E6DAFF-E402-4332-BE94-AB71D29D1970}"/>
               </a:ext>
             </a:extLst>
           </p:cNvPr>
@@ -7773,7 +7321,7 @@
                 <a:ea typeface="Arial"/>
                 <a:cs typeface="Arial"/>
               </a:rPr>
-              <a:t>Mẫu bài giảng song ngữ</a:t>
+              <a:t>Cấp số cộng</a:t>
             </a:r>
           </a:p>
         </p:txBody>
@@ -7783,7 +7331,7 @@
           <p:cNvPr id="3" name="formula-2">
             <a:extLst xmlns:a="http://schemas.openxmlformats.org/drawingml/2006/main">
               <a:ext uri="{FF2B5EF4-FFF2-40B4-BE49-F238E27FC236}">
-                <a16:creationId xmlns:a16="http://schemas.microsoft.com/office/drawing/2014/main" id="{42E1A732-45F5-4D91-81D2-A619A9F6311E}"/>
+                <a16:creationId xmlns:a16="http://schemas.microsoft.com/office/drawing/2014/main" id="{DB840A99-4B7B-4343-937C-BFCFEE36EE0A}"/>
               </a:ext>
             </a:extLst>
           </p:cNvPr>
@@ -7840,7 +7388,7 @@
           <p:cNvPr id="4" name="formula-3">
             <a:extLst xmlns:a="http://schemas.openxmlformats.org/drawingml/2006/main">
               <a:ext uri="{FF2B5EF4-FFF2-40B4-BE49-F238E27FC236}">
-                <a16:creationId xmlns:a16="http://schemas.microsoft.com/office/drawing/2014/main" id="{0353C425-109A-4F90-AC5A-7F2462707A93}"/>
+                <a16:creationId xmlns:a16="http://schemas.microsoft.com/office/drawing/2014/main" id="{8809E7BE-1140-4EDD-986E-10CD60D4EA59}"/>
               </a:ext>
             </a:extLst>
           </p:cNvPr>
@@ -7887,7 +7435,7 @@
                 <a:ea typeface="Arial"/>
                 <a:cs typeface="Arial"/>
               </a:rPr>
-              <a:t>Mẫu cấu trúc · Thay bằng nội dung bài học</a:t>
+              <a:t>Ví dụ để xem thiết kế · Bài của thầy cô dùng nội dung và hình từ nguồn</a:t>
             </a:r>
           </a:p>
         </p:txBody>
@@ -7897,7 +7445,7 @@
           <p:cNvPr id="5" name="formula-4">
             <a:extLst xmlns:a="http://schemas.openxmlformats.org/drawingml/2006/main">
               <a:ext uri="{FF2B5EF4-FFF2-40B4-BE49-F238E27FC236}">
-                <a16:creationId xmlns:a16="http://schemas.microsoft.com/office/drawing/2014/main" id="{5026DF50-AF46-4D57-9850-034E0DD60348}"/>
+                <a16:creationId xmlns:a16="http://schemas.microsoft.com/office/drawing/2014/main" id="{EE024F82-1951-4EBD-B51A-FEAF6A99A830}"/>
               </a:ext>
             </a:extLst>
           </p:cNvPr>
@@ -7909,7 +7457,7 @@
         <p:spPr>
           <a:xfrm xmlns:a="http://schemas.openxmlformats.org/drawingml/2006/main">
             <a:off x="609600" y="2038350"/>
-            <a:ext cx="10972800" cy="1790700"/>
+            <a:ext cx="5219700" cy="1790700"/>
           </a:xfrm>
           <a:prstGeom xmlns:a="http://schemas.openxmlformats.org/drawingml/2006/main" prst="rect">
             <a:avLst/>
@@ -7926,7 +7474,7 @@
           <a:lstStyle xmlns:a="http://schemas.openxmlformats.org/drawingml/2006/main"/>
           <a:p xmlns:a="http://schemas.openxmlformats.org/drawingml/2006/main">
             <a:pPr algn="ctr">
-              <a:defRPr sz="3150" b="1" i="0">
+              <a:defRPr sz="2100" b="1" i="0">
                 <a:solidFill>
                   <a:srgbClr val="422D1A"/>
                 </a:solidFill>
@@ -7936,7 +7484,7 @@
               </a:defRPr>
             </a:pPr>
             <a:r>
-              <a:rPr sz="3150" b="1" i="0">
+              <a:rPr sz="2100" b="1" i="0">
                 <a:solidFill>
                   <a:srgbClr val="422D1A"/>
                 </a:solidFill>
@@ -7944,69 +7492,46 @@
                 <a:ea typeface="Arial"/>
                 <a:cs typeface="Arial"/>
               </a:rPr>
-              <a:t>[Công thức hoặc quy tắc]</a:t>
-            </a:r>
-          </a:p>
+              <a:t>uₙ = u₁ + (n − 1)d</a:t>
+            </a:r>
+          </a:p>
+        </p:txBody>
+      </p:sp>
+      <p:sp>
+        <p:nvSpPr>
+          <p:cNvPr id="6" name="formula-5">
+            <a:extLst xmlns:a="http://schemas.openxmlformats.org/drawingml/2006/main">
+              <a:ext uri="{FF2B5EF4-FFF2-40B4-BE49-F238E27FC236}">
+                <a16:creationId xmlns:a16="http://schemas.microsoft.com/office/drawing/2014/main" id="{7135D8D2-E928-405D-9423-439193C533FC}"/>
+              </a:ext>
+            </a:extLst>
+          </p:cNvPr>
+          <p:cNvSpPr>
+            <a:spLocks xmlns:a="http://schemas.openxmlformats.org/drawingml/2006/main" noGrp="1"/>
+          </p:cNvSpPr>
+          <p:nvPr/>
+        </p:nvSpPr>
+        <p:spPr>
+          <a:xfrm xmlns:a="http://schemas.openxmlformats.org/drawingml/2006/main">
+            <a:off x="609600" y="4152900"/>
+            <a:ext cx="5219700" cy="1790700"/>
+          </a:xfrm>
+          <a:prstGeom xmlns:a="http://schemas.openxmlformats.org/drawingml/2006/main" prst="rect">
+            <a:avLst/>
+          </a:prstGeom>
+          <a:noFill xmlns:a="http://schemas.openxmlformats.org/drawingml/2006/main"/>
+          <a:ln xmlns:a="http://schemas.openxmlformats.org/drawingml/2006/main" w="0">
+            <a:noFill/>
+          </a:ln>
+        </p:spPr>
+        <p:txBody>
+          <a:bodyPr xmlns:a="http://schemas.openxmlformats.org/drawingml/2006/main">
+            <a:noAutofit/>
+          </a:bodyPr>
+          <a:lstStyle xmlns:a="http://schemas.openxmlformats.org/drawingml/2006/main"/>
           <a:p xmlns:a="http://schemas.openxmlformats.org/drawingml/2006/main">
             <a:pPr algn="ctr">
-              <a:defRPr sz="3150" b="1" i="0">
-                <a:solidFill>
-                  <a:srgbClr val="422D1A"/>
-                </a:solidFill>
-                <a:latin typeface="Arial"/>
-                <a:ea typeface="Arial"/>
-                <a:cs typeface="Arial"/>
-              </a:defRPr>
-            </a:pPr>
-            <a:r>
-              <a:rPr sz="3150" b="1" i="0">
-                <a:solidFill>
-                  <a:srgbClr val="422D1A"/>
-                </a:solidFill>
-                <a:latin typeface="Arial"/>
-                <a:ea typeface="Arial"/>
-                <a:cs typeface="Arial"/>
-              </a:rPr>
-              <a:t>[Điều kiện áp dụng]</a:t>
-            </a:r>
-          </a:p>
-        </p:txBody>
-      </p:sp>
-      <p:sp>
-        <p:nvSpPr>
-          <p:cNvPr id="6" name="formula-5">
-            <a:extLst xmlns:a="http://schemas.openxmlformats.org/drawingml/2006/main">
-              <a:ext uri="{FF2B5EF4-FFF2-40B4-BE49-F238E27FC236}">
-                <a16:creationId xmlns:a16="http://schemas.microsoft.com/office/drawing/2014/main" id="{6F60117F-16B8-462F-A8BF-D6A8989CDA3B}"/>
-              </a:ext>
-            </a:extLst>
-          </p:cNvPr>
-          <p:cNvSpPr>
-            <a:spLocks xmlns:a="http://schemas.openxmlformats.org/drawingml/2006/main" noGrp="1"/>
-          </p:cNvSpPr>
-          <p:nvPr/>
-        </p:nvSpPr>
-        <p:spPr>
-          <a:xfrm xmlns:a="http://schemas.openxmlformats.org/drawingml/2006/main">
-            <a:off x="609600" y="4152900"/>
-            <a:ext cx="10972800" cy="1790700"/>
-          </a:xfrm>
-          <a:prstGeom xmlns:a="http://schemas.openxmlformats.org/drawingml/2006/main" prst="rect">
-            <a:avLst/>
-          </a:prstGeom>
-          <a:noFill xmlns:a="http://schemas.openxmlformats.org/drawingml/2006/main"/>
-          <a:ln xmlns:a="http://schemas.openxmlformats.org/drawingml/2006/main" w="0">
-            <a:noFill/>
-          </a:ln>
-        </p:spPr>
-        <p:txBody>
-          <a:bodyPr xmlns:a="http://schemas.openxmlformats.org/drawingml/2006/main">
-            <a:noAutofit/>
-          </a:bodyPr>
-          <a:lstStyle xmlns:a="http://schemas.openxmlformats.org/drawingml/2006/main"/>
-          <a:p xmlns:a="http://schemas.openxmlformats.org/drawingml/2006/main">
-            <a:pPr algn="ctr">
-              <a:defRPr sz="3150" b="1" i="1">
+              <a:defRPr sz="2100" b="1" i="1">
                 <a:solidFill>
                   <a:srgbClr val="B85B14"/>
                 </a:solidFill>
@@ -8016,7 +7541,7 @@
               </a:defRPr>
             </a:pPr>
             <a:r>
-              <a:rPr sz="3150" b="1" i="1">
+              <a:rPr sz="2100" b="1" i="1">
                 <a:solidFill>
                   <a:srgbClr val="B85B14"/>
                 </a:solidFill>
@@ -8024,38 +7549,43 @@
                 <a:ea typeface="Arial"/>
                 <a:cs typeface="Arial"/>
               </a:rPr>
-              <a:t>[Formula or rule]</a:t>
-            </a:r>
-          </a:p>
-          <a:p xmlns:a="http://schemas.openxmlformats.org/drawingml/2006/main">
-            <a:pPr algn="ctr">
-              <a:defRPr sz="3150" b="1" i="1">
-                <a:solidFill>
-                  <a:srgbClr val="B85B14"/>
-                </a:solidFill>
-                <a:latin typeface="Arial"/>
-                <a:ea typeface="Arial"/>
-                <a:cs typeface="Arial"/>
-              </a:defRPr>
-            </a:pPr>
-            <a:r>
-              <a:rPr sz="3150" b="1" i="1">
-                <a:solidFill>
-                  <a:srgbClr val="B85B14"/>
-                </a:solidFill>
-                <a:latin typeface="Arial"/>
-                <a:ea typeface="Arial"/>
-                <a:cs typeface="Arial"/>
-              </a:rPr>
-              <a:t>[Conditions of use]</a:t>
-            </a:r>
-          </a:p>
-        </p:txBody>
-      </p:sp>
+              <a:t>uₙ = u₁ + (n − 1)d</a:t>
+            </a:r>
+          </a:p>
+        </p:txBody>
+      </p:sp>
+      <p:pic>
+        <p:nvPicPr>
+          <p:cNvPr id="14" name=""/>
+          <p:cNvPicPr>
+            <a:picLocks xmlns:a="http://schemas.openxmlformats.org/drawingml/2006/main" noChangeAspect="1"/>
+          </p:cNvPicPr>
+          <p:nvPr/>
+        </p:nvPicPr>
+        <p:blipFill>
+          <a:blip xmlns:r="http://schemas.openxmlformats.org/officeDocument/2006/relationships" xmlns:a="http://schemas.openxmlformats.org/drawingml/2006/main" r:embed="R6f659a01626240fa">
+            <a:extLst>
+              <a:ext uri="{96DAC541-7B7A-43D3-8B79-37D633B846F1}">
+                <asvg:svgBlip xmlns:asvg="http://schemas.microsoft.com/office/drawing/2016/SVG/main" r:embed="Rd76a161b75024b81"/>
+              </a:ext>
+            </a:extLst>
+          </a:blip>
+          <a:stretch xmlns:a="http://schemas.openxmlformats.org/drawingml/2006/main"/>
+        </p:blipFill>
+        <p:spPr>
+          <a:xfrm xmlns:a="http://schemas.openxmlformats.org/drawingml/2006/main">
+            <a:off x="6629400" y="2038350"/>
+            <a:ext cx="4953000" cy="3905250"/>
+          </a:xfrm>
+          <a:prstGeom xmlns:a="http://schemas.openxmlformats.org/drawingml/2006/main" prst="rect">
+            <a:avLst/>
+          </a:prstGeom>
+        </p:spPr>
+      </p:pic>
     </p:spTree>
     <p:extLst>
       <p:ext uri="{BB962C8B-B14F-4D97-AF65-F5344CB8AC3E}">
-        <p14:creationId xmlns:p14="http://schemas.microsoft.com/office/powerpoint/2010/main" val="1474628038"/>
+        <p14:creationId xmlns:p14="http://schemas.microsoft.com/office/powerpoint/2010/main" val="1316475897"/>
       </p:ext>
     </p:extLst>
   </p:cSld>

</xml_diff>